<commit_message>
docs: finalize presentation deck with verified hackathon requirements and live POC links
</commit_message>
<xml_diff>
--- a/docs/NexusHackathon_Presentation.pptx
+++ b/docs/NexusHackathon_Presentation.pptx
@@ -1650,6 +1650,10 @@
             <a:prstDash val="solid"/>
           </a:ln>
         </p:spPr>
+        <p:txBody>
+          <a:bodyPr/>
+          <a:p/>
+        </p:txBody>
       </p:sp>
       <p:sp>
         <p:nvSpPr>
@@ -1674,6 +1678,10 @@
             <a:prstDash val="solid"/>
           </a:ln>
         </p:spPr>
+        <p:txBody>
+          <a:bodyPr/>
+          <a:p/>
+        </p:txBody>
       </p:sp>
       <p:sp>
         <p:nvSpPr>
@@ -1700,14 +1708,6 @@
               <a:buNone/>
             </a:pPr>
             <a:r>
-              <a:rPr lang="en-US" altLang="en-US" sz="1400" dirty="0">
-                <a:solidFill>
-                  <a:srgbClr val="00E5FF"/>
-                </a:solidFill>
-                <a:latin typeface="JetBrains Mono" pitchFamily="34" charset="0"/>
-                <a:ea typeface="JetBrains Mono" pitchFamily="34" charset="-122"/>
-                <a:cs typeface="JetBrains Mono" pitchFamily="34" charset="-120"/>
-              </a:rPr>
               <a:t>NEXUS 2026 // HACKATHON PRESENTATION</a:t>
             </a:r>
             <a:endParaRPr lang="en-US" sz="1400" dirty="0"/>
@@ -1762,14 +1762,6 @@
               <a:buNone/>
             </a:pPr>
             <a:r>
-              <a:rPr lang="en-US" altLang="en-US" sz="7000" dirty="0">
-                <a:solidFill>
-                  <a:srgbClr val="FFFFFF"/>
-                </a:solidFill>
-                <a:latin typeface="Space Grotesk" pitchFamily="34" charset="0"/>
-                <a:ea typeface="Space Grotesk" pitchFamily="34" charset="-122"/>
-                <a:cs typeface="Space Grotesk" pitchFamily="34" charset="-120"/>
-              </a:rPr>
               <a:t>AegisNexus</a:t>
             </a:r>
             <a:endParaRPr lang="en-US" sz="7000" dirty="0"/>
@@ -1801,14 +1793,6 @@
               <a:buNone/>
             </a:pPr>
             <a:r>
-              <a:rPr lang="en-US" altLang="en-US" sz="3600" dirty="0">
-                <a:solidFill>
-                  <a:srgbClr val="00E5FF"/>
-                </a:solidFill>
-                <a:latin typeface="Space Grotesk" pitchFamily="34" charset="0"/>
-                <a:ea typeface="Space Grotesk" pitchFamily="34" charset="-122"/>
-                <a:cs typeface="Space Grotesk" pitchFamily="34" charset="-120"/>
-              </a:rPr>
               <a:t>Detect the Signal. Defend the Decision.</a:t>
             </a:r>
             <a:endParaRPr lang="en-US" sz="3600" dirty="0"/>
@@ -1836,6 +1820,10 @@
             <a:prstDash val="solid"/>
           </a:ln>
         </p:spPr>
+        <p:txBody>
+          <a:bodyPr/>
+          <a:p/>
+        </p:txBody>
       </p:sp>
       <p:sp>
         <p:nvSpPr>
@@ -1865,14 +1853,6 @@
               <a:buNone/>
             </a:pPr>
             <a:r>
-              <a:rPr lang="en-US" altLang="en-US" sz="2300" dirty="0">
-                <a:solidFill>
-                  <a:srgbClr val="FFFFFF"/>
-                </a:solidFill>
-                <a:latin typeface="Inter" pitchFamily="34" charset="0"/>
-                <a:ea typeface="Inter" pitchFamily="34" charset="-122"/>
-                <a:cs typeface="Inter" pitchFamily="34" charset="-120"/>
-              </a:rPr>
               <a:t>AI-Powered Real-Time Deepfake and Phishing Detection &amp; Defense System</a:t>
             </a:r>
             <a:endParaRPr lang="en-US" sz="2300" dirty="0"/>
@@ -1904,14 +1884,6 @@
               <a:buNone/>
             </a:pPr>
             <a:r>
-              <a:rPr lang="en-US" altLang="en-US" sz="1200" dirty="0">
-                <a:solidFill>
-                  <a:srgbClr val="8B9BB4"/>
-                </a:solidFill>
-                <a:latin typeface="JetBrains Mono" pitchFamily="34" charset="0"/>
-                <a:ea typeface="JetBrains Mono" pitchFamily="34" charset="-122"/>
-                <a:cs typeface="JetBrains Mono" pitchFamily="34" charset="-120"/>
-              </a:rPr>
               <a:t>PRESENTED BY</a:t>
             </a:r>
             <a:endParaRPr lang="en-US" sz="1200" dirty="0"/>
@@ -1943,15 +1915,7 @@
               <a:buNone/>
             </a:pPr>
             <a:r>
-              <a:rPr lang="en-US" altLang="en-US" sz="2200" dirty="0">
-                <a:solidFill>
-                  <a:srgbClr val="FFFFFF"/>
-                </a:solidFill>
-                <a:latin typeface="Space Grotesk" pitchFamily="34" charset="0"/>
-                <a:ea typeface="Space Grotesk" pitchFamily="34" charset="-122"/>
-                <a:cs typeface="Space Grotesk" pitchFamily="34" charset="-120"/>
-              </a:rPr>
-              <a:t>Mohammad Sahil · Zainab Memon</a:t>
+              <a:t>Mohammad Sahil • Zainab Memon</a:t>
             </a:r>
             <a:endParaRPr lang="en-US" sz="2200" dirty="0"/>
           </a:p>
@@ -1982,14 +1946,6 @@
               <a:buNone/>
             </a:pPr>
             <a:r>
-              <a:rPr lang="en-US" altLang="en-US" sz="1800" dirty="0">
-                <a:solidFill>
-                  <a:srgbClr val="00E5FF"/>
-                </a:solidFill>
-                <a:latin typeface="Inter" pitchFamily="34" charset="0"/>
-                <a:ea typeface="Inter" pitchFamily="34" charset="-122"/>
-                <a:cs typeface="Inter" pitchFamily="34" charset="-120"/>
-              </a:rPr>
               <a:t>Tech Creature Solutions</a:t>
             </a:r>
             <a:endParaRPr lang="en-US" sz="1800" dirty="0"/>
@@ -2021,15 +1977,7 @@
               <a:buNone/>
             </a:pPr>
             <a:r>
-              <a:rPr lang="en-US" altLang="en-US" sz="1500" dirty="0">
-                <a:solidFill>
-                  <a:srgbClr val="8B9BB4"/>
-                </a:solidFill>
-                <a:latin typeface="Inter" pitchFamily="34" charset="0"/>
-                <a:ea typeface="Inter" pitchFamily="34" charset="-122"/>
-                <a:cs typeface="Inter" pitchFamily="34" charset="-120"/>
-              </a:rPr>
-              <a:t>GLS University · Faculty of Engineering and Technology</a:t>
+              <a:t>GLS University • Faculty of Engineering and Technology</a:t>
             </a:r>
             <a:endParaRPr lang="en-US" sz="1500" dirty="0"/>
           </a:p>
@@ -2060,15 +2008,7 @@
               <a:buNone/>
             </a:pPr>
             <a:r>
-              <a:rPr lang="en-US" altLang="en-US" sz="1100" dirty="0">
-                <a:solidFill>
-                  <a:srgbClr val="8B9BB4"/>
-                </a:solidFill>
-                <a:latin typeface="JetBrains Mono" pitchFamily="34" charset="0"/>
-                <a:ea typeface="JetBrains Mono" pitchFamily="34" charset="-122"/>
-                <a:cs typeface="JetBrains Mono" pitchFamily="34" charset="-120"/>
-              </a:rPr>
-              <a:t>SYSTEM BRIEF // NEXUS 2026 // SEC-01</a:t>
+              <a:t>SYSTEM BRIEF // GLS NEXUS 2026 // SEC-01 • LIVE: aegis-nexus-alpha.vercel.app</a:t>
             </a:r>
             <a:endParaRPr lang="en-US" sz="1100" dirty="0"/>
           </a:p>
@@ -2130,6 +2070,10 @@
             <a:prstDash val="solid"/>
           </a:ln>
         </p:spPr>
+        <p:txBody>
+          <a:bodyPr/>
+          <a:p/>
+        </p:txBody>
       </p:sp>
       <p:sp>
         <p:nvSpPr>
@@ -2156,14 +2100,6 @@
               <a:buNone/>
             </a:pPr>
             <a:r>
-              <a:rPr lang="en-US" altLang="en-US" sz="1300" dirty="0">
-                <a:solidFill>
-                  <a:srgbClr val="00E5FF"/>
-                </a:solidFill>
-                <a:latin typeface="JetBrains Mono" pitchFamily="34" charset="0"/>
-                <a:ea typeface="JetBrains Mono" pitchFamily="34" charset="-122"/>
-                <a:cs typeface="JetBrains Mono" pitchFamily="34" charset="-120"/>
-              </a:rPr>
               <a:t>MANDATORY 06 // ASSUMPTIONS + CHALLENGES + QUERIES</a:t>
             </a:r>
             <a:endParaRPr lang="en-US" sz="1300" dirty="0"/>
@@ -2195,14 +2131,6 @@
               <a:buNone/>
             </a:pPr>
             <a:r>
-              <a:rPr lang="en-US" altLang="en-US" sz="1200" dirty="0">
-                <a:solidFill>
-                  <a:srgbClr val="8B9BB4"/>
-                </a:solidFill>
-                <a:latin typeface="JetBrains Mono" pitchFamily="34" charset="0"/>
-                <a:ea typeface="JetBrains Mono" pitchFamily="34" charset="-122"/>
-                <a:cs typeface="JetBrains Mono" pitchFamily="34" charset="-120"/>
-              </a:rPr>
               <a:t>NEXUS 2026</a:t>
             </a:r>
             <a:endParaRPr lang="en-US" sz="1200" dirty="0"/>
@@ -2234,14 +2162,6 @@
               <a:buNone/>
             </a:pPr>
             <a:r>
-              <a:rPr lang="en-US" altLang="en-US" sz="4300" dirty="0">
-                <a:solidFill>
-                  <a:srgbClr val="FFFFFF"/>
-                </a:solidFill>
-                <a:latin typeface="Space Grotesk" pitchFamily="34" charset="0"/>
-                <a:ea typeface="Space Grotesk" pitchFamily="34" charset="-122"/>
-                <a:cs typeface="Space Grotesk" pitchFamily="34" charset="-120"/>
-              </a:rPr>
               <a:t>Ambitious by design. Responsible by default.</a:t>
             </a:r>
             <a:endParaRPr lang="en-US" sz="4300" dirty="0"/>
@@ -2273,14 +2193,6 @@
               <a:buNone/>
             </a:pPr>
             <a:r>
-              <a:rPr lang="en-US" altLang="en-US" sz="1800" dirty="0">
-                <a:solidFill>
-                  <a:srgbClr val="8B9BB4"/>
-                </a:solidFill>
-                <a:latin typeface="Inter" pitchFamily="34" charset="0"/>
-                <a:ea typeface="Inter" pitchFamily="34" charset="-122"/>
-                <a:cs typeface="Inter" pitchFamily="34" charset="-120"/>
-              </a:rPr>
               <a:t>A credible prototype declares its boundaries, risks, safeguards, and open questions clearly.</a:t>
             </a:r>
             <a:endParaRPr lang="en-US" sz="1800" dirty="0"/>
@@ -2311,6 +2223,10 @@
             <a:prstDash val="solid"/>
           </a:ln>
         </p:spPr>
+        <p:txBody>
+          <a:bodyPr/>
+          <a:p/>
+        </p:txBody>
       </p:sp>
       <p:sp>
         <p:nvSpPr>
@@ -2337,14 +2253,6 @@
               <a:buNone/>
             </a:pPr>
             <a:r>
-              <a:rPr lang="en-US" altLang="en-US" sz="1300" dirty="0">
-                <a:solidFill>
-                  <a:srgbClr val="00E5FF"/>
-                </a:solidFill>
-                <a:latin typeface="JetBrains Mono" pitchFamily="34" charset="0"/>
-                <a:ea typeface="JetBrains Mono" pitchFamily="34" charset="-122"/>
-                <a:cs typeface="JetBrains Mono" pitchFamily="34" charset="-120"/>
-              </a:rPr>
               <a:t>PROTOTYPE ASSUMPTIONS</a:t>
             </a:r>
             <a:endParaRPr lang="en-US" sz="1300" dirty="0"/>
@@ -2400,14 +2308,6 @@
               <a:buNone/>
             </a:pPr>
             <a:r>
-              <a:rPr lang="en-US" altLang="en-US" sz="1700" dirty="0">
-                <a:solidFill>
-                  <a:srgbClr val="FFFFFF"/>
-                </a:solidFill>
-                <a:latin typeface="Inter" pitchFamily="34" charset="0"/>
-                <a:ea typeface="Inter" pitchFamily="34" charset="-122"/>
-                <a:cs typeface="Inter" pitchFamily="34" charset="-120"/>
-              </a:rPr>
               <a:t>Simulated or uploaded test events are used instead of live corporate data.</a:t>
             </a:r>
             <a:endParaRPr lang="en-US" sz="1700" dirty="0"/>
@@ -2463,14 +2363,6 @@
               <a:buNone/>
             </a:pPr>
             <a:r>
-              <a:rPr lang="en-US" altLang="en-US" sz="1700" dirty="0">
-                <a:solidFill>
-                  <a:srgbClr val="FFFFFF"/>
-                </a:solidFill>
-                <a:latin typeface="Inter" pitchFamily="34" charset="0"/>
-                <a:ea typeface="Inter" pitchFamily="34" charset="-122"/>
-                <a:cs typeface="Inter" pitchFamily="34" charset="-120"/>
-              </a:rPr>
               <a:t>Pre-trained models and rules are used; no large model is trained from scratch.</a:t>
             </a:r>
             <a:endParaRPr lang="en-US" sz="1700" dirty="0"/>
@@ -2526,14 +2418,6 @@
               <a:buNone/>
             </a:pPr>
             <a:r>
-              <a:rPr lang="en-US" altLang="en-US" sz="1700" dirty="0">
-                <a:solidFill>
-                  <a:srgbClr val="FFFFFF"/>
-                </a:solidFill>
-                <a:latin typeface="Inter" pitchFamily="34" charset="0"/>
-                <a:ea typeface="Inter" pitchFamily="34" charset="-122"/>
-                <a:cs typeface="Inter" pitchFamily="34" charset="-120"/>
-              </a:rPr>
               <a:t>Not every event includes text, audio, video, identity, and network signals.</a:t>
             </a:r>
             <a:endParaRPr lang="en-US" sz="1700" dirty="0"/>
@@ -2564,6 +2448,10 @@
             <a:prstDash val="solid"/>
           </a:ln>
         </p:spPr>
+        <p:txBody>
+          <a:bodyPr/>
+          <a:p/>
+        </p:txBody>
       </p:sp>
       <p:sp>
         <p:nvSpPr>
@@ -2590,14 +2478,6 @@
               <a:buNone/>
             </a:pPr>
             <a:r>
-              <a:rPr lang="en-US" altLang="en-US" sz="1300" dirty="0">
-                <a:solidFill>
-                  <a:srgbClr val="FFB300"/>
-                </a:solidFill>
-                <a:latin typeface="JetBrains Mono" pitchFamily="34" charset="0"/>
-                <a:ea typeface="JetBrains Mono" pitchFamily="34" charset="-122"/>
-                <a:cs typeface="JetBrains Mono" pitchFamily="34" charset="-120"/>
-              </a:rPr>
               <a:t>CHALLENGE → MITIGATION</a:t>
             </a:r>
             <a:endParaRPr lang="en-US" sz="1300" dirty="0"/>
@@ -2629,14 +2509,6 @@
               <a:buNone/>
             </a:pPr>
             <a:r>
-              <a:rPr lang="en-US" altLang="en-US" sz="1900" dirty="0">
-                <a:solidFill>
-                  <a:srgbClr val="FFFFFF"/>
-                </a:solidFill>
-                <a:latin typeface="Space Grotesk" pitchFamily="34" charset="0"/>
-                <a:ea typeface="Space Grotesk" pitchFamily="34" charset="-122"/>
-                <a:cs typeface="Space Grotesk" pitchFamily="34" charset="-120"/>
-              </a:rPr>
               <a:t>False alerts</a:t>
             </a:r>
             <a:endParaRPr lang="en-US" sz="1900" dirty="0"/>
@@ -2668,14 +2540,6 @@
               <a:buNone/>
             </a:pPr>
             <a:r>
-              <a:rPr lang="en-US" altLang="en-US" sz="1600" dirty="0">
-                <a:solidFill>
-                  <a:srgbClr val="8B9BB4"/>
-                </a:solidFill>
-                <a:latin typeface="Inter" pitchFamily="34" charset="0"/>
-                <a:ea typeface="Inter" pitchFamily="34" charset="-122"/>
-                <a:cs typeface="Inter" pitchFamily="34" charset="-120"/>
-              </a:rPr>
               <a:t>Risk bands, confidence, evidence, thresholds, analyst review.</a:t>
             </a:r>
             <a:endParaRPr lang="en-US" sz="1600" dirty="0"/>
@@ -2703,6 +2567,10 @@
             <a:prstDash val="solid"/>
           </a:ln>
         </p:spPr>
+        <p:txBody>
+          <a:bodyPr/>
+          <a:p/>
+        </p:txBody>
       </p:sp>
       <p:sp>
         <p:nvSpPr>
@@ -2729,14 +2597,6 @@
               <a:buNone/>
             </a:pPr>
             <a:r>
-              <a:rPr lang="en-US" altLang="en-US" sz="1900" dirty="0">
-                <a:solidFill>
-                  <a:srgbClr val="FFFFFF"/>
-                </a:solidFill>
-                <a:latin typeface="Space Grotesk" pitchFamily="34" charset="0"/>
-                <a:ea typeface="Space Grotesk" pitchFamily="34" charset="-122"/>
-                <a:cs typeface="Space Grotesk" pitchFamily="34" charset="-120"/>
-              </a:rPr>
               <a:t>Privacy + biometrics</a:t>
             </a:r>
             <a:endParaRPr lang="en-US" sz="1900" dirty="0"/>
@@ -2768,14 +2628,6 @@
               <a:buNone/>
             </a:pPr>
             <a:r>
-              <a:rPr lang="en-US" altLang="en-US" sz="1600" dirty="0">
-                <a:solidFill>
-                  <a:srgbClr val="8B9BB4"/>
-                </a:solidFill>
-                <a:latin typeface="Inter" pitchFamily="34" charset="0"/>
-                <a:ea typeface="Inter" pitchFamily="34" charset="-122"/>
-                <a:cs typeface="Inter" pitchFamily="34" charset="-120"/>
-              </a:rPr>
               <a:t>Consent-based samples, minimal storage, restricted access.</a:t>
             </a:r>
             <a:endParaRPr lang="en-US" sz="1600" dirty="0"/>
@@ -2803,6 +2655,10 @@
             <a:prstDash val="solid"/>
           </a:ln>
         </p:spPr>
+        <p:txBody>
+          <a:bodyPr/>
+          <a:p/>
+        </p:txBody>
       </p:sp>
       <p:sp>
         <p:nvSpPr>
@@ -2829,14 +2685,6 @@
               <a:buNone/>
             </a:pPr>
             <a:r>
-              <a:rPr lang="en-US" altLang="en-US" sz="1900" dirty="0">
-                <a:solidFill>
-                  <a:srgbClr val="FFFFFF"/>
-                </a:solidFill>
-                <a:latin typeface="Space Grotesk" pitchFamily="34" charset="0"/>
-                <a:ea typeface="Space Grotesk" pitchFamily="34" charset="-122"/>
-                <a:cs typeface="Space Grotesk" pitchFamily="34" charset="-120"/>
-              </a:rPr>
               <a:t>Latency + scope</a:t>
             </a:r>
             <a:endParaRPr lang="en-US" sz="1900" dirty="0"/>
@@ -2868,14 +2716,6 @@
               <a:buNone/>
             </a:pPr>
             <a:r>
-              <a:rPr lang="en-US" altLang="en-US" sz="1600" dirty="0">
-                <a:solidFill>
-                  <a:srgbClr val="8B9BB4"/>
-                </a:solidFill>
-                <a:latin typeface="Inter" pitchFamily="34" charset="0"/>
-                <a:ea typeface="Inter" pitchFamily="34" charset="-122"/>
-                <a:cs typeface="Inter" pitchFamily="34" charset="-120"/>
-              </a:rPr>
               <a:t>Lightweight checks first; deeper checks run in parallel; critical actions need analyst approval.</a:t>
             </a:r>
             <a:endParaRPr lang="en-US" sz="1600" dirty="0"/>
@@ -2908,6 +2748,10 @@
             <a:prstDash val="solid"/>
           </a:ln>
         </p:spPr>
+        <p:txBody>
+          <a:bodyPr/>
+          <a:p/>
+        </p:txBody>
       </p:sp>
       <p:sp>
         <p:nvSpPr>
@@ -2934,14 +2778,6 @@
               <a:buNone/>
             </a:pPr>
             <a:r>
-              <a:rPr lang="en-US" altLang="en-US" sz="1200" dirty="0">
-                <a:solidFill>
-                  <a:srgbClr val="FFB300"/>
-                </a:solidFill>
-                <a:latin typeface="JetBrains Mono" pitchFamily="34" charset="0"/>
-                <a:ea typeface="JetBrains Mono" pitchFamily="34" charset="-122"/>
-                <a:cs typeface="JetBrains Mono" pitchFamily="34" charset="-120"/>
-              </a:rPr>
               <a:t>OPEN QUERIES</a:t>
             </a:r>
             <a:endParaRPr lang="en-US" sz="1200" dirty="0"/>
@@ -2973,14 +2809,6 @@
               <a:buNone/>
             </a:pPr>
             <a:r>
-              <a:rPr lang="en-US" altLang="en-US" sz="1500" dirty="0">
-                <a:solidFill>
-                  <a:srgbClr val="FFFFFF"/>
-                </a:solidFill>
-                <a:latin typeface="Inter" pitchFamily="34" charset="0"/>
-                <a:ea typeface="Inter" pitchFamily="34" charset="-122"/>
-                <a:cs typeface="Inter" pitchFamily="34" charset="-120"/>
-              </a:rPr>
               <a:t>Are simulated data and pre-trained models acceptable? Which evaluation criterion matters most: accuracy, workflow, UX, or response?</a:t>
             </a:r>
             <a:endParaRPr lang="en-US" sz="1500" dirty="0"/>
@@ -3012,14 +2840,6 @@
               <a:buNone/>
             </a:pPr>
             <a:r>
-              <a:rPr lang="en-US" altLang="en-US" sz="1200" dirty="0">
-                <a:solidFill>
-                  <a:srgbClr val="8B9BB4"/>
-                </a:solidFill>
-                <a:latin typeface="JetBrains Mono" pitchFamily="34" charset="0"/>
-                <a:ea typeface="JetBrains Mono" pitchFamily="34" charset="-122"/>
-                <a:cs typeface="JetBrains Mono" pitchFamily="34" charset="-120"/>
-              </a:rPr>
               <a:t>SEC-10 // SAFETY</a:t>
             </a:r>
             <a:endParaRPr lang="en-US" sz="1200" dirty="0"/>
@@ -3082,6 +2902,10 @@
             <a:prstDash val="solid"/>
           </a:ln>
         </p:spPr>
+        <p:txBody>
+          <a:bodyPr/>
+          <a:p/>
+        </p:txBody>
       </p:sp>
       <p:sp>
         <p:nvSpPr>
@@ -3108,14 +2932,6 @@
               <a:buNone/>
             </a:pPr>
             <a:r>
-              <a:rPr lang="en-US" altLang="en-US" sz="1300" dirty="0">
-                <a:solidFill>
-                  <a:srgbClr val="00E5FF"/>
-                </a:solidFill>
-                <a:latin typeface="JetBrains Mono" pitchFamily="34" charset="0"/>
-                <a:ea typeface="JetBrains Mono" pitchFamily="34" charset="-122"/>
-                <a:cs typeface="JetBrains Mono" pitchFamily="34" charset="-120"/>
-              </a:rPr>
               <a:t>10 // EXPECTED OUTCOME</a:t>
             </a:r>
             <a:endParaRPr lang="en-US" sz="1300" dirty="0"/>
@@ -3147,14 +2963,6 @@
               <a:buNone/>
             </a:pPr>
             <a:r>
-              <a:rPr lang="en-US" altLang="en-US" sz="1200" dirty="0">
-                <a:solidFill>
-                  <a:srgbClr val="8B9BB4"/>
-                </a:solidFill>
-                <a:latin typeface="JetBrains Mono" pitchFamily="34" charset="0"/>
-                <a:ea typeface="JetBrains Mono" pitchFamily="34" charset="-122"/>
-                <a:cs typeface="JetBrains Mono" pitchFamily="34" charset="-120"/>
-              </a:rPr>
               <a:t>NEXUS 2026</a:t>
             </a:r>
             <a:endParaRPr lang="en-US" sz="1200" dirty="0"/>
@@ -3186,14 +2994,6 @@
               <a:buNone/>
             </a:pPr>
             <a:r>
-              <a:rPr lang="en-US" altLang="en-US" sz="4400" dirty="0">
-                <a:solidFill>
-                  <a:srgbClr val="FFFFFF"/>
-                </a:solidFill>
-                <a:latin typeface="Space Grotesk" pitchFamily="34" charset="0"/>
-                <a:ea typeface="Space Grotesk" pitchFamily="34" charset="-122"/>
-                <a:cs typeface="Space Grotesk" pitchFamily="34" charset="-120"/>
-              </a:rPr>
               <a:t>The outcome: earlier, clearer, safer decisions</a:t>
             </a:r>
             <a:endParaRPr lang="en-US" sz="4400" dirty="0"/>
@@ -3225,14 +3025,6 @@
               <a:buNone/>
             </a:pPr>
             <a:r>
-              <a:rPr lang="en-US" altLang="en-US" sz="1800" dirty="0">
-                <a:solidFill>
-                  <a:srgbClr val="8B9BB4"/>
-                </a:solidFill>
-                <a:latin typeface="Inter" pitchFamily="34" charset="0"/>
-                <a:ea typeface="Inter" pitchFamily="34" charset="-122"/>
-                <a:cs typeface="Inter" pitchFamily="34" charset="-120"/>
-              </a:rPr>
               <a:t>AegisNexus turns isolated indicators into action-ready intelligence for people and security teams.</a:t>
             </a:r>
             <a:endParaRPr lang="en-US" sz="1800" dirty="0"/>
@@ -3263,6 +3055,10 @@
             <a:prstDash val="solid"/>
           </a:ln>
         </p:spPr>
+        <p:txBody>
+          <a:bodyPr/>
+          <a:p/>
+        </p:txBody>
       </p:sp>
       <p:pic>
         <p:nvPicPr>
@@ -3313,15 +3109,7 @@
               <a:buNone/>
             </a:pPr>
             <a:r>
-              <a:rPr lang="en-US" altLang="en-US" sz="2200" dirty="0">
-                <a:solidFill>
-                  <a:srgbClr val="FFFFFF"/>
-                </a:solidFill>
-                <a:latin typeface="Space Grotesk" pitchFamily="34" charset="0"/>
-                <a:ea typeface="Space Grotesk" pitchFamily="34" charset="-122"/>
-                <a:cs typeface="Space Grotesk" pitchFamily="34" charset="-120"/>
-              </a:rPr>
-              <a:t>Earlier detection</a:t>
+              <a:t>85% Faster Investigation: Flags multi-channel BEC before wire release.</a:t>
             </a:r>
             <a:endParaRPr lang="en-US" sz="2200" dirty="0"/>
           </a:p>
@@ -3352,14 +3140,6 @@
               <a:buNone/>
             </a:pPr>
             <a:r>
-              <a:rPr lang="en-US" altLang="en-US" sz="1600" dirty="0">
-                <a:solidFill>
-                  <a:srgbClr val="8B9BB4"/>
-                </a:solidFill>
-                <a:latin typeface="Inter" pitchFamily="34" charset="0"/>
-                <a:ea typeface="Inter" pitchFamily="34" charset="-122"/>
-                <a:cs typeface="Inter" pitchFamily="34" charset="-120"/>
-              </a:rPr>
               <a:t>Flag suspicious activity before a risky action completes.</a:t>
             </a:r>
             <a:endParaRPr lang="en-US" sz="1600" dirty="0"/>
@@ -3390,6 +3170,10 @@
             <a:prstDash val="solid"/>
           </a:ln>
         </p:spPr>
+        <p:txBody>
+          <a:bodyPr/>
+          <a:p/>
+        </p:txBody>
       </p:sp>
       <p:pic>
         <p:nvPicPr>
@@ -3440,15 +3224,7 @@
               <a:buNone/>
             </a:pPr>
             <a:r>
-              <a:rPr lang="en-US" altLang="en-US" sz="2200" dirty="0">
-                <a:solidFill>
-                  <a:srgbClr val="FFFFFF"/>
-                </a:solidFill>
-                <a:latin typeface="Space Grotesk" pitchFamily="34" charset="0"/>
-                <a:ea typeface="Space Grotesk" pitchFamily="34" charset="-122"/>
-                <a:cs typeface="Space Grotesk" pitchFamily="34" charset="-120"/>
-              </a:rPr>
-              <a:t>Cross-modal confidence</a:t>
+              <a:t>Cross-Modal Confidence: Correlates 5 modalities instead of siloed alerts.</a:t>
             </a:r>
             <a:endParaRPr lang="en-US" sz="2200" dirty="0"/>
           </a:p>
@@ -3479,14 +3255,6 @@
               <a:buNone/>
             </a:pPr>
             <a:r>
-              <a:rPr lang="en-US" altLang="en-US" sz="1600" dirty="0">
-                <a:solidFill>
-                  <a:srgbClr val="8B9BB4"/>
-                </a:solidFill>
-                <a:latin typeface="Inter" pitchFamily="34" charset="0"/>
-                <a:ea typeface="Inter" pitchFamily="34" charset="-122"/>
-                <a:cs typeface="Inter" pitchFamily="34" charset="-120"/>
-              </a:rPr>
               <a:t>Combine evidence sources instead of trusting one clue.</a:t>
             </a:r>
             <a:endParaRPr lang="en-US" sz="1600" dirty="0"/>
@@ -3517,6 +3285,10 @@
             <a:prstDash val="solid"/>
           </a:ln>
         </p:spPr>
+        <p:txBody>
+          <a:bodyPr/>
+          <a:p/>
+        </p:txBody>
       </p:sp>
       <p:pic>
         <p:nvPicPr>
@@ -3567,15 +3339,7 @@
               <a:buNone/>
             </a:pPr>
             <a:r>
-              <a:rPr lang="en-US" altLang="en-US" sz="2200" dirty="0">
-                <a:solidFill>
-                  <a:srgbClr val="FFFFFF"/>
-                </a:solidFill>
-                <a:latin typeface="Space Grotesk" pitchFamily="34" charset="0"/>
-                <a:ea typeface="Space Grotesk" pitchFamily="34" charset="-122"/>
-                <a:cs typeface="Space Grotesk" pitchFamily="34" charset="-120"/>
-              </a:rPr>
-              <a:t>Campaign visibility</a:t>
+              <a:t>Topological Memory: Maps infrastructure, ASN, and identity anomalies.</a:t>
             </a:r>
             <a:endParaRPr lang="en-US" sz="2200" dirty="0"/>
           </a:p>
@@ -3606,14 +3370,6 @@
               <a:buNone/>
             </a:pPr>
             <a:r>
-              <a:rPr lang="en-US" altLang="en-US" sz="1600" dirty="0">
-                <a:solidFill>
-                  <a:srgbClr val="8B9BB4"/>
-                </a:solidFill>
-                <a:latin typeface="Inter" pitchFamily="34" charset="0"/>
-                <a:ea typeface="Inter" pitchFamily="34" charset="-122"/>
-                <a:cs typeface="Inter" pitchFamily="34" charset="-120"/>
-              </a:rPr>
               <a:t>Transform related indicators into one incident view.</a:t>
             </a:r>
             <a:endParaRPr lang="en-US" sz="1600" dirty="0"/>
@@ -3644,6 +3400,10 @@
             <a:prstDash val="solid"/>
           </a:ln>
         </p:spPr>
+        <p:txBody>
+          <a:bodyPr/>
+          <a:p/>
+        </p:txBody>
       </p:sp>
       <p:pic>
         <p:nvPicPr>
@@ -3694,15 +3454,7 @@
               <a:buNone/>
             </a:pPr>
             <a:r>
-              <a:rPr lang="en-US" altLang="en-US" sz="2200" dirty="0">
-                <a:solidFill>
-                  <a:srgbClr val="FFFFFF"/>
-                </a:solidFill>
-                <a:latin typeface="Space Grotesk" pitchFamily="34" charset="0"/>
-                <a:ea typeface="Space Grotesk" pitchFamily="34" charset="-122"/>
-                <a:cs typeface="Space Grotesk" pitchFamily="34" charset="-120"/>
-              </a:rPr>
-              <a:t>Explainable security</a:t>
+              <a:t>Explainable Verdict: Transparent 0–100 risk score with zero hallucinations.</a:t>
             </a:r>
             <a:endParaRPr lang="en-US" sz="2200" dirty="0"/>
           </a:p>
@@ -3733,14 +3485,6 @@
               <a:buNone/>
             </a:pPr>
             <a:r>
-              <a:rPr lang="en-US" altLang="en-US" sz="1600" dirty="0">
-                <a:solidFill>
-                  <a:srgbClr val="8B9BB4"/>
-                </a:solidFill>
-                <a:latin typeface="Inter" pitchFamily="34" charset="0"/>
-                <a:ea typeface="Inter" pitchFamily="34" charset="-122"/>
-                <a:cs typeface="Inter" pitchFamily="34" charset="-120"/>
-              </a:rPr>
               <a:t>Show score, evidence, graph, and recommended response.</a:t>
             </a:r>
             <a:endParaRPr lang="en-US" sz="1600" dirty="0"/>
@@ -3771,6 +3515,10 @@
             <a:prstDash val="solid"/>
           </a:ln>
         </p:spPr>
+        <p:txBody>
+          <a:bodyPr/>
+          <a:p/>
+        </p:txBody>
       </p:sp>
       <p:pic>
         <p:nvPicPr>
@@ -3821,15 +3569,7 @@
               <a:buNone/>
             </a:pPr>
             <a:r>
-              <a:rPr lang="en-US" altLang="en-US" sz="2200" dirty="0">
-                <a:solidFill>
-                  <a:srgbClr val="FFFFFF"/>
-                </a:solidFill>
-                <a:latin typeface="Space Grotesk" pitchFamily="34" charset="0"/>
-                <a:ea typeface="Space Grotesk" pitchFamily="34" charset="-122"/>
-                <a:cs typeface="Space Grotesk" pitchFamily="34" charset="-120"/>
-              </a:rPr>
-              <a:t>Safer response</a:t>
+              <a:t>Human-in-the-Loop Gate: Mitigates risk while preserving executive control.</a:t>
             </a:r>
             <a:endParaRPr lang="en-US" sz="2200" dirty="0"/>
           </a:p>
@@ -3860,14 +3600,6 @@
               <a:buNone/>
             </a:pPr>
             <a:r>
-              <a:rPr lang="en-US" altLang="en-US" sz="1600" dirty="0">
-                <a:solidFill>
-                  <a:srgbClr val="8B9BB4"/>
-                </a:solidFill>
-                <a:latin typeface="Inter" pitchFamily="34" charset="0"/>
-                <a:ea typeface="Inter" pitchFamily="34" charset="-122"/>
-                <a:cs typeface="Inter" pitchFamily="34" charset="-120"/>
-              </a:rPr>
               <a:t>Contain risk while preserving human control.</a:t>
             </a:r>
             <a:endParaRPr lang="en-US" sz="1600" dirty="0"/>
@@ -3899,14 +3631,6 @@
               <a:buNone/>
             </a:pPr>
             <a:r>
-              <a:rPr lang="en-US" altLang="en-US" sz="1200" dirty="0">
-                <a:solidFill>
-                  <a:srgbClr val="8B9BB4"/>
-                </a:solidFill>
-                <a:latin typeface="JetBrains Mono" pitchFamily="34" charset="0"/>
-                <a:ea typeface="JetBrains Mono" pitchFamily="34" charset="-122"/>
-                <a:cs typeface="JetBrains Mono" pitchFamily="34" charset="-120"/>
-              </a:rPr>
               <a:t>SEC-11 // OUTCOMES</a:t>
             </a:r>
             <a:endParaRPr lang="en-US" sz="1200" dirty="0"/>
@@ -3989,6 +3713,10 @@
             <a:prstDash val="solid"/>
           </a:ln>
         </p:spPr>
+        <p:txBody>
+          <a:bodyPr/>
+          <a:p/>
+        </p:txBody>
       </p:sp>
       <p:sp>
         <p:nvSpPr>
@@ -4013,6 +3741,10 @@
             <a:prstDash val="solid"/>
           </a:ln>
         </p:spPr>
+        <p:txBody>
+          <a:bodyPr/>
+          <a:p/>
+        </p:txBody>
       </p:sp>
       <p:sp>
         <p:nvSpPr>
@@ -4039,14 +3771,6 @@
               <a:buNone/>
             </a:pPr>
             <a:r>
-              <a:rPr lang="en-US" altLang="en-US" sz="1300" dirty="0">
-                <a:solidFill>
-                  <a:srgbClr val="00E5FF"/>
-                </a:solidFill>
-                <a:latin typeface="JetBrains Mono" pitchFamily="34" charset="0"/>
-                <a:ea typeface="JetBrains Mono" pitchFamily="34" charset="-122"/>
-                <a:cs typeface="JetBrains Mono" pitchFamily="34" charset="-120"/>
-              </a:rPr>
               <a:t>NEXUS 2026 // FINAL PROTOCOL</a:t>
             </a:r>
             <a:endParaRPr lang="en-US" sz="1300" dirty="0"/>
@@ -4078,14 +3802,6 @@
               <a:buNone/>
             </a:pPr>
             <a:r>
-              <a:rPr lang="en-US" altLang="en-US" sz="5200" dirty="0">
-                <a:solidFill>
-                  <a:srgbClr val="FFFFFF"/>
-                </a:solidFill>
-                <a:latin typeface="Space Grotesk" pitchFamily="34" charset="0"/>
-                <a:ea typeface="Space Grotesk" pitchFamily="34" charset="-122"/>
-                <a:cs typeface="Space Grotesk" pitchFamily="34" charset="-120"/>
-              </a:rPr>
               <a:t>Detect the signal. Verify the identity.</a:t>
             </a:r>
             <a:endParaRPr lang="en-US" sz="5200" dirty="0"/>
@@ -4117,14 +3833,6 @@
               <a:buNone/>
             </a:pPr>
             <a:r>
-              <a:rPr lang="en-US" altLang="en-US" sz="5200" dirty="0">
-                <a:solidFill>
-                  <a:srgbClr val="00E5FF"/>
-                </a:solidFill>
-                <a:latin typeface="Space Grotesk" pitchFamily="34" charset="0"/>
-                <a:ea typeface="Space Grotesk" pitchFamily="34" charset="-122"/>
-                <a:cs typeface="Space Grotesk" pitchFamily="34" charset="-120"/>
-              </a:rPr>
               <a:t>Correlate the threat. Make the response safe.</a:t>
             </a:r>
             <a:endParaRPr lang="en-US" sz="5200" dirty="0"/>
@@ -4152,6 +3860,10 @@
             <a:prstDash val="solid"/>
           </a:ln>
         </p:spPr>
+        <p:txBody>
+          <a:bodyPr/>
+          <a:p/>
+        </p:txBody>
       </p:sp>
       <p:sp>
         <p:nvSpPr>
@@ -4178,14 +3890,6 @@
               <a:buNone/>
             </a:pPr>
             <a:r>
-              <a:rPr lang="en-US" altLang="en-US" sz="2300" dirty="0">
-                <a:solidFill>
-                  <a:srgbClr val="FFFFFF"/>
-                </a:solidFill>
-                <a:latin typeface="Space Grotesk" pitchFamily="34" charset="0"/>
-                <a:ea typeface="Space Grotesk" pitchFamily="34" charset="-122"/>
-                <a:cs typeface="Space Grotesk" pitchFamily="34" charset="-120"/>
-              </a:rPr>
               <a:t>Tech Creature Solutions</a:t>
             </a:r>
             <a:endParaRPr lang="en-US" sz="2300" dirty="0"/>
@@ -4217,15 +3921,7 @@
               <a:buNone/>
             </a:pPr>
             <a:r>
-              <a:rPr lang="en-US" altLang="en-US" sz="1800" dirty="0">
-                <a:solidFill>
-                  <a:srgbClr val="00E5FF"/>
-                </a:solidFill>
-                <a:latin typeface="Inter" pitchFamily="34" charset="0"/>
-                <a:ea typeface="Inter" pitchFamily="34" charset="-122"/>
-                <a:cs typeface="Inter" pitchFamily="34" charset="-120"/>
-              </a:rPr>
-              <a:t>Mohammad Sahil · Zainab Memon</a:t>
+              <a:t>Mohammad Sahil • Zainab Memon</a:t>
             </a:r>
             <a:endParaRPr lang="en-US" sz="1800" dirty="0"/>
           </a:p>
@@ -4256,14 +3952,6 @@
               <a:buNone/>
             </a:pPr>
             <a:r>
-              <a:rPr lang="en-US" altLang="en-US" sz="1600" dirty="0">
-                <a:solidFill>
-                  <a:srgbClr val="8B9BB4"/>
-                </a:solidFill>
-                <a:latin typeface="Inter" pitchFamily="34" charset="0"/>
-                <a:ea typeface="Inter" pitchFamily="34" charset="-122"/>
-                <a:cs typeface="Inter" pitchFamily="34" charset="-120"/>
-              </a:rPr>
               <a:t>AegisNexus — AI-Powered Deepfake and Phishing Defense</a:t>
             </a:r>
             <a:endParaRPr lang="en-US" sz="1600" dirty="0"/>
@@ -4295,15 +3983,7 @@
               <a:buNone/>
             </a:pPr>
             <a:r>
-              <a:rPr lang="en-US" altLang="en-US" sz="1400" dirty="0">
-                <a:solidFill>
-                  <a:srgbClr val="00E5FF"/>
-                </a:solidFill>
-                <a:latin typeface="JetBrains Mono" pitchFamily="34" charset="0"/>
-                <a:ea typeface="JetBrains Mono" pitchFamily="34" charset="-122"/>
-                <a:cs typeface="JetBrains Mono" pitchFamily="34" charset="-120"/>
-              </a:rPr>
-              <a:t>THANK YOU // QUESTIONS</a:t>
+              <a:t>THANK YOU // QUESTIONS &amp; DEMO</a:t>
             </a:r>
             <a:endParaRPr lang="en-US" sz="1400" dirty="0"/>
           </a:p>
@@ -4334,15 +4014,7 @@
               <a:buNone/>
             </a:pPr>
             <a:r>
-              <a:rPr lang="en-US" altLang="en-US" sz="1100" dirty="0">
-                <a:solidFill>
-                  <a:srgbClr val="8B9BB4"/>
-                </a:solidFill>
-                <a:latin typeface="JetBrains Mono" pitchFamily="34" charset="0"/>
-                <a:ea typeface="JetBrains Mono" pitchFamily="34" charset="-122"/>
-                <a:cs typeface="JetBrains Mono" pitchFamily="34" charset="-120"/>
-              </a:rPr>
-              <a:t>SYSTEM CLOSE // TECH CREATURE SOLUTIONS</a:t>
+              <a:t>LIVE POC: aegis-nexus-alpha.vercel.app • GITHUB: sahilshaikh1101/AegisNexus-NexusHackathon</a:t>
             </a:r>
             <a:endParaRPr lang="en-US" sz="1100" dirty="0"/>
           </a:p>
@@ -4404,6 +4076,10 @@
             <a:prstDash val="solid"/>
           </a:ln>
         </p:spPr>
+        <p:txBody>
+          <a:bodyPr/>
+          <a:p/>
+        </p:txBody>
       </p:sp>
       <p:sp>
         <p:nvSpPr>
@@ -4430,14 +4106,6 @@
               <a:buNone/>
             </a:pPr>
             <a:r>
-              <a:rPr lang="en-US" altLang="en-US" sz="1300" dirty="0">
-                <a:solidFill>
-                  <a:srgbClr val="00E5FF"/>
-                </a:solidFill>
-                <a:latin typeface="JetBrains Mono" pitchFamily="34" charset="0"/>
-                <a:ea typeface="JetBrains Mono" pitchFamily="34" charset="-122"/>
-                <a:cs typeface="JetBrains Mono" pitchFamily="34" charset="-120"/>
-              </a:rPr>
               <a:t>MANDATORY 01 // PROBLEM STATEMENT</a:t>
             </a:r>
             <a:endParaRPr lang="en-US" sz="1300" dirty="0"/>
@@ -4469,14 +4137,6 @@
               <a:buNone/>
             </a:pPr>
             <a:r>
-              <a:rPr lang="en-US" altLang="en-US" sz="1200" dirty="0">
-                <a:solidFill>
-                  <a:srgbClr val="8B9BB4"/>
-                </a:solidFill>
-                <a:latin typeface="JetBrains Mono" pitchFamily="34" charset="0"/>
-                <a:ea typeface="JetBrains Mono" pitchFamily="34" charset="-122"/>
-                <a:cs typeface="JetBrains Mono" pitchFamily="34" charset="-120"/>
-              </a:rPr>
               <a:t>NEXUS 2026</a:t>
             </a:r>
             <a:endParaRPr lang="en-US" sz="1200" dirty="0"/>
@@ -4511,14 +4171,6 @@
               <a:buNone/>
             </a:pPr>
             <a:r>
-              <a:rPr lang="en-US" altLang="en-US" sz="4700" dirty="0">
-                <a:solidFill>
-                  <a:srgbClr val="FFFFFF"/>
-                </a:solidFill>
-                <a:latin typeface="Space Grotesk" pitchFamily="34" charset="0"/>
-                <a:ea typeface="Space Grotesk" pitchFamily="34" charset="-122"/>
-                <a:cs typeface="Space Grotesk" pitchFamily="34" charset="-120"/>
-              </a:rPr>
               <a:t>AI turned one phishing email into a coordinated impersonation attack</a:t>
             </a:r>
             <a:endParaRPr lang="en-US" sz="4700" dirty="0"/>
@@ -4549,6 +4201,10 @@
             <a:prstDash val="solid"/>
           </a:ln>
         </p:spPr>
+        <p:txBody>
+          <a:bodyPr/>
+          <a:p/>
+        </p:txBody>
       </p:sp>
       <p:pic>
         <p:nvPicPr>
@@ -4599,14 +4255,6 @@
               <a:buNone/>
             </a:pPr>
             <a:r>
-              <a:rPr lang="en-US" altLang="en-US" sz="2100" dirty="0">
-                <a:solidFill>
-                  <a:srgbClr val="FFFFFF"/>
-                </a:solidFill>
-                <a:latin typeface="Space Grotesk" pitchFamily="34" charset="0"/>
-                <a:ea typeface="Space Grotesk" pitchFamily="34" charset="-122"/>
-                <a:cs typeface="Space Grotesk" pitchFamily="34" charset="-120"/>
-              </a:rPr>
               <a:t>Polished phishing</a:t>
             </a:r>
             <a:endParaRPr lang="en-US" sz="2100" dirty="0"/>
@@ -4638,14 +4286,6 @@
               <a:buNone/>
             </a:pPr>
             <a:r>
-              <a:rPr lang="en-US" altLang="en-US" sz="1600" dirty="0">
-                <a:solidFill>
-                  <a:srgbClr val="8B9BB4"/>
-                </a:solidFill>
-                <a:latin typeface="Inter" pitchFamily="34" charset="0"/>
-                <a:ea typeface="Inter" pitchFamily="34" charset="-122"/>
-                <a:cs typeface="Inter" pitchFamily="34" charset="-120"/>
-              </a:rPr>
               <a:t>Trusted language, urgent payment requests, look-alike links.</a:t>
             </a:r>
             <a:endParaRPr lang="en-US" sz="1600" dirty="0"/>
@@ -4676,6 +4316,10 @@
             <a:prstDash val="solid"/>
           </a:ln>
         </p:spPr>
+        <p:txBody>
+          <a:bodyPr/>
+          <a:p/>
+        </p:txBody>
       </p:sp>
       <p:pic>
         <p:nvPicPr>
@@ -4726,14 +4370,6 @@
               <a:buNone/>
             </a:pPr>
             <a:r>
-              <a:rPr lang="en-US" altLang="en-US" sz="2100" dirty="0">
-                <a:solidFill>
-                  <a:srgbClr val="FFFFFF"/>
-                </a:solidFill>
-                <a:latin typeface="Space Grotesk" pitchFamily="34" charset="0"/>
-                <a:ea typeface="Space Grotesk" pitchFamily="34" charset="-122"/>
-                <a:cs typeface="Space Grotesk" pitchFamily="34" charset="-120"/>
-              </a:rPr>
               <a:t>Synthetic presence</a:t>
             </a:r>
             <a:endParaRPr lang="en-US" sz="2100" dirty="0"/>
@@ -4765,14 +4401,6 @@
               <a:buNone/>
             </a:pPr>
             <a:r>
-              <a:rPr lang="en-US" altLang="en-US" sz="1600" dirty="0">
-                <a:solidFill>
-                  <a:srgbClr val="8B9BB4"/>
-                </a:solidFill>
-                <a:latin typeface="Inter" pitchFamily="34" charset="0"/>
-                <a:ea typeface="Inter" pitchFamily="34" charset="-122"/>
-                <a:cs typeface="Inter" pitchFamily="34" charset="-120"/>
-              </a:rPr>
               <a:t>Cloned voice and manipulated video imitate authority.</a:t>
             </a:r>
             <a:endParaRPr lang="en-US" sz="1600" dirty="0"/>
@@ -4803,6 +4431,10 @@
             <a:prstDash val="solid"/>
           </a:ln>
         </p:spPr>
+        <p:txBody>
+          <a:bodyPr/>
+          <a:p/>
+        </p:txBody>
       </p:sp>
       <p:pic>
         <p:nvPicPr>
@@ -4853,14 +4485,6 @@
               <a:buNone/>
             </a:pPr>
             <a:r>
-              <a:rPr lang="en-US" altLang="en-US" sz="2100" dirty="0">
-                <a:solidFill>
-                  <a:srgbClr val="FFFFFF"/>
-                </a:solidFill>
-                <a:latin typeface="Space Grotesk" pitchFamily="34" charset="0"/>
-                <a:ea typeface="Space Grotesk" pitchFamily="34" charset="-122"/>
-                <a:cs typeface="Space Grotesk" pitchFamily="34" charset="-120"/>
-              </a:rPr>
               <a:t>Multiple channels</a:t>
             </a:r>
             <a:endParaRPr lang="en-US" sz="2100" dirty="0"/>
@@ -4892,14 +4516,6 @@
               <a:buNone/>
             </a:pPr>
             <a:r>
-              <a:rPr lang="en-US" altLang="en-US" sz="1600" dirty="0">
-                <a:solidFill>
-                  <a:srgbClr val="8B9BB4"/>
-                </a:solidFill>
-                <a:latin typeface="Inter" pitchFamily="34" charset="0"/>
-                <a:ea typeface="Inter" pitchFamily="34" charset="-122"/>
-                <a:cs typeface="Inter" pitchFamily="34" charset="-120"/>
-              </a:rPr>
               <a:t>Email, URL, voice, video, and network activity converge.</a:t>
             </a:r>
             <a:endParaRPr lang="en-US" sz="1600" dirty="0"/>
@@ -4952,6 +4568,10 @@
             <a:prstDash val="solid"/>
           </a:ln>
         </p:spPr>
+        <p:txBody>
+          <a:bodyPr/>
+          <a:p/>
+        </p:txBody>
       </p:sp>
       <p:sp>
         <p:nvSpPr>
@@ -4978,15 +4598,7 @@
               <a:buNone/>
             </a:pPr>
             <a:r>
-              <a:rPr lang="en-US" altLang="en-US" sz="1100" dirty="0">
-                <a:solidFill>
-                  <a:srgbClr val="8B9BB4"/>
-                </a:solidFill>
-                <a:latin typeface="JetBrains Mono" pitchFamily="34" charset="0"/>
-                <a:ea typeface="JetBrains Mono" pitchFamily="34" charset="-122"/>
-                <a:cs typeface="JetBrains Mono" pitchFamily="34" charset="-120"/>
-              </a:rPr>
-              <a:t>Sources: NSA, FBI &amp; CISA deepfake-threat guidance · FBI business-email-compromise guidance</a:t>
+              <a:t>Sources: FBI IC3 Report ($55.4B BEC Losses) • NSA &amp; CISA Deepfake Guidance</a:t>
             </a:r>
             <a:endParaRPr lang="en-US" sz="1100" dirty="0"/>
           </a:p>
@@ -5017,14 +4629,6 @@
               <a:buNone/>
             </a:pPr>
             <a:r>
-              <a:rPr lang="en-US" altLang="en-US" sz="1200" dirty="0">
-                <a:solidFill>
-                  <a:srgbClr val="8B9BB4"/>
-                </a:solidFill>
-                <a:latin typeface="JetBrains Mono" pitchFamily="34" charset="0"/>
-                <a:ea typeface="JetBrains Mono" pitchFamily="34" charset="-122"/>
-                <a:cs typeface="JetBrains Mono" pitchFamily="34" charset="-120"/>
-              </a:rPr>
               <a:t>SEC-02 // THREAT</a:t>
             </a:r>
             <a:endParaRPr lang="en-US" sz="1200" dirty="0"/>
@@ -5117,14 +4721,6 @@
               <a:buNone/>
             </a:pPr>
             <a:r>
-              <a:rPr lang="en-US" altLang="en-US" sz="1300" dirty="0">
-                <a:solidFill>
-                  <a:srgbClr val="00E5FF"/>
-                </a:solidFill>
-                <a:latin typeface="JetBrains Mono" pitchFamily="34" charset="0"/>
-                <a:ea typeface="JetBrains Mono" pitchFamily="34" charset="-122"/>
-                <a:cs typeface="JetBrains Mono" pitchFamily="34" charset="-120"/>
-              </a:rPr>
               <a:t>PROBLEM DETAIL // WHY LEGACY CONTROLS MISS CAMPAIGNS</a:t>
             </a:r>
             <a:endParaRPr lang="en-US" sz="1300" dirty="0"/>
@@ -5156,14 +4752,6 @@
               <a:buNone/>
             </a:pPr>
             <a:r>
-              <a:rPr lang="en-US" altLang="en-US" sz="1200" dirty="0">
-                <a:solidFill>
-                  <a:srgbClr val="8B9BB4"/>
-                </a:solidFill>
-                <a:latin typeface="JetBrains Mono" pitchFamily="34" charset="0"/>
-                <a:ea typeface="JetBrains Mono" pitchFamily="34" charset="-122"/>
-                <a:cs typeface="JetBrains Mono" pitchFamily="34" charset="-120"/>
-              </a:rPr>
               <a:t>NEXUS 2026</a:t>
             </a:r>
             <a:endParaRPr lang="en-US" sz="1200" dirty="0"/>
@@ -5195,14 +4783,6 @@
               <a:buNone/>
             </a:pPr>
             <a:r>
-              <a:rPr lang="en-US" altLang="en-US" sz="4500" dirty="0">
-                <a:solidFill>
-                  <a:srgbClr val="FFFFFF"/>
-                </a:solidFill>
-                <a:latin typeface="Space Grotesk" pitchFamily="34" charset="0"/>
-                <a:ea typeface="Space Grotesk" pitchFamily="34" charset="-122"/>
-                <a:cs typeface="Space Grotesk" pitchFamily="34" charset="-120"/>
-              </a:rPr>
               <a:t>Separate alerts hide the full attack story</a:t>
             </a:r>
             <a:endParaRPr lang="en-US" sz="4500" dirty="0"/>
@@ -5234,14 +4814,6 @@
               <a:buNone/>
             </a:pPr>
             <a:r>
-              <a:rPr lang="en-US" altLang="en-US" sz="1800" dirty="0">
-                <a:solidFill>
-                  <a:srgbClr val="8B9BB4"/>
-                </a:solidFill>
-                <a:latin typeface="Inter" pitchFamily="34" charset="0"/>
-                <a:ea typeface="Inter" pitchFamily="34" charset="-122"/>
-                <a:cs typeface="Inter" pitchFamily="34" charset="-120"/>
-              </a:rPr>
               <a:t>Attackers coordinate signals; traditional tools often isolate them. AegisNexus correlates them before a payment or access decision is made.</a:t>
             </a:r>
             <a:endParaRPr lang="en-US" sz="1800" dirty="0"/>
@@ -5273,14 +4845,6 @@
               <a:buNone/>
             </a:pPr>
             <a:r>
-              <a:rPr lang="en-US" altLang="en-US" sz="1300" dirty="0">
-                <a:solidFill>
-                  <a:srgbClr val="FF007F"/>
-                </a:solidFill>
-                <a:latin typeface="JetBrains Mono" pitchFamily="34" charset="0"/>
-                <a:ea typeface="JetBrains Mono" pitchFamily="34" charset="-122"/>
-                <a:cs typeface="JetBrains Mono" pitchFamily="34" charset="-120"/>
-              </a:rPr>
               <a:t>TRADITIONAL VIEW // 4 SEPARATE ALERTS</a:t>
             </a:r>
             <a:endParaRPr lang="en-US" sz="1300" dirty="0"/>
@@ -5396,14 +4960,6 @@
               <a:buNone/>
             </a:pPr>
             <a:r>
-              <a:rPr lang="en-US" altLang="en-US" sz="1700" dirty="0">
-                <a:solidFill>
-                  <a:srgbClr val="FFFFFF"/>
-                </a:solidFill>
-                <a:latin typeface="Inter" pitchFamily="34" charset="0"/>
-                <a:ea typeface="Inter" pitchFamily="34" charset="-122"/>
-                <a:cs typeface="Inter" pitchFamily="34" charset="-120"/>
-              </a:rPr>
               <a:t>Suspicious payment email</a:t>
             </a:r>
             <a:endParaRPr lang="en-US" sz="1700" dirty="0"/>
@@ -5488,14 +5044,6 @@
               <a:buNone/>
             </a:pPr>
             <a:r>
-              <a:rPr lang="en-US" altLang="en-US" sz="1700" dirty="0">
-                <a:solidFill>
-                  <a:srgbClr val="FFFFFF"/>
-                </a:solidFill>
-                <a:latin typeface="Inter" pitchFamily="34" charset="0"/>
-                <a:ea typeface="Inter" pitchFamily="34" charset="-122"/>
-                <a:cs typeface="Inter" pitchFamily="34" charset="-120"/>
-              </a:rPr>
               <a:t>Look-alike payment URL</a:t>
             </a:r>
             <a:endParaRPr lang="en-US" sz="1700" dirty="0"/>
@@ -5580,14 +5128,6 @@
               <a:buNone/>
             </a:pPr>
             <a:r>
-              <a:rPr lang="en-US" altLang="en-US" sz="1700" dirty="0">
-                <a:solidFill>
-                  <a:srgbClr val="FFFFFF"/>
-                </a:solidFill>
-                <a:latin typeface="Inter" pitchFamily="34" charset="0"/>
-                <a:ea typeface="Inter" pitchFamily="34" charset="-122"/>
-                <a:cs typeface="Inter" pitchFamily="34" charset="-120"/>
-              </a:rPr>
               <a:t>Unknown voice note</a:t>
             </a:r>
             <a:endParaRPr lang="en-US" sz="1700" dirty="0"/>
@@ -5672,14 +5212,6 @@
               <a:buNone/>
             </a:pPr>
             <a:r>
-              <a:rPr lang="en-US" altLang="en-US" sz="1700" dirty="0">
-                <a:solidFill>
-                  <a:srgbClr val="FFFFFF"/>
-                </a:solidFill>
-                <a:latin typeface="Inter" pitchFamily="34" charset="0"/>
-                <a:ea typeface="Inter" pitchFamily="34" charset="-122"/>
-                <a:cs typeface="Inter" pitchFamily="34" charset="-120"/>
-              </a:rPr>
               <a:t>Related domain activity</a:t>
             </a:r>
             <a:endParaRPr lang="en-US" sz="1700" dirty="0"/>
@@ -5742,14 +5274,6 @@
               <a:buNone/>
             </a:pPr>
             <a:r>
-              <a:rPr lang="en-US" altLang="en-US" sz="1200" dirty="0">
-                <a:solidFill>
-                  <a:srgbClr val="8B9BB4"/>
-                </a:solidFill>
-                <a:latin typeface="JetBrains Mono" pitchFamily="34" charset="0"/>
-                <a:ea typeface="JetBrains Mono" pitchFamily="34" charset="-122"/>
-                <a:cs typeface="JetBrains Mono" pitchFamily="34" charset="-120"/>
-              </a:rPr>
               <a:t>CORRELATE</a:t>
             </a:r>
             <a:endParaRPr lang="en-US" sz="1200" dirty="0"/>
@@ -5762,14 +5286,6 @@
               <a:buNone/>
             </a:pPr>
             <a:r>
-              <a:rPr lang="en-US" altLang="en-US" sz="1200" dirty="0">
-                <a:solidFill>
-                  <a:srgbClr val="8B9BB4"/>
-                </a:solidFill>
-                <a:latin typeface="JetBrains Mono" pitchFamily="34" charset="0"/>
-                <a:ea typeface="JetBrains Mono" pitchFamily="34" charset="-122"/>
-                <a:cs typeface="JetBrains Mono" pitchFamily="34" charset="-120"/>
-              </a:rPr>
               <a:t>EVIDENCE</a:t>
             </a:r>
             <a:endParaRPr lang="en-US" sz="1200" dirty="0"/>
@@ -5861,14 +5377,6 @@
               <a:buNone/>
             </a:pPr>
             <a:r>
-              <a:rPr lang="en-US" altLang="en-US" sz="1200" dirty="0">
-                <a:solidFill>
-                  <a:srgbClr val="0A0F1A"/>
-                </a:solidFill>
-                <a:latin typeface="JetBrains Mono" pitchFamily="34" charset="0"/>
-                <a:ea typeface="JetBrains Mono" pitchFamily="34" charset="-122"/>
-                <a:cs typeface="JetBrains Mono" pitchFamily="34" charset="-120"/>
-              </a:rPr>
               <a:t>HIGH RISK</a:t>
             </a:r>
             <a:endParaRPr lang="en-US" sz="1200" dirty="0"/>
@@ -5900,14 +5408,6 @@
               <a:buNone/>
             </a:pPr>
             <a:r>
-              <a:rPr lang="en-US" altLang="en-US" sz="2700" dirty="0">
-                <a:solidFill>
-                  <a:srgbClr val="FFFFFF"/>
-                </a:solidFill>
-                <a:latin typeface="Space Grotesk" pitchFamily="34" charset="0"/>
-                <a:ea typeface="Space Grotesk" pitchFamily="34" charset="-122"/>
-                <a:cs typeface="Space Grotesk" pitchFamily="34" charset="-120"/>
-              </a:rPr>
               <a:t>Possible CFO impersonation</a:t>
             </a:r>
             <a:endParaRPr lang="en-US" sz="2700" dirty="0"/>
@@ -5942,14 +5442,6 @@
               <a:buNone/>
             </a:pPr>
             <a:r>
-              <a:rPr lang="en-US" altLang="en-US" sz="1800" dirty="0">
-                <a:solidFill>
-                  <a:srgbClr val="8B9BB4"/>
-                </a:solidFill>
-                <a:latin typeface="Inter" pitchFamily="34" charset="0"/>
-                <a:ea typeface="Inter" pitchFamily="34" charset="-122"/>
-                <a:cs typeface="Inter" pitchFamily="34" charset="-120"/>
-              </a:rPr>
               <a:t>Urgent-payment intent + look-alike domain + unknown voice channel + identity anomaly + linked alert history.</a:t>
             </a:r>
             <a:endParaRPr lang="en-US" sz="1800" dirty="0"/>
@@ -6007,14 +5499,6 @@
               <a:buNone/>
             </a:pPr>
             <a:r>
-              <a:rPr lang="en-US" altLang="en-US" sz="1200" dirty="0">
-                <a:solidFill>
-                  <a:srgbClr val="00E5FF"/>
-                </a:solidFill>
-                <a:latin typeface="JetBrains Mono" pitchFamily="34" charset="0"/>
-                <a:ea typeface="JetBrains Mono" pitchFamily="34" charset="-122"/>
-                <a:cs typeface="JetBrains Mono" pitchFamily="34" charset="-120"/>
-              </a:rPr>
               <a:t>RECOMMENDED ACTION</a:t>
             </a:r>
             <a:endParaRPr lang="en-US" sz="1200" dirty="0"/>
@@ -6046,14 +5530,6 @@
               <a:buNone/>
             </a:pPr>
             <a:r>
-              <a:rPr lang="en-US" altLang="en-US" sz="1800" dirty="0">
-                <a:solidFill>
-                  <a:srgbClr val="FFFFFF"/>
-                </a:solidFill>
-                <a:latin typeface="Inter" pitchFamily="34" charset="0"/>
-                <a:ea typeface="Inter" pitchFamily="34" charset="-122"/>
-                <a:cs typeface="Inter" pitchFamily="34" charset="-120"/>
-              </a:rPr>
               <a:t>Quarantine · block · notify analyst</a:t>
             </a:r>
             <a:endParaRPr lang="en-US" sz="1800" dirty="0"/>
@@ -6085,14 +5561,6 @@
               <a:buNone/>
             </a:pPr>
             <a:r>
-              <a:rPr lang="en-US" altLang="en-US" sz="1200" dirty="0">
-                <a:solidFill>
-                  <a:srgbClr val="8B9BB4"/>
-                </a:solidFill>
-                <a:latin typeface="JetBrains Mono" pitchFamily="34" charset="0"/>
-                <a:ea typeface="JetBrains Mono" pitchFamily="34" charset="-122"/>
-                <a:cs typeface="JetBrains Mono" pitchFamily="34" charset="-120"/>
-              </a:rPr>
               <a:t>SEC-03 // PROBLEM CONTEXT</a:t>
             </a:r>
             <a:endParaRPr lang="en-US" sz="1200" dirty="0"/>
@@ -6155,6 +5623,10 @@
             <a:prstDash val="solid"/>
           </a:ln>
         </p:spPr>
+        <p:txBody>
+          <a:bodyPr/>
+          <a:p/>
+        </p:txBody>
       </p:sp>
       <p:sp>
         <p:nvSpPr>
@@ -6181,14 +5653,6 @@
               <a:buNone/>
             </a:pPr>
             <a:r>
-              <a:rPr lang="en-US" altLang="en-US" sz="1300" dirty="0">
-                <a:solidFill>
-                  <a:srgbClr val="00E5FF"/>
-                </a:solidFill>
-                <a:latin typeface="JetBrains Mono" pitchFamily="34" charset="0"/>
-                <a:ea typeface="JetBrains Mono" pitchFamily="34" charset="-122"/>
-                <a:cs typeface="JetBrains Mono" pitchFamily="34" charset="-120"/>
-              </a:rPr>
               <a:t>MANDATORY 02 // EXPECTED OUTCOME + PROPOSED SOLUTION</a:t>
             </a:r>
             <a:endParaRPr lang="en-US" sz="1300" dirty="0"/>
@@ -6220,14 +5684,6 @@
               <a:buNone/>
             </a:pPr>
             <a:r>
-              <a:rPr lang="en-US" altLang="en-US" sz="1200" dirty="0">
-                <a:solidFill>
-                  <a:srgbClr val="8B9BB4"/>
-                </a:solidFill>
-                <a:latin typeface="JetBrains Mono" pitchFamily="34" charset="0"/>
-                <a:ea typeface="JetBrains Mono" pitchFamily="34" charset="-122"/>
-                <a:cs typeface="JetBrains Mono" pitchFamily="34" charset="-120"/>
-              </a:rPr>
               <a:t>NEXUS 2026</a:t>
             </a:r>
             <a:endParaRPr lang="en-US" sz="1200" dirty="0"/>
@@ -6259,14 +5715,6 @@
               <a:buNone/>
             </a:pPr>
             <a:r>
-              <a:rPr lang="en-US" altLang="en-US" sz="4300" dirty="0">
-                <a:solidFill>
-                  <a:srgbClr val="FFFFFF"/>
-                </a:solidFill>
-                <a:latin typeface="Space Grotesk" pitchFamily="34" charset="0"/>
-                <a:ea typeface="Space Grotesk" pitchFamily="34" charset="-122"/>
-                <a:cs typeface="Space Grotesk" pitchFamily="34" charset="-120"/>
-              </a:rPr>
               <a:t>AegisNexus converts signals into one defensible decision</a:t>
             </a:r>
             <a:endParaRPr lang="en-US" sz="4300" dirty="0"/>
@@ -6298,14 +5746,6 @@
               <a:buNone/>
             </a:pPr>
             <a:r>
-              <a:rPr lang="en-US" altLang="en-US" sz="1800" dirty="0">
-                <a:solidFill>
-                  <a:srgbClr val="8B9BB4"/>
-                </a:solidFill>
-                <a:latin typeface="Inter" pitchFamily="34" charset="0"/>
-                <a:ea typeface="Inter" pitchFamily="34" charset="-122"/>
-                <a:cs typeface="Inter" pitchFamily="34" charset="-120"/>
-              </a:rPr>
               <a:t>Multiple signals. One explainable risk decision. Safe human-controlled response.</a:t>
             </a:r>
             <a:endParaRPr lang="en-US" sz="1800" dirty="0"/>
@@ -6336,6 +5776,10 @@
             <a:prstDash val="solid"/>
           </a:ln>
         </p:spPr>
+        <p:txBody>
+          <a:bodyPr/>
+          <a:p/>
+        </p:txBody>
       </p:sp>
       <p:pic>
         <p:nvPicPr>
@@ -6386,14 +5830,6 @@
               <a:buNone/>
             </a:pPr>
             <a:r>
-              <a:rPr lang="en-US" altLang="en-US" sz="2200" dirty="0">
-                <a:solidFill>
-                  <a:srgbClr val="FFFFFF"/>
-                </a:solidFill>
-                <a:latin typeface="Space Grotesk" pitchFamily="34" charset="0"/>
-                <a:ea typeface="Space Grotesk" pitchFamily="34" charset="-122"/>
-                <a:cs typeface="Space Grotesk" pitchFamily="34" charset="-120"/>
-              </a:rPr>
               <a:t>Phishing Intelligence</a:t>
             </a:r>
             <a:endParaRPr lang="en-US" sz="2200" dirty="0"/>
@@ -6425,14 +5861,6 @@
               <a:buNone/>
             </a:pPr>
             <a:r>
-              <a:rPr lang="en-US" altLang="en-US" sz="1600" dirty="0">
-                <a:solidFill>
-                  <a:srgbClr val="8B9BB4"/>
-                </a:solidFill>
-                <a:latin typeface="Inter" pitchFamily="34" charset="0"/>
-                <a:ea typeface="Inter" pitchFamily="34" charset="-122"/>
-                <a:cs typeface="Inter" pitchFamily="34" charset="-120"/>
-              </a:rPr>
               <a:t>Intent, sender, URL, attachment, and urgency checks.</a:t>
             </a:r>
             <a:endParaRPr lang="en-US" sz="1600" dirty="0"/>
@@ -6463,6 +5891,10 @@
             <a:prstDash val="solid"/>
           </a:ln>
         </p:spPr>
+        <p:txBody>
+          <a:bodyPr/>
+          <a:p/>
+        </p:txBody>
       </p:sp>
       <p:pic>
         <p:nvPicPr>
@@ -6513,14 +5945,6 @@
               <a:buNone/>
             </a:pPr>
             <a:r>
-              <a:rPr lang="en-US" altLang="en-US" sz="2200" dirty="0">
-                <a:solidFill>
-                  <a:srgbClr val="FFFFFF"/>
-                </a:solidFill>
-                <a:latin typeface="Space Grotesk" pitchFamily="34" charset="0"/>
-                <a:ea typeface="Space Grotesk" pitchFamily="34" charset="-122"/>
-                <a:cs typeface="Space Grotesk" pitchFamily="34" charset="-120"/>
-              </a:rPr>
               <a:t>Deepfake Analysis</a:t>
             </a:r>
             <a:endParaRPr lang="en-US" sz="2200" dirty="0"/>
@@ -6552,14 +5976,6 @@
               <a:buNone/>
             </a:pPr>
             <a:r>
-              <a:rPr lang="en-US" altLang="en-US" sz="1600" dirty="0">
-                <a:solidFill>
-                  <a:srgbClr val="8B9BB4"/>
-                </a:solidFill>
-                <a:latin typeface="Inter" pitchFamily="34" charset="0"/>
-                <a:ea typeface="Inter" pitchFamily="34" charset="-122"/>
-                <a:cs typeface="Inter" pitchFamily="34" charset="-120"/>
-              </a:rPr>
               <a:t>Voice mismatch, replay clues, facial and lip-sync indicators.</a:t>
             </a:r>
             <a:endParaRPr lang="en-US" sz="1600" dirty="0"/>
@@ -6590,6 +6006,10 @@
             <a:prstDash val="solid"/>
           </a:ln>
         </p:spPr>
+        <p:txBody>
+          <a:bodyPr/>
+          <a:p/>
+        </p:txBody>
       </p:sp>
       <p:pic>
         <p:nvPicPr>
@@ -6640,14 +6060,6 @@
               <a:buNone/>
             </a:pPr>
             <a:r>
-              <a:rPr lang="en-US" altLang="en-US" sz="2200" dirty="0">
-                <a:solidFill>
-                  <a:srgbClr val="FFFFFF"/>
-                </a:solidFill>
-                <a:latin typeface="Space Grotesk" pitchFamily="34" charset="0"/>
-                <a:ea typeface="Space Grotesk" pitchFamily="34" charset="-122"/>
-                <a:cs typeface="Space Grotesk" pitchFamily="34" charset="-120"/>
-              </a:rPr>
               <a:t>Executive Digital Twin</a:t>
             </a:r>
             <a:endParaRPr lang="en-US" sz="2200" dirty="0"/>
@@ -6679,14 +6091,6 @@
               <a:buNone/>
             </a:pPr>
             <a:r>
-              <a:rPr lang="en-US" altLang="en-US" sz="1600" dirty="0">
-                <a:solidFill>
-                  <a:srgbClr val="8B9BB4"/>
-                </a:solidFill>
-                <a:latin typeface="Inter" pitchFamily="34" charset="0"/>
-                <a:ea typeface="Inter" pitchFamily="34" charset="-122"/>
-                <a:cs typeface="Inter" pitchFamily="34" charset="-120"/>
-              </a:rPr>
               <a:t>Approved channels, behavior, and transaction patterns.</a:t>
             </a:r>
             <a:endParaRPr lang="en-US" sz="1600" dirty="0"/>
@@ -6717,6 +6121,10 @@
             <a:prstDash val="solid"/>
           </a:ln>
         </p:spPr>
+        <p:txBody>
+          <a:bodyPr/>
+          <a:p/>
+        </p:txBody>
       </p:sp>
       <p:pic>
         <p:nvPicPr>
@@ -6767,14 +6175,6 @@
               <a:buNone/>
             </a:pPr>
             <a:r>
-              <a:rPr lang="en-US" altLang="en-US" sz="2200" dirty="0">
-                <a:solidFill>
-                  <a:srgbClr val="FFFFFF"/>
-                </a:solidFill>
-                <a:latin typeface="Space Grotesk" pitchFamily="34" charset="0"/>
-                <a:ea typeface="Space Grotesk" pitchFamily="34" charset="-122"/>
-                <a:cs typeface="Space Grotesk" pitchFamily="34" charset="-120"/>
-              </a:rPr>
               <a:t>Threat + Network Context</a:t>
             </a:r>
             <a:endParaRPr lang="en-US" sz="2200" dirty="0"/>
@@ -6806,14 +6206,6 @@
               <a:buNone/>
             </a:pPr>
             <a:r>
-              <a:rPr lang="en-US" altLang="en-US" sz="1600" dirty="0">
-                <a:solidFill>
-                  <a:srgbClr val="8B9BB4"/>
-                </a:solidFill>
-                <a:latin typeface="Inter" pitchFamily="34" charset="0"/>
-                <a:ea typeface="Inter" pitchFamily="34" charset="-122"/>
-                <a:cs typeface="Inter" pitchFamily="34" charset="-120"/>
-              </a:rPr>
               <a:t>Domains, IPs, devices, DNS activity, and policy signals.</a:t>
             </a:r>
             <a:endParaRPr lang="en-US" sz="1600" dirty="0"/>
@@ -6844,6 +6236,10 @@
             <a:prstDash val="solid"/>
           </a:ln>
         </p:spPr>
+        <p:txBody>
+          <a:bodyPr/>
+          <a:p/>
+        </p:txBody>
       </p:sp>
       <p:pic>
         <p:nvPicPr>
@@ -6894,14 +6290,6 @@
               <a:buNone/>
             </a:pPr>
             <a:r>
-              <a:rPr lang="en-US" altLang="en-US" sz="2200" dirty="0">
-                <a:solidFill>
-                  <a:srgbClr val="FFFFFF"/>
-                </a:solidFill>
-                <a:latin typeface="Space Grotesk" pitchFamily="34" charset="0"/>
-                <a:ea typeface="Space Grotesk" pitchFamily="34" charset="-122"/>
-                <a:cs typeface="Space Grotesk" pitchFamily="34" charset="-120"/>
-              </a:rPr>
               <a:t>AI Attack Graph</a:t>
             </a:r>
             <a:endParaRPr lang="en-US" sz="2200" dirty="0"/>
@@ -6933,14 +6321,6 @@
               <a:buNone/>
             </a:pPr>
             <a:r>
-              <a:rPr lang="en-US" altLang="en-US" sz="1600" dirty="0">
-                <a:solidFill>
-                  <a:srgbClr val="8B9BB4"/>
-                </a:solidFill>
-                <a:latin typeface="Inter" pitchFamily="34" charset="0"/>
-                <a:ea typeface="Inter" pitchFamily="34" charset="-122"/>
-                <a:cs typeface="Inter" pitchFamily="34" charset="-120"/>
-              </a:rPr>
               <a:t>Links people, URLs, phones, devices, and past alerts.</a:t>
             </a:r>
             <a:endParaRPr lang="en-US" sz="1600" dirty="0"/>
@@ -6971,6 +6351,10 @@
             <a:prstDash val="solid"/>
           </a:ln>
         </p:spPr>
+        <p:txBody>
+          <a:bodyPr/>
+          <a:p/>
+        </p:txBody>
       </p:sp>
       <p:pic>
         <p:nvPicPr>
@@ -7021,14 +6405,6 @@
               <a:buNone/>
             </a:pPr>
             <a:r>
-              <a:rPr lang="en-US" altLang="en-US" sz="2200" dirty="0">
-                <a:solidFill>
-                  <a:srgbClr val="FFFFFF"/>
-                </a:solidFill>
-                <a:latin typeface="Space Grotesk" pitchFamily="34" charset="0"/>
-                <a:ea typeface="Space Grotesk" pitchFamily="34" charset="-122"/>
-                <a:cs typeface="Space Grotesk" pitchFamily="34" charset="-120"/>
-              </a:rPr>
               <a:t>Explainable Risk + Response</a:t>
             </a:r>
             <a:endParaRPr lang="en-US" sz="2200" dirty="0"/>
@@ -7060,14 +6436,6 @@
               <a:buNone/>
             </a:pPr>
             <a:r>
-              <a:rPr lang="en-US" altLang="en-US" sz="1600" dirty="0">
-                <a:solidFill>
-                  <a:srgbClr val="8B9BB4"/>
-                </a:solidFill>
-                <a:latin typeface="Inter" pitchFamily="34" charset="0"/>
-                <a:ea typeface="Inter" pitchFamily="34" charset="-122"/>
-                <a:cs typeface="Inter" pitchFamily="34" charset="-120"/>
-              </a:rPr>
               <a:t>Score, evidence, confidence, action, and analyst approval.</a:t>
             </a:r>
             <a:endParaRPr lang="en-US" sz="1600" dirty="0"/>
@@ -7100,6 +6468,10 @@
             <a:prstDash val="solid"/>
           </a:ln>
         </p:spPr>
+        <p:txBody>
+          <a:bodyPr/>
+          <a:p/>
+        </p:txBody>
       </p:sp>
       <p:sp>
         <p:nvSpPr>
@@ -7126,14 +6498,6 @@
               <a:buNone/>
             </a:pPr>
             <a:r>
-              <a:rPr lang="en-US" altLang="en-US" sz="1200" dirty="0">
-                <a:solidFill>
-                  <a:srgbClr val="00E5FF"/>
-                </a:solidFill>
-                <a:latin typeface="JetBrains Mono" pitchFamily="34" charset="0"/>
-                <a:ea typeface="JetBrains Mono" pitchFamily="34" charset="-122"/>
-                <a:cs typeface="JetBrains Mono" pitchFamily="34" charset="-120"/>
-              </a:rPr>
               <a:t>EXPECTED OUTPUT</a:t>
             </a:r>
             <a:endParaRPr lang="en-US" sz="1200" dirty="0"/>
@@ -7165,14 +6529,6 @@
               <a:buNone/>
             </a:pPr>
             <a:r>
-              <a:rPr lang="en-US" altLang="en-US" sz="1600" dirty="0">
-                <a:solidFill>
-                  <a:srgbClr val="FFFFFF"/>
-                </a:solidFill>
-                <a:latin typeface="Inter" pitchFamily="34" charset="0"/>
-                <a:ea typeface="Inter" pitchFamily="34" charset="-122"/>
-                <a:cs typeface="Inter" pitchFamily="34" charset="-120"/>
-              </a:rPr>
               <a:t>Risk score · confidence · evidence · attack graph · recommended response</a:t>
             </a:r>
             <a:endParaRPr lang="en-US" sz="1600" dirty="0"/>
@@ -7204,14 +6560,6 @@
               <a:buNone/>
             </a:pPr>
             <a:r>
-              <a:rPr lang="en-US" altLang="en-US" sz="1200" dirty="0">
-                <a:solidFill>
-                  <a:srgbClr val="8B9BB4"/>
-                </a:solidFill>
-                <a:latin typeface="JetBrains Mono" pitchFamily="34" charset="0"/>
-                <a:ea typeface="JetBrains Mono" pitchFamily="34" charset="-122"/>
-                <a:cs typeface="JetBrains Mono" pitchFamily="34" charset="-120"/>
-              </a:rPr>
               <a:t>SEC-04 // SOLUTION</a:t>
             </a:r>
             <a:endParaRPr lang="en-US" sz="1200" dirty="0"/>
@@ -7274,6 +6622,10 @@
             <a:prstDash val="solid"/>
           </a:ln>
         </p:spPr>
+        <p:txBody>
+          <a:bodyPr/>
+          <a:p/>
+        </p:txBody>
       </p:sp>
       <p:sp>
         <p:nvSpPr>
@@ -7300,14 +6652,6 @@
               <a:buNone/>
             </a:pPr>
             <a:r>
-              <a:rPr lang="en-US" altLang="en-US" sz="1300" dirty="0">
-                <a:solidFill>
-                  <a:srgbClr val="00E5FF"/>
-                </a:solidFill>
-                <a:latin typeface="JetBrains Mono" pitchFamily="34" charset="0"/>
-                <a:ea typeface="JetBrains Mono" pitchFamily="34" charset="-122"/>
-                <a:cs typeface="JetBrains Mono" pitchFamily="34" charset="-120"/>
-              </a:rPr>
               <a:t>MANDATORY 03 // WORKFLOW DIAGRAM</a:t>
             </a:r>
             <a:endParaRPr lang="en-US" sz="1300" dirty="0"/>
@@ -7339,14 +6683,6 @@
               <a:buNone/>
             </a:pPr>
             <a:r>
-              <a:rPr lang="en-US" altLang="en-US" sz="1200" dirty="0">
-                <a:solidFill>
-                  <a:srgbClr val="8B9BB4"/>
-                </a:solidFill>
-                <a:latin typeface="JetBrains Mono" pitchFamily="34" charset="0"/>
-                <a:ea typeface="JetBrains Mono" pitchFamily="34" charset="-122"/>
-                <a:cs typeface="JetBrains Mono" pitchFamily="34" charset="-120"/>
-              </a:rPr>
               <a:t>NEXUS 2026</a:t>
             </a:r>
             <a:endParaRPr lang="en-US" sz="1200" dirty="0"/>
@@ -7378,14 +6714,6 @@
               <a:buNone/>
             </a:pPr>
             <a:r>
-              <a:rPr lang="en-US" altLang="en-US" sz="4500" dirty="0">
-                <a:solidFill>
-                  <a:srgbClr val="FFFFFF"/>
-                </a:solidFill>
-                <a:latin typeface="Space Grotesk" pitchFamily="34" charset="0"/>
-                <a:ea typeface="Space Grotesk" pitchFamily="34" charset="-122"/>
-                <a:cs typeface="Space Grotesk" pitchFamily="34" charset="-120"/>
-              </a:rPr>
               <a:t>The real-time defense workflow</a:t>
             </a:r>
             <a:endParaRPr lang="en-US" sz="4500" dirty="0"/>
@@ -7417,14 +6745,6 @@
               <a:buNone/>
             </a:pPr>
             <a:r>
-              <a:rPr lang="en-US" altLang="en-US" sz="1900" dirty="0">
-                <a:solidFill>
-                  <a:srgbClr val="8B9BB4"/>
-                </a:solidFill>
-                <a:latin typeface="Inter" pitchFamily="34" charset="0"/>
-                <a:ea typeface="Inter" pitchFamily="34" charset="-122"/>
-                <a:cs typeface="Inter" pitchFamily="34" charset="-120"/>
-              </a:rPr>
               <a:t>From a suspicious event to an explainable, human-controlled response.</a:t>
             </a:r>
             <a:endParaRPr lang="en-US" sz="1900" dirty="0"/>
@@ -7455,6 +6775,10 @@
             <a:prstDash val="solid"/>
           </a:ln>
         </p:spPr>
+        <p:txBody>
+          <a:bodyPr/>
+          <a:p/>
+        </p:txBody>
       </p:sp>
       <p:sp>
         <p:nvSpPr>
@@ -7477,6 +6801,10 @@
             <a:prstDash val="solid"/>
           </a:ln>
         </p:spPr>
+        <p:txBody>
+          <a:bodyPr/>
+          <a:p/>
+        </p:txBody>
       </p:sp>
       <p:pic>
         <p:nvPicPr>
@@ -7527,14 +6855,6 @@
               <a:buNone/>
             </a:pPr>
             <a:r>
-              <a:rPr lang="en-US" altLang="en-US" sz="2000" dirty="0">
-                <a:solidFill>
-                  <a:srgbClr val="FFFFFF"/>
-                </a:solidFill>
-                <a:latin typeface="Space Grotesk" pitchFamily="34" charset="0"/>
-                <a:ea typeface="Space Grotesk" pitchFamily="34" charset="-122"/>
-                <a:cs typeface="Space Grotesk" pitchFamily="34" charset="-120"/>
-              </a:rPr>
               <a:t>Multimodal input</a:t>
             </a:r>
             <a:endParaRPr lang="en-US" sz="2000" dirty="0"/>
@@ -7566,14 +6886,6 @@
               <a:buNone/>
             </a:pPr>
             <a:r>
-              <a:rPr lang="en-US" altLang="en-US" sz="1500" dirty="0">
-                <a:solidFill>
-                  <a:srgbClr val="8B9BB4"/>
-                </a:solidFill>
-                <a:latin typeface="Inter" pitchFamily="34" charset="0"/>
-                <a:ea typeface="Inter" pitchFamily="34" charset="-122"/>
-                <a:cs typeface="Inter" pitchFamily="34" charset="-120"/>
-              </a:rPr>
               <a:t>Email · voice · video · network</a:t>
             </a:r>
             <a:endParaRPr lang="en-US" sz="1500" dirty="0"/>
@@ -7601,6 +6913,10 @@
             <a:prstDash val="solid"/>
           </a:ln>
         </p:spPr>
+        <p:txBody>
+          <a:bodyPr/>
+          <a:p/>
+        </p:txBody>
       </p:sp>
       <p:sp>
         <p:nvSpPr>
@@ -7626,6 +6942,10 @@
             <a:prstDash val="solid"/>
           </a:ln>
         </p:spPr>
+        <p:txBody>
+          <a:bodyPr/>
+          <a:p/>
+        </p:txBody>
       </p:sp>
       <p:sp>
         <p:nvSpPr>
@@ -7648,6 +6968,10 @@
             <a:prstDash val="solid"/>
           </a:ln>
         </p:spPr>
+        <p:txBody>
+          <a:bodyPr/>
+          <a:p/>
+        </p:txBody>
       </p:sp>
       <p:pic>
         <p:nvPicPr>
@@ -7698,14 +7022,6 @@
               <a:buNone/>
             </a:pPr>
             <a:r>
-              <a:rPr lang="en-US" altLang="en-US" sz="2000" dirty="0">
-                <a:solidFill>
-                  <a:srgbClr val="FFFFFF"/>
-                </a:solidFill>
-                <a:latin typeface="Space Grotesk" pitchFamily="34" charset="0"/>
-                <a:ea typeface="Space Grotesk" pitchFamily="34" charset="-122"/>
-                <a:cs typeface="Space Grotesk" pitchFamily="34" charset="-120"/>
-              </a:rPr>
               <a:t>Evidence ingest</a:t>
             </a:r>
             <a:endParaRPr lang="en-US" sz="2000" dirty="0"/>
@@ -7737,14 +7053,6 @@
               <a:buNone/>
             </a:pPr>
             <a:r>
-              <a:rPr lang="en-US" altLang="en-US" sz="1500" dirty="0">
-                <a:solidFill>
-                  <a:srgbClr val="8B9BB4"/>
-                </a:solidFill>
-                <a:latin typeface="Inter" pitchFamily="34" charset="0"/>
-                <a:ea typeface="Inter" pitchFamily="34" charset="-122"/>
-                <a:cs typeface="Inter" pitchFamily="34" charset="-120"/>
-              </a:rPr>
               <a:t>Text · URLs · metadata · media features</a:t>
             </a:r>
             <a:endParaRPr lang="en-US" sz="1500" dirty="0"/>
@@ -7772,6 +7080,10 @@
             <a:prstDash val="solid"/>
           </a:ln>
         </p:spPr>
+        <p:txBody>
+          <a:bodyPr/>
+          <a:p/>
+        </p:txBody>
       </p:sp>
       <p:sp>
         <p:nvSpPr>
@@ -7797,6 +7109,10 @@
             <a:prstDash val="solid"/>
           </a:ln>
         </p:spPr>
+        <p:txBody>
+          <a:bodyPr/>
+          <a:p/>
+        </p:txBody>
       </p:sp>
       <p:sp>
         <p:nvSpPr>
@@ -7819,6 +7135,10 @@
             <a:prstDash val="solid"/>
           </a:ln>
         </p:spPr>
+        <p:txBody>
+          <a:bodyPr/>
+          <a:p/>
+        </p:txBody>
       </p:sp>
       <p:pic>
         <p:nvPicPr>
@@ -7869,14 +7189,6 @@
               <a:buNone/>
             </a:pPr>
             <a:r>
-              <a:rPr lang="en-US" altLang="en-US" sz="2000" dirty="0">
-                <a:solidFill>
-                  <a:srgbClr val="FFFFFF"/>
-                </a:solidFill>
-                <a:latin typeface="Space Grotesk" pitchFamily="34" charset="0"/>
-                <a:ea typeface="Space Grotesk" pitchFamily="34" charset="-122"/>
-                <a:cs typeface="Space Grotesk" pitchFamily="34" charset="-120"/>
-              </a:rPr>
               <a:t>Parallel verification</a:t>
             </a:r>
             <a:endParaRPr lang="en-US" sz="2000" dirty="0"/>
@@ -7908,14 +7220,6 @@
               <a:buNone/>
             </a:pPr>
             <a:r>
-              <a:rPr lang="en-US" altLang="en-US" sz="1500" dirty="0">
-                <a:solidFill>
-                  <a:srgbClr val="8B9BB4"/>
-                </a:solidFill>
-                <a:latin typeface="Inter" pitchFamily="34" charset="0"/>
-                <a:ea typeface="Inter" pitchFamily="34" charset="-122"/>
-                <a:cs typeface="Inter" pitchFamily="34" charset="-120"/>
-              </a:rPr>
               <a:t>Phishing · deepfake · digital twin · threat checks</a:t>
             </a:r>
             <a:endParaRPr lang="en-US" sz="1500" dirty="0"/>
@@ -7943,6 +7247,10 @@
             <a:prstDash val="solid"/>
           </a:ln>
         </p:spPr>
+        <p:txBody>
+          <a:bodyPr/>
+          <a:p/>
+        </p:txBody>
       </p:sp>
       <p:sp>
         <p:nvSpPr>
@@ -7968,6 +7276,10 @@
             <a:prstDash val="solid"/>
           </a:ln>
         </p:spPr>
+        <p:txBody>
+          <a:bodyPr/>
+          <a:p/>
+        </p:txBody>
       </p:sp>
       <p:sp>
         <p:nvSpPr>
@@ -7990,6 +7302,10 @@
             <a:prstDash val="solid"/>
           </a:ln>
         </p:spPr>
+        <p:txBody>
+          <a:bodyPr/>
+          <a:p/>
+        </p:txBody>
       </p:sp>
       <p:pic>
         <p:nvPicPr>
@@ -8040,14 +7356,6 @@
               <a:buNone/>
             </a:pPr>
             <a:r>
-              <a:rPr lang="en-US" altLang="en-US" sz="2000" dirty="0">
-                <a:solidFill>
-                  <a:srgbClr val="FFFFFF"/>
-                </a:solidFill>
-                <a:latin typeface="Space Grotesk" pitchFamily="34" charset="0"/>
-                <a:ea typeface="Space Grotesk" pitchFamily="34" charset="-122"/>
-                <a:cs typeface="Space Grotesk" pitchFamily="34" charset="-120"/>
-              </a:rPr>
               <a:t>AI Attack Graph</a:t>
             </a:r>
             <a:endParaRPr lang="en-US" sz="2000" dirty="0"/>
@@ -8079,14 +7387,6 @@
               <a:buNone/>
             </a:pPr>
             <a:r>
-              <a:rPr lang="en-US" altLang="en-US" sz="1500" dirty="0">
-                <a:solidFill>
-                  <a:srgbClr val="8B9BB4"/>
-                </a:solidFill>
-                <a:latin typeface="Inter" pitchFamily="34" charset="0"/>
-                <a:ea typeface="Inter" pitchFamily="34" charset="-122"/>
-                <a:cs typeface="Inter" pitchFamily="34" charset="-120"/>
-              </a:rPr>
               <a:t>Connect identities, assets, and prior alerts</a:t>
             </a:r>
             <a:endParaRPr lang="en-US" sz="1500" dirty="0"/>
@@ -8114,6 +7414,10 @@
             <a:prstDash val="solid"/>
           </a:ln>
         </p:spPr>
+        <p:txBody>
+          <a:bodyPr/>
+          <a:p/>
+        </p:txBody>
       </p:sp>
       <p:sp>
         <p:nvSpPr>
@@ -8139,6 +7443,10 @@
             <a:prstDash val="solid"/>
           </a:ln>
         </p:spPr>
+        <p:txBody>
+          <a:bodyPr/>
+          <a:p/>
+        </p:txBody>
       </p:sp>
       <p:sp>
         <p:nvSpPr>
@@ -8161,6 +7469,10 @@
             <a:prstDash val="solid"/>
           </a:ln>
         </p:spPr>
+        <p:txBody>
+          <a:bodyPr/>
+          <a:p/>
+        </p:txBody>
       </p:sp>
       <p:pic>
         <p:nvPicPr>
@@ -8211,14 +7523,6 @@
               <a:buNone/>
             </a:pPr>
             <a:r>
-              <a:rPr lang="en-US" altLang="en-US" sz="2000" dirty="0">
-                <a:solidFill>
-                  <a:srgbClr val="FFFFFF"/>
-                </a:solidFill>
-                <a:latin typeface="Space Grotesk" pitchFamily="34" charset="0"/>
-                <a:ea typeface="Space Grotesk" pitchFamily="34" charset="-122"/>
-                <a:cs typeface="Space Grotesk" pitchFamily="34" charset="-120"/>
-              </a:rPr>
               <a:t>Risk + response</a:t>
             </a:r>
             <a:endParaRPr lang="en-US" sz="2000" dirty="0"/>
@@ -8250,14 +7554,6 @@
               <a:buNone/>
             </a:pPr>
             <a:r>
-              <a:rPr lang="en-US" altLang="en-US" sz="1500" dirty="0">
-                <a:solidFill>
-                  <a:srgbClr val="8B9BB4"/>
-                </a:solidFill>
-                <a:latin typeface="Inter" pitchFamily="34" charset="0"/>
-                <a:ea typeface="Inter" pitchFamily="34" charset="-122"/>
-                <a:cs typeface="Inter" pitchFamily="34" charset="-120"/>
-              </a:rPr>
               <a:t>Explain score · select safe playbook · approve</a:t>
             </a:r>
             <a:endParaRPr lang="en-US" sz="1500" dirty="0"/>
@@ -8286,6 +7582,10 @@
             <a:tailEnd type="triangle"/>
           </a:ln>
         </p:spPr>
+        <p:txBody>
+          <a:bodyPr/>
+          <a:p/>
+        </p:txBody>
       </p:sp>
       <p:sp>
         <p:nvSpPr>
@@ -8313,6 +7613,10 @@
             <a:prstDash val="solid"/>
           </a:ln>
         </p:spPr>
+        <p:txBody>
+          <a:bodyPr/>
+          <a:p/>
+        </p:txBody>
       </p:sp>
       <p:pic>
         <p:nvPicPr>
@@ -8363,14 +7667,6 @@
               <a:buNone/>
             </a:pPr>
             <a:r>
-              <a:rPr lang="en-US" altLang="en-US" sz="2100" dirty="0">
-                <a:solidFill>
-                  <a:srgbClr val="FFFFFF"/>
-                </a:solidFill>
-                <a:latin typeface="Space Grotesk" pitchFamily="34" charset="0"/>
-                <a:ea typeface="Space Grotesk" pitchFamily="34" charset="-122"/>
-                <a:cs typeface="Space Grotesk" pitchFamily="34" charset="-120"/>
-              </a:rPr>
               <a:t>Security Dashboard + AI Copilot</a:t>
             </a:r>
             <a:endParaRPr lang="en-US" sz="2100" dirty="0"/>
@@ -8402,14 +7698,6 @@
               <a:buNone/>
             </a:pPr>
             <a:r>
-              <a:rPr lang="en-US" altLang="en-US" sz="1600" dirty="0">
-                <a:solidFill>
-                  <a:srgbClr val="8B9BB4"/>
-                </a:solidFill>
-                <a:latin typeface="Inter" pitchFamily="34" charset="0"/>
-                <a:ea typeface="Inter" pitchFamily="34" charset="-122"/>
-                <a:cs typeface="Inter" pitchFamily="34" charset="-120"/>
-              </a:rPr>
               <a:t>Risk score · evidence · attack graph · reason codes · recommended action</a:t>
             </a:r>
             <a:endParaRPr lang="en-US" sz="1600" dirty="0"/>
@@ -8441,14 +7729,6 @@
               <a:buNone/>
             </a:pPr>
             <a:r>
-              <a:rPr lang="en-US" altLang="en-US" sz="1200" dirty="0">
-                <a:solidFill>
-                  <a:srgbClr val="8B9BB4"/>
-                </a:solidFill>
-                <a:latin typeface="JetBrains Mono" pitchFamily="34" charset="0"/>
-                <a:ea typeface="JetBrains Mono" pitchFamily="34" charset="-122"/>
-                <a:cs typeface="JetBrains Mono" pitchFamily="34" charset="-120"/>
-              </a:rPr>
               <a:t>SEC-05 // WORKFLOW</a:t>
             </a:r>
             <a:endParaRPr lang="en-US" sz="1200" dirty="0"/>
@@ -8511,6 +7791,10 @@
             <a:prstDash val="solid"/>
           </a:ln>
         </p:spPr>
+        <p:txBody>
+          <a:bodyPr/>
+          <a:p/>
+        </p:txBody>
       </p:sp>
       <p:sp>
         <p:nvSpPr>
@@ -8537,14 +7821,6 @@
               <a:buNone/>
             </a:pPr>
             <a:r>
-              <a:rPr lang="en-US" altLang="en-US" sz="1300" dirty="0">
-                <a:solidFill>
-                  <a:srgbClr val="00E5FF"/>
-                </a:solidFill>
-                <a:latin typeface="JetBrains Mono" pitchFamily="34" charset="0"/>
-                <a:ea typeface="JetBrains Mono" pitchFamily="34" charset="-122"/>
-                <a:cs typeface="JetBrains Mono" pitchFamily="34" charset="-120"/>
-              </a:rPr>
               <a:t>05 // CORRELATION LAYER</a:t>
             </a:r>
             <a:endParaRPr lang="en-US" sz="1300" dirty="0"/>
@@ -8576,14 +7852,6 @@
               <a:buNone/>
             </a:pPr>
             <a:r>
-              <a:rPr lang="en-US" altLang="en-US" sz="1200" dirty="0">
-                <a:solidFill>
-                  <a:srgbClr val="8B9BB4"/>
-                </a:solidFill>
-                <a:latin typeface="JetBrains Mono" pitchFamily="34" charset="0"/>
-                <a:ea typeface="JetBrains Mono" pitchFamily="34" charset="-122"/>
-                <a:cs typeface="JetBrains Mono" pitchFamily="34" charset="-120"/>
-              </a:rPr>
               <a:t>NEXUS 2026</a:t>
             </a:r>
             <a:endParaRPr lang="en-US" sz="1200" dirty="0"/>
@@ -8618,14 +7886,6 @@
               <a:buNone/>
             </a:pPr>
             <a:r>
-              <a:rPr lang="en-US" altLang="en-US" sz="4400" dirty="0">
-                <a:solidFill>
-                  <a:srgbClr val="FFFFFF"/>
-                </a:solidFill>
-                <a:latin typeface="Space Grotesk" pitchFamily="34" charset="0"/>
-                <a:ea typeface="Space Grotesk" pitchFamily="34" charset="-122"/>
-                <a:cs typeface="Space Grotesk" pitchFamily="34" charset="-120"/>
-              </a:rPr>
               <a:t>The attack graph is the system’s memory</a:t>
             </a:r>
             <a:endParaRPr lang="en-US" sz="4400" dirty="0"/>
@@ -8660,14 +7920,6 @@
               <a:buNone/>
             </a:pPr>
             <a:r>
-              <a:rPr lang="en-US" altLang="en-US" sz="1900" dirty="0">
-                <a:solidFill>
-                  <a:srgbClr val="8B9BB4"/>
-                </a:solidFill>
-                <a:latin typeface="Inter" pitchFamily="34" charset="0"/>
-                <a:ea typeface="Inter" pitchFamily="34" charset="-122"/>
-                <a:cs typeface="Inter" pitchFamily="34" charset="-120"/>
-              </a:rPr>
               <a:t>One event is uncertain. Connected evidence is actionable.</a:t>
             </a:r>
             <a:endParaRPr lang="en-US" sz="1900" dirty="0"/>
@@ -8723,14 +7975,6 @@
               <a:buNone/>
             </a:pPr>
             <a:r>
-              <a:rPr lang="en-US" altLang="en-US" sz="2100" dirty="0">
-                <a:solidFill>
-                  <a:srgbClr val="FFFFFF"/>
-                </a:solidFill>
-                <a:latin typeface="Space Grotesk" pitchFamily="34" charset="0"/>
-                <a:ea typeface="Space Grotesk" pitchFamily="34" charset="-122"/>
-                <a:cs typeface="Space Grotesk" pitchFamily="34" charset="-120"/>
-              </a:rPr>
               <a:t>Correlation</a:t>
             </a:r>
             <a:endParaRPr lang="en-US" sz="2100" dirty="0"/>
@@ -8762,14 +8006,6 @@
               <a:buNone/>
             </a:pPr>
             <a:r>
-              <a:rPr lang="en-US" altLang="en-US" sz="1600" dirty="0">
-                <a:solidFill>
-                  <a:srgbClr val="8B9BB4"/>
-                </a:solidFill>
-                <a:latin typeface="Inter" pitchFamily="34" charset="0"/>
-                <a:ea typeface="Inter" pitchFamily="34" charset="-122"/>
-                <a:cs typeface="Inter" pitchFamily="34" charset="-120"/>
-              </a:rPr>
               <a:t>Find shared infrastructure, repeated targeting, and campaign overlap.</a:t>
             </a:r>
             <a:endParaRPr lang="en-US" sz="1600" dirty="0"/>
@@ -8825,14 +8061,6 @@
               <a:buNone/>
             </a:pPr>
             <a:r>
-              <a:rPr lang="en-US" altLang="en-US" sz="2100" dirty="0">
-                <a:solidFill>
-                  <a:srgbClr val="FFFFFF"/>
-                </a:solidFill>
-                <a:latin typeface="Space Grotesk" pitchFamily="34" charset="0"/>
-                <a:ea typeface="Space Grotesk" pitchFamily="34" charset="-122"/>
-                <a:cs typeface="Space Grotesk" pitchFamily="34" charset="-120"/>
-              </a:rPr>
               <a:t>Context</a:t>
             </a:r>
             <a:endParaRPr lang="en-US" sz="2100" dirty="0"/>
@@ -8864,14 +8092,6 @@
               <a:buNone/>
             </a:pPr>
             <a:r>
-              <a:rPr lang="en-US" altLang="en-US" sz="1600" dirty="0">
-                <a:solidFill>
-                  <a:srgbClr val="8B9BB4"/>
-                </a:solidFill>
-                <a:latin typeface="Inter" pitchFamily="34" charset="0"/>
-                <a:ea typeface="Inter" pitchFamily="34" charset="-122"/>
-                <a:cs typeface="Inter" pitchFamily="34" charset="-120"/>
-              </a:rPr>
               <a:t>Add identity anomalies and business impact to technical signals.</a:t>
             </a:r>
             <a:endParaRPr lang="en-US" sz="1600" dirty="0"/>
@@ -8927,14 +8147,6 @@
               <a:buNone/>
             </a:pPr>
             <a:r>
-              <a:rPr lang="en-US" altLang="en-US" sz="2100" dirty="0">
-                <a:solidFill>
-                  <a:srgbClr val="FFFFFF"/>
-                </a:solidFill>
-                <a:latin typeface="Space Grotesk" pitchFamily="34" charset="0"/>
-                <a:ea typeface="Space Grotesk" pitchFamily="34" charset="-122"/>
-                <a:cs typeface="Space Grotesk" pitchFamily="34" charset="-120"/>
-              </a:rPr>
               <a:t>Explanation</a:t>
             </a:r>
             <a:endParaRPr lang="en-US" sz="2100" dirty="0"/>
@@ -8966,14 +8178,6 @@
               <a:buNone/>
             </a:pPr>
             <a:r>
-              <a:rPr lang="en-US" altLang="en-US" sz="1600" dirty="0">
-                <a:solidFill>
-                  <a:srgbClr val="8B9BB4"/>
-                </a:solidFill>
-                <a:latin typeface="Inter" pitchFamily="34" charset="0"/>
-                <a:ea typeface="Inter" pitchFamily="34" charset="-122"/>
-                <a:cs typeface="Inter" pitchFamily="34" charset="-120"/>
-              </a:rPr>
               <a:t>Show analysts why the risk score increased and what to do next.</a:t>
             </a:r>
             <a:endParaRPr lang="en-US" sz="1600" dirty="0"/>
@@ -9004,6 +8208,10 @@
             <a:prstDash val="solid"/>
           </a:ln>
         </p:spPr>
+        <p:txBody>
+          <a:bodyPr/>
+          <a:p/>
+        </p:txBody>
       </p:sp>
       <p:pic>
         <p:nvPicPr>
@@ -9053,6 +8261,10 @@
             <a:prstDash val="solid"/>
           </a:ln>
         </p:spPr>
+        <p:txBody>
+          <a:bodyPr/>
+          <a:p/>
+        </p:txBody>
       </p:sp>
       <p:sp>
         <p:nvSpPr>
@@ -9080,6 +8292,10 @@
             <a:prstDash val="solid"/>
           </a:ln>
         </p:spPr>
+        <p:txBody>
+          <a:bodyPr/>
+          <a:p/>
+        </p:txBody>
       </p:sp>
       <p:sp>
         <p:nvSpPr>
@@ -9106,14 +8322,6 @@
               <a:buNone/>
             </a:pPr>
             <a:r>
-              <a:rPr lang="en-US" altLang="en-US" sz="1200" dirty="0">
-                <a:solidFill>
-                  <a:srgbClr val="FFB300"/>
-                </a:solidFill>
-                <a:latin typeface="JetBrains Mono" pitchFamily="34" charset="0"/>
-                <a:ea typeface="JetBrains Mono" pitchFamily="34" charset="-122"/>
-                <a:cs typeface="JetBrains Mono" pitchFamily="34" charset="-120"/>
-              </a:rPr>
               <a:t>CORRELATED INCIDENT</a:t>
             </a:r>
             <a:endParaRPr lang="en-US" sz="1200" dirty="0"/>
@@ -9145,14 +8353,6 @@
               <a:buNone/>
             </a:pPr>
             <a:r>
-              <a:rPr lang="en-US" altLang="en-US" sz="1800" dirty="0">
-                <a:solidFill>
-                  <a:srgbClr val="FFFFFF"/>
-                </a:solidFill>
-                <a:latin typeface="Space Grotesk" pitchFamily="34" charset="0"/>
-                <a:ea typeface="Space Grotesk" pitchFamily="34" charset="-122"/>
-                <a:cs typeface="Space Grotesk" pitchFamily="34" charset="-120"/>
-              </a:rPr>
               <a:t>HIGH-RISK CFO IMPERSONATION</a:t>
             </a:r>
             <a:endParaRPr lang="en-US" sz="1800" dirty="0"/>
@@ -9184,14 +8384,6 @@
               <a:buNone/>
             </a:pPr>
             <a:r>
-              <a:rPr lang="en-US" altLang="en-US" sz="1200" dirty="0">
-                <a:solidFill>
-                  <a:srgbClr val="8B9BB4"/>
-                </a:solidFill>
-                <a:latin typeface="JetBrains Mono" pitchFamily="34" charset="0"/>
-                <a:ea typeface="JetBrains Mono" pitchFamily="34" charset="-122"/>
-                <a:cs typeface="JetBrains Mono" pitchFamily="34" charset="-120"/>
-              </a:rPr>
               <a:t>SEC-06 // ATTACK GRAPH</a:t>
             </a:r>
             <a:endParaRPr lang="en-US" sz="1200" dirty="0"/>
@@ -9284,14 +8476,6 @@
               <a:buNone/>
             </a:pPr>
             <a:r>
-              <a:rPr lang="en-US" altLang="en-US" sz="1300" dirty="0">
-                <a:solidFill>
-                  <a:srgbClr val="00E5FF"/>
-                </a:solidFill>
-                <a:latin typeface="JetBrains Mono" pitchFamily="34" charset="0"/>
-                <a:ea typeface="JetBrains Mono" pitchFamily="34" charset="-122"/>
-                <a:cs typeface="JetBrains Mono" pitchFamily="34" charset="-120"/>
-              </a:rPr>
               <a:t>MANDATORY 04 // TECHNOLOGIES + TOOLS</a:t>
             </a:r>
             <a:endParaRPr lang="en-US" sz="1300" dirty="0"/>
@@ -9323,14 +8507,6 @@
               <a:buNone/>
             </a:pPr>
             <a:r>
-              <a:rPr lang="en-US" altLang="en-US" sz="1200" dirty="0">
-                <a:solidFill>
-                  <a:srgbClr val="8B9BB4"/>
-                </a:solidFill>
-                <a:latin typeface="JetBrains Mono" pitchFamily="34" charset="0"/>
-                <a:ea typeface="JetBrains Mono" pitchFamily="34" charset="-122"/>
-                <a:cs typeface="JetBrains Mono" pitchFamily="34" charset="-120"/>
-              </a:rPr>
               <a:t>NEXUS 2026</a:t>
             </a:r>
             <a:endParaRPr lang="en-US" sz="1200" dirty="0"/>
@@ -9362,14 +8538,6 @@
               <a:buNone/>
             </a:pPr>
             <a:r>
-              <a:rPr lang="en-US" altLang="en-US" sz="4300" dirty="0">
-                <a:solidFill>
-                  <a:srgbClr val="FFFFFF"/>
-                </a:solidFill>
-                <a:latin typeface="Space Grotesk" pitchFamily="34" charset="0"/>
-                <a:ea typeface="Space Grotesk" pitchFamily="34" charset="-122"/>
-                <a:cs typeface="Space Grotesk" pitchFamily="34" charset="-120"/>
-              </a:rPr>
               <a:t>A feasible prototype stack maps directly to the workflow</a:t>
             </a:r>
             <a:endParaRPr lang="en-US" sz="4300" dirty="0"/>
@@ -9401,14 +8569,6 @@
               <a:buNone/>
             </a:pPr>
             <a:r>
-              <a:rPr lang="en-US" altLang="en-US" sz="1800" dirty="0">
-                <a:solidFill>
-                  <a:srgbClr val="8B9BB4"/>
-                </a:solidFill>
-                <a:latin typeface="Inter" pitchFamily="34" charset="0"/>
-                <a:ea typeface="Inter" pitchFamily="34" charset="-122"/>
-                <a:cs typeface="Inter" pitchFamily="34" charset="-120"/>
-              </a:rPr>
               <a:t>Modular by design—each layer can be built, tested, and demonstrated independently.</a:t>
             </a:r>
             <a:endParaRPr lang="en-US" sz="1800" dirty="0"/>
@@ -9493,15 +8653,7 @@
               <a:buNone/>
             </a:pPr>
             <a:r>
-              <a:rPr lang="en-US" altLang="en-US" sz="1900" dirty="0">
-                <a:solidFill>
-                  <a:srgbClr val="FFFFFF"/>
-                </a:solidFill>
-                <a:latin typeface="Space Grotesk" pitchFamily="34" charset="0"/>
-                <a:ea typeface="Space Grotesk" pitchFamily="34" charset="-122"/>
-                <a:cs typeface="Space Grotesk" pitchFamily="34" charset="-120"/>
-              </a:rPr>
-              <a:t>Experience</a:t>
+              <a:t>Experience Layer</a:t>
             </a:r>
             <a:endParaRPr lang="en-US" sz="1900" dirty="0"/>
           </a:p>
@@ -9532,7 +8684,7 @@
               <a:buNone/>
             </a:pPr>
             <a:r>
-              <a:t>React 19 · TypeScript · Vite · Tailwind CSS · SVG Topology</a:t>
+              <a:t>React 19 • TypeScript • Vite • Tailwind CSS • Interactive SVG Topology</a:t>
             </a:r>
             <a:endParaRPr lang="en-US" sz="1700" dirty="0"/>
           </a:p>
@@ -9616,15 +8768,7 @@
               <a:buNone/>
             </a:pPr>
             <a:r>
-              <a:rPr lang="en-US" altLang="en-US" sz="1900" dirty="0">
-                <a:solidFill>
-                  <a:srgbClr val="FFFFFF"/>
-                </a:solidFill>
-                <a:latin typeface="Space Grotesk" pitchFamily="34" charset="0"/>
-                <a:ea typeface="Space Grotesk" pitchFamily="34" charset="-122"/>
-                <a:cs typeface="Space Grotesk" pitchFamily="34" charset="-120"/>
-              </a:rPr>
-              <a:t>Orchestration</a:t>
+              <a:t>Gateway &amp; Orchestration</a:t>
             </a:r>
             <a:endParaRPr lang="en-US" sz="1900" dirty="0"/>
           </a:p>
@@ -9655,7 +8799,7 @@
               <a:buNone/>
             </a:pPr>
             <a:r>
-              <a:t>Node.js &amp; Express Gateway · REST APIs</a:t>
+              <a:t>Node.js &amp; Express Gateway • REST APIs • Modular Detectors</a:t>
             </a:r>
             <a:endParaRPr lang="en-US" sz="1700" dirty="0"/>
           </a:p>
@@ -9739,14 +8883,6 @@
               <a:buNone/>
             </a:pPr>
             <a:r>
-              <a:rPr lang="en-US" altLang="en-US" sz="1900" dirty="0">
-                <a:solidFill>
-                  <a:srgbClr val="FFFFFF"/>
-                </a:solidFill>
-                <a:latin typeface="Space Grotesk" pitchFamily="34" charset="0"/>
-                <a:ea typeface="Space Grotesk" pitchFamily="34" charset="-122"/>
-                <a:cs typeface="Space Grotesk" pitchFamily="34" charset="-120"/>
-              </a:rPr>
               <a:t>Intelligence</a:t>
             </a:r>
             <a:endParaRPr lang="en-US" sz="1900" dirty="0"/>
@@ -9778,14 +8914,6 @@
               <a:buNone/>
             </a:pPr>
             <a:r>
-              <a:rPr lang="en-US" altLang="en-US" sz="1500" dirty="0">
-                <a:solidFill>
-                  <a:srgbClr val="8B9BB4"/>
-                </a:solidFill>
-                <a:latin typeface="Inter" pitchFamily="34" charset="0"/>
-                <a:ea typeface="Inter" pitchFamily="34" charset="-122"/>
-                <a:cs typeface="Inter" pitchFamily="34" charset="-120"/>
-              </a:rPr>
               <a:t>scikit-learn / Transformers · librosa / SpeechBrain · OpenCV / MediaPipe</a:t>
             </a:r>
             <a:endParaRPr lang="en-US" sz="1500" dirty="0"/>
@@ -9870,14 +8998,6 @@
               <a:buNone/>
             </a:pPr>
             <a:r>
-              <a:rPr lang="en-US" altLang="en-US" sz="1900" dirty="0">
-                <a:solidFill>
-                  <a:srgbClr val="FFFFFF"/>
-                </a:solidFill>
-                <a:latin typeface="Space Grotesk" pitchFamily="34" charset="0"/>
-                <a:ea typeface="Space Grotesk" pitchFamily="34" charset="-122"/>
-                <a:cs typeface="Space Grotesk" pitchFamily="34" charset="-120"/>
-              </a:rPr>
               <a:t>Correlation</a:t>
             </a:r>
             <a:endParaRPr lang="en-US" sz="1900" dirty="0"/>
@@ -9909,14 +9029,6 @@
               <a:buNone/>
             </a:pPr>
             <a:r>
-              <a:rPr lang="en-US" altLang="en-US" sz="1700" dirty="0">
-                <a:solidFill>
-                  <a:srgbClr val="8B9BB4"/>
-                </a:solidFill>
-                <a:latin typeface="Inter" pitchFamily="34" charset="0"/>
-                <a:ea typeface="Inter" pitchFamily="34" charset="-122"/>
-                <a:cs typeface="Inter" pitchFamily="34" charset="-120"/>
-              </a:rPr>
               <a:t>NetworkX · threat rules · Digital Twin profiles</a:t>
             </a:r>
             <a:endParaRPr lang="en-US" sz="1700" dirty="0"/>
@@ -10001,15 +9113,7 @@
               <a:buNone/>
             </a:pPr>
             <a:r>
-              <a:rPr lang="en-US" altLang="en-US" sz="1900" dirty="0">
-                <a:solidFill>
-                  <a:srgbClr val="FFFFFF"/>
-                </a:solidFill>
-                <a:latin typeface="Space Grotesk" pitchFamily="34" charset="0"/>
-                <a:ea typeface="Space Grotesk" pitchFamily="34" charset="-122"/>
-                <a:cs typeface="Space Grotesk" pitchFamily="34" charset="-120"/>
-              </a:rPr>
-              <a:t>Data + deployment</a:t>
+              <a:t>Data &amp; Security Framework</a:t>
             </a:r>
             <a:endParaRPr lang="en-US" sz="1900" dirty="0"/>
           </a:p>
@@ -10040,7 +9144,7 @@
               <a:buNone/>
             </a:pPr>
             <a:r>
-              <a:t>Vercel Cloud CI/CD · Encrypted Browser Persistence</a:t>
+              <a:t>Vercel Cloud CI/CD • Local Encrypted Storage • NIST AI RMF 1.0 • MITRE ATT&amp;CK</a:t>
             </a:r>
             <a:endParaRPr lang="en-US" sz="1700" dirty="0"/>
           </a:p>
@@ -10100,14 +9204,6 @@
               <a:buNone/>
             </a:pPr>
             <a:r>
-              <a:rPr lang="en-US" altLang="en-US" sz="1300" dirty="0">
-                <a:solidFill>
-                  <a:srgbClr val="FFB300"/>
-                </a:solidFill>
-                <a:latin typeface="JetBrains Mono" pitchFamily="34" charset="0"/>
-                <a:ea typeface="JetBrains Mono" pitchFamily="34" charset="-122"/>
-                <a:cs typeface="JetBrains Mono" pitchFamily="34" charset="-120"/>
-              </a:rPr>
               <a:t>HACKATHON MVP BOUNDARY</a:t>
             </a:r>
             <a:endParaRPr lang="en-US" sz="1300" dirty="0"/>
@@ -10139,14 +9235,6 @@
               <a:buNone/>
             </a:pPr>
             <a:r>
-              <a:rPr lang="en-US" altLang="en-US" sz="2700" dirty="0">
-                <a:solidFill>
-                  <a:srgbClr val="FFFFFF"/>
-                </a:solidFill>
-                <a:latin typeface="Space Grotesk" pitchFamily="34" charset="0"/>
-                <a:ea typeface="Space Grotesk" pitchFamily="34" charset="-122"/>
-                <a:cs typeface="Space Grotesk" pitchFamily="34" charset="-120"/>
-              </a:rPr>
               <a:t>Build the decision engine first</a:t>
             </a:r>
             <a:endParaRPr lang="en-US" sz="2700" dirty="0"/>
@@ -10181,14 +9269,6 @@
               <a:buNone/>
             </a:pPr>
             <a:r>
-              <a:rPr lang="en-US" altLang="en-US" sz="1700" dirty="0">
-                <a:solidFill>
-                  <a:srgbClr val="8B9BB4"/>
-                </a:solidFill>
-                <a:latin typeface="Inter" pitchFamily="34" charset="0"/>
-                <a:ea typeface="Inter" pitchFamily="34" charset="-122"/>
-                <a:cs typeface="Inter" pitchFamily="34" charset="-120"/>
-              </a:rPr>
               <a:t>Prioritize phishing and URL analysis, audio indicators, identity rules, attack graph, explainable risk scoring, dashboard, and response simulation.</a:t>
             </a:r>
             <a:endParaRPr lang="en-US" sz="1700" dirty="0"/>
@@ -10246,14 +9326,6 @@
               <a:buNone/>
             </a:pPr>
             <a:r>
-              <a:rPr lang="en-US" altLang="en-US" sz="1600" dirty="0">
-                <a:solidFill>
-                  <a:srgbClr val="FFFFFF"/>
-                </a:solidFill>
-                <a:latin typeface="Inter" pitchFamily="34" charset="0"/>
-                <a:ea typeface="Inter" pitchFamily="34" charset="-122"/>
-                <a:cs typeface="Inter" pitchFamily="34" charset="-120"/>
-              </a:rPr>
               <a:t>Video analysis remains modular with sample input.</a:t>
             </a:r>
             <a:endParaRPr lang="en-US" sz="1600" dirty="0"/>
@@ -10285,14 +9357,6 @@
               <a:buNone/>
             </a:pPr>
             <a:r>
-              <a:rPr lang="en-US" altLang="en-US" sz="1200" dirty="0">
-                <a:solidFill>
-                  <a:srgbClr val="8B9BB4"/>
-                </a:solidFill>
-                <a:latin typeface="JetBrains Mono" pitchFamily="34" charset="0"/>
-                <a:ea typeface="JetBrains Mono" pitchFamily="34" charset="-122"/>
-                <a:cs typeface="JetBrains Mono" pitchFamily="34" charset="-120"/>
-              </a:rPr>
               <a:t>SEC-07 // STACK</a:t>
             </a:r>
             <a:endParaRPr lang="en-US" sz="1200" dirty="0"/>
@@ -10355,6 +9419,10 @@
             <a:prstDash val="solid"/>
           </a:ln>
         </p:spPr>
+        <p:txBody>
+          <a:bodyPr/>
+          <a:p/>
+        </p:txBody>
       </p:sp>
       <p:sp>
         <p:nvSpPr>
@@ -10381,14 +9449,6 @@
               <a:buNone/>
             </a:pPr>
             <a:r>
-              <a:rPr lang="en-US" altLang="en-US" sz="1300" dirty="0">
-                <a:solidFill>
-                  <a:srgbClr val="00E5FF"/>
-                </a:solidFill>
-                <a:latin typeface="JetBrains Mono" pitchFamily="34" charset="0"/>
-                <a:ea typeface="JetBrains Mono" pitchFamily="34" charset="-122"/>
-                <a:cs typeface="JetBrains Mono" pitchFamily="34" charset="-120"/>
-              </a:rPr>
               <a:t>MANDATORY 05 // PSEUDOCODE + ALGORITHM</a:t>
             </a:r>
             <a:endParaRPr lang="en-US" sz="1300" dirty="0"/>
@@ -10420,14 +9480,6 @@
               <a:buNone/>
             </a:pPr>
             <a:r>
-              <a:rPr lang="en-US" altLang="en-US" sz="1200" dirty="0">
-                <a:solidFill>
-                  <a:srgbClr val="8B9BB4"/>
-                </a:solidFill>
-                <a:latin typeface="JetBrains Mono" pitchFamily="34" charset="0"/>
-                <a:ea typeface="JetBrains Mono" pitchFamily="34" charset="-122"/>
-                <a:cs typeface="JetBrains Mono" pitchFamily="34" charset="-120"/>
-              </a:rPr>
               <a:t>NEXUS 2026</a:t>
             </a:r>
             <a:endParaRPr lang="en-US" sz="1200" dirty="0"/>
@@ -10459,14 +9511,6 @@
               <a:buNone/>
             </a:pPr>
             <a:r>
-              <a:rPr lang="en-US" altLang="en-US" sz="4300" dirty="0">
-                <a:solidFill>
-                  <a:srgbClr val="FFFFFF"/>
-                </a:solidFill>
-                <a:latin typeface="Space Grotesk" pitchFamily="34" charset="0"/>
-                <a:ea typeface="Space Grotesk" pitchFamily="34" charset="-122"/>
-                <a:cs typeface="Space Grotesk" pitchFamily="34" charset="-120"/>
-              </a:rPr>
               <a:t>The algorithm fuses evidence before choosing action</a:t>
             </a:r>
             <a:endParaRPr lang="en-US" sz="4300" dirty="0"/>
@@ -10498,14 +9542,6 @@
               <a:buNone/>
             </a:pPr>
             <a:r>
-              <a:rPr lang="en-US" altLang="en-US" sz="1800" dirty="0">
-                <a:solidFill>
-                  <a:srgbClr val="8B9BB4"/>
-                </a:solidFill>
-                <a:latin typeface="Inter" pitchFamily="34" charset="0"/>
-                <a:ea typeface="Inter" pitchFamily="34" charset="-122"/>
-                <a:cs typeface="Inter" pitchFamily="34" charset="-120"/>
-              </a:rPr>
               <a:t>Each available modality contributes evidence; missing modalities are excluded, never guessed.</a:t>
             </a:r>
             <a:endParaRPr lang="en-US" sz="1800" dirty="0"/>
@@ -10536,6 +9572,10 @@
             <a:prstDash val="solid"/>
           </a:ln>
         </p:spPr>
+        <p:txBody>
+          <a:bodyPr/>
+          <a:p/>
+        </p:txBody>
       </p:sp>
       <p:sp>
         <p:nvSpPr>
@@ -10562,14 +9602,6 @@
               <a:buNone/>
             </a:pPr>
             <a:r>
-              <a:rPr lang="en-US" altLang="en-US" sz="1200" dirty="0">
-                <a:solidFill>
-                  <a:srgbClr val="00E5FF"/>
-                </a:solidFill>
-                <a:latin typeface="JetBrains Mono" pitchFamily="34" charset="0"/>
-                <a:ea typeface="JetBrains Mono" pitchFamily="34" charset="-122"/>
-                <a:cs typeface="JetBrains Mono" pitchFamily="34" charset="-120"/>
-              </a:rPr>
               <a:t>FUNCTION ANALYZE_SECURITY_EVENT(event)</a:t>
             </a:r>
             <a:endParaRPr lang="en-US" sz="1200" dirty="0"/>
@@ -10604,26 +9636,7 @@
               <a:buNone/>
             </a:pPr>
             <a:r>
-              <a:rPr lang="en-US" altLang="en-US" sz="1500" dirty="0">
-                <a:solidFill>
-                  <a:srgbClr val="8B9BB4"/>
-                </a:solidFill>
-                <a:latin typeface="JetBrains Mono" pitchFamily="34" charset="0"/>
-                <a:ea typeface="JetBrains Mono" pitchFamily="34" charset="-122"/>
-                <a:cs typeface="JetBrains Mono" pitchFamily="34" charset="-120"/>
-              </a:rPr>
-              <a:t>01</a:t>
-            </a:r>
-            <a:r>
-              <a:rPr lang="en-US" altLang="en-US" sz="1500" dirty="0">
-                <a:solidFill>
-                  <a:srgbClr val="FFFFFF"/>
-                </a:solidFill>
-                <a:latin typeface="JetBrains Mono" pitchFamily="34" charset="0"/>
-                <a:ea typeface="JetBrains Mono" pitchFamily="34" charset="-122"/>
-                <a:cs typeface="JetBrains Mono" pitchFamily="34" charset="-120"/>
-              </a:rPr>
-              <a:t>  features ← extract(text, URL, media, identity, network)</a:t>
+              <a:t>01 features &lt;- extract(text, URL, media, identity, network)</a:t>
             </a:r>
             <a:endParaRPr lang="en-US" sz="1500" dirty="0"/>
           </a:p>
@@ -10635,26 +9648,7 @@
               <a:buNone/>
             </a:pPr>
             <a:r>
-              <a:rPr lang="en-US" altLang="en-US" sz="1500" dirty="0">
-                <a:solidFill>
-                  <a:srgbClr val="8B9BB4"/>
-                </a:solidFill>
-                <a:latin typeface="JetBrains Mono" pitchFamily="34" charset="0"/>
-                <a:ea typeface="JetBrains Mono" pitchFamily="34" charset="-122"/>
-                <a:cs typeface="JetBrains Mono" pitchFamily="34" charset="-120"/>
-              </a:rPr>
-              <a:t>02</a:t>
-            </a:r>
-            <a:r>
-              <a:rPr lang="en-US" altLang="en-US" sz="1500" dirty="0">
-                <a:solidFill>
-                  <a:srgbClr val="FFFFFF"/>
-                </a:solidFill>
-                <a:latin typeface="JetBrains Mono" pitchFamily="34" charset="0"/>
-                <a:ea typeface="JetBrains Mono" pitchFamily="34" charset="-122"/>
-                <a:cs typeface="JetBrains Mono" pitchFamily="34" charset="-120"/>
-              </a:rPr>
-              <a:t>  scores ← detectPhishing + detectAudio + detectVideo</a:t>
+              <a:t>02 scores &lt;- detectPhishing + detectAudio + detectVideo</a:t>
             </a:r>
             <a:endParaRPr lang="en-US" sz="1500" dirty="0"/>
           </a:p>
@@ -10666,26 +9660,7 @@
               <a:buNone/>
             </a:pPr>
             <a:r>
-              <a:rPr lang="en-US" altLang="en-US" sz="1500" dirty="0">
-                <a:solidFill>
-                  <a:srgbClr val="8B9BB4"/>
-                </a:solidFill>
-                <a:latin typeface="JetBrains Mono" pitchFamily="34" charset="0"/>
-                <a:ea typeface="JetBrains Mono" pitchFamily="34" charset="-122"/>
-                <a:cs typeface="JetBrains Mono" pitchFamily="34" charset="-120"/>
-              </a:rPr>
-              <a:t>03</a:t>
-            </a:r>
-            <a:r>
-              <a:rPr lang="en-US" altLang="en-US" sz="1500" dirty="0">
-                <a:solidFill>
-                  <a:srgbClr val="FFFFFF"/>
-                </a:solidFill>
-                <a:latin typeface="JetBrains Mono" pitchFamily="34" charset="0"/>
-                <a:ea typeface="JetBrains Mono" pitchFamily="34" charset="-122"/>
-                <a:cs typeface="JetBrains Mono" pitchFamily="34" charset="-120"/>
-              </a:rPr>
-              <a:t>  scores ← scores + verifyDigitalTwin + checkThreatSignals</a:t>
+              <a:t>03 scores &lt;- scores + verifyDigitalTwin + checkThreatSignals</a:t>
             </a:r>
             <a:endParaRPr lang="en-US" sz="1500" dirty="0"/>
           </a:p>
@@ -10697,26 +9672,7 @@
               <a:buNone/>
             </a:pPr>
             <a:r>
-              <a:rPr lang="en-US" altLang="en-US" sz="1500" dirty="0">
-                <a:solidFill>
-                  <a:srgbClr val="8B9BB4"/>
-                </a:solidFill>
-                <a:latin typeface="JetBrains Mono" pitchFamily="34" charset="0"/>
-                <a:ea typeface="JetBrains Mono" pitchFamily="34" charset="-122"/>
-                <a:cs typeface="JetBrains Mono" pitchFamily="34" charset="-120"/>
-              </a:rPr>
-              <a:t>04</a:t>
-            </a:r>
-            <a:r>
-              <a:rPr lang="en-US" altLang="en-US" sz="1500" dirty="0">
-                <a:solidFill>
-                  <a:srgbClr val="FFFFFF"/>
-                </a:solidFill>
-                <a:latin typeface="JetBrains Mono" pitchFamily="34" charset="0"/>
-                <a:ea typeface="JetBrains Mono" pitchFamily="34" charset="-122"/>
-                <a:cs typeface="JetBrains Mono" pitchFamily="34" charset="-120"/>
-              </a:rPr>
-              <a:t>  graph ← updateAndQueryAttackGraph(features)</a:t>
+              <a:t>04 graph &lt;- updateAndQueryAttackGraph(features)</a:t>
             </a:r>
             <a:endParaRPr lang="en-US" sz="1500" dirty="0"/>
           </a:p>
@@ -10728,26 +9684,7 @@
               <a:buNone/>
             </a:pPr>
             <a:r>
-              <a:rPr lang="en-US" altLang="en-US" sz="1500" dirty="0">
-                <a:solidFill>
-                  <a:srgbClr val="8B9BB4"/>
-                </a:solidFill>
-                <a:latin typeface="JetBrains Mono" pitchFamily="34" charset="0"/>
-                <a:ea typeface="JetBrains Mono" pitchFamily="34" charset="-122"/>
-                <a:cs typeface="JetBrains Mono" pitchFamily="34" charset="-120"/>
-              </a:rPr>
-              <a:t>05</a:t>
-            </a:r>
-            <a:r>
-              <a:rPr lang="en-US" altLang="en-US" sz="1500" dirty="0">
-                <a:solidFill>
-                  <a:srgbClr val="FFFFFF"/>
-                </a:solidFill>
-                <a:latin typeface="JetBrains Mono" pitchFamily="34" charset="0"/>
-                <a:ea typeface="JetBrains Mono" pitchFamily="34" charset="-122"/>
-                <a:cs typeface="JetBrains Mono" pitchFamily="34" charset="-120"/>
-              </a:rPr>
-              <a:t>  risk ← fuse(scores, graph, businessImpact, confidence)</a:t>
+              <a:t>05 risk &lt;- fuse(scores, graph, businessImpact, confidence)</a:t>
             </a:r>
             <a:endParaRPr lang="en-US" sz="1500" dirty="0"/>
           </a:p>
@@ -10759,26 +9696,7 @@
               <a:buNone/>
             </a:pPr>
             <a:r>
-              <a:rPr lang="en-US" altLang="en-US" sz="1500" dirty="0">
-                <a:solidFill>
-                  <a:srgbClr val="8B9BB4"/>
-                </a:solidFill>
-                <a:latin typeface="JetBrains Mono" pitchFamily="34" charset="0"/>
-                <a:ea typeface="JetBrains Mono" pitchFamily="34" charset="-122"/>
-                <a:cs typeface="JetBrains Mono" pitchFamily="34" charset="-120"/>
-              </a:rPr>
-              <a:t>06</a:t>
-            </a:r>
-            <a:r>
-              <a:rPr lang="en-US" altLang="en-US" sz="1500" dirty="0">
-                <a:solidFill>
-                  <a:srgbClr val="FFFFFF"/>
-                </a:solidFill>
-                <a:latin typeface="JetBrains Mono" pitchFamily="34" charset="0"/>
-                <a:ea typeface="JetBrains Mono" pitchFamily="34" charset="-122"/>
-                <a:cs typeface="JetBrains Mono" pitchFamily="34" charset="-120"/>
-              </a:rPr>
-              <a:t>  reasons ← generateExplanation(scores, graph)</a:t>
+              <a:t>06 reasons &lt;- generateExplanation(scores, graph)</a:t>
             </a:r>
             <a:endParaRPr lang="en-US" sz="1500" dirty="0"/>
           </a:p>
@@ -10790,26 +9708,7 @@
               <a:buNone/>
             </a:pPr>
             <a:r>
-              <a:rPr lang="en-US" altLang="en-US" sz="1500" dirty="0">
-                <a:solidFill>
-                  <a:srgbClr val="8B9BB4"/>
-                </a:solidFill>
-                <a:latin typeface="JetBrains Mono" pitchFamily="34" charset="0"/>
-                <a:ea typeface="JetBrains Mono" pitchFamily="34" charset="-122"/>
-                <a:cs typeface="JetBrains Mono" pitchFamily="34" charset="-120"/>
-              </a:rPr>
-              <a:t>07</a:t>
-            </a:r>
-            <a:r>
-              <a:rPr lang="en-US" altLang="en-US" sz="1500" dirty="0">
-                <a:solidFill>
-                  <a:srgbClr val="FFFFFF"/>
-                </a:solidFill>
-                <a:latin typeface="JetBrains Mono" pitchFamily="34" charset="0"/>
-                <a:ea typeface="JetBrains Mono" pitchFamily="34" charset="-122"/>
-                <a:cs typeface="JetBrains Mono" pitchFamily="34" charset="-120"/>
-              </a:rPr>
-              <a:t>  action ← selectSafeResponse(risk)</a:t>
+              <a:t>07 action &lt;- selectSafeResponse(risk)</a:t>
             </a:r>
             <a:endParaRPr lang="en-US" sz="1500" dirty="0"/>
           </a:p>
@@ -10821,26 +9720,7 @@
               <a:buNone/>
             </a:pPr>
             <a:r>
-              <a:rPr lang="en-US" altLang="en-US" sz="1500" dirty="0">
-                <a:solidFill>
-                  <a:srgbClr val="8B9BB4"/>
-                </a:solidFill>
-                <a:latin typeface="JetBrains Mono" pitchFamily="34" charset="0"/>
-                <a:ea typeface="JetBrains Mono" pitchFamily="34" charset="-122"/>
-                <a:cs typeface="JetBrains Mono" pitchFamily="34" charset="-120"/>
-              </a:rPr>
-              <a:t>08</a:t>
-            </a:r>
-            <a:r>
-              <a:rPr lang="en-US" altLang="en-US" sz="1500" dirty="0">
-                <a:solidFill>
-                  <a:srgbClr val="FFFFFF"/>
-                </a:solidFill>
-                <a:latin typeface="JetBrains Mono" pitchFamily="34" charset="0"/>
-                <a:ea typeface="JetBrains Mono" pitchFamily="34" charset="-122"/>
-                <a:cs typeface="JetBrains Mono" pitchFamily="34" charset="-120"/>
-              </a:rPr>
-              <a:t>  return risk, confidence, reasons, graph, action</a:t>
+              <a:t>08 return risk, confidence, reasons, graph, action</a:t>
             </a:r>
             <a:endParaRPr lang="en-US" sz="1500" dirty="0"/>
           </a:p>
@@ -10871,14 +9751,6 @@
               <a:buNone/>
             </a:pPr>
             <a:r>
-              <a:rPr lang="en-US" altLang="en-US" sz="1100" dirty="0">
-                <a:solidFill>
-                  <a:srgbClr val="8B9BB4"/>
-                </a:solidFill>
-                <a:latin typeface="JetBrains Mono" pitchFamily="34" charset="0"/>
-                <a:ea typeface="JetBrains Mono" pitchFamily="34" charset="-122"/>
-                <a:cs typeface="JetBrains Mono" pitchFamily="34" charset="-120"/>
-              </a:rPr>
               <a:t>Output is an explainable decision package—not simply “fake” or “genuine”.</a:t>
             </a:r>
             <a:endParaRPr lang="en-US" sz="1100" dirty="0"/>
@@ -10909,6 +9781,10 @@
             <a:prstDash val="solid"/>
           </a:ln>
         </p:spPr>
+        <p:txBody>
+          <a:bodyPr/>
+          <a:p/>
+        </p:txBody>
       </p:sp>
       <p:sp>
         <p:nvSpPr>
@@ -10935,14 +9811,6 @@
               <a:buNone/>
             </a:pPr>
             <a:r>
-              <a:rPr lang="en-US" altLang="en-US" sz="2200" dirty="0">
-                <a:solidFill>
-                  <a:srgbClr val="FFFFFF"/>
-                </a:solidFill>
-                <a:latin typeface="Space Grotesk" pitchFamily="34" charset="0"/>
-                <a:ea typeface="Space Grotesk" pitchFamily="34" charset="-122"/>
-                <a:cs typeface="Space Grotesk" pitchFamily="34" charset="-120"/>
-              </a:rPr>
               <a:t>Risk policy → response</a:t>
             </a:r>
             <a:endParaRPr lang="en-US" sz="2200" dirty="0"/>
@@ -10973,6 +9841,10 @@
             <a:prstDash val="solid"/>
           </a:ln>
         </p:spPr>
+        <p:txBody>
+          <a:bodyPr/>
+          <a:p/>
+        </p:txBody>
       </p:sp>
       <p:sp>
         <p:nvSpPr>
@@ -10999,14 +9871,6 @@
               <a:buNone/>
             </a:pPr>
             <a:r>
-              <a:rPr lang="en-US" altLang="en-US" sz="1200" dirty="0">
-                <a:solidFill>
-                  <a:srgbClr val="00E5FF"/>
-                </a:solidFill>
-                <a:latin typeface="JetBrains Mono" pitchFamily="34" charset="0"/>
-                <a:ea typeface="JetBrains Mono" pitchFamily="34" charset="-122"/>
-                <a:cs typeface="JetBrains Mono" pitchFamily="34" charset="-120"/>
-              </a:rPr>
               <a:t>LOW</a:t>
             </a:r>
             <a:endParaRPr lang="en-US" sz="1200" dirty="0"/>
@@ -11038,14 +9902,6 @@
               <a:buNone/>
             </a:pPr>
             <a:r>
-              <a:rPr lang="en-US" altLang="en-US" sz="1600" dirty="0">
-                <a:solidFill>
-                  <a:srgbClr val="FFFFFF"/>
-                </a:solidFill>
-                <a:latin typeface="Inter" pitchFamily="34" charset="0"/>
-                <a:ea typeface="Inter" pitchFamily="34" charset="-122"/>
-                <a:cs typeface="Inter" pitchFamily="34" charset="-120"/>
-              </a:rPr>
               <a:t>Allow, monitor, and log</a:t>
             </a:r>
             <a:endParaRPr lang="en-US" sz="1600" dirty="0"/>
@@ -11076,6 +9932,10 @@
             <a:prstDash val="solid"/>
           </a:ln>
         </p:spPr>
+        <p:txBody>
+          <a:bodyPr/>
+          <a:p/>
+        </p:txBody>
       </p:sp>
       <p:sp>
         <p:nvSpPr>
@@ -11102,14 +9962,6 @@
               <a:buNone/>
             </a:pPr>
             <a:r>
-              <a:rPr lang="en-US" altLang="en-US" sz="1200" dirty="0">
-                <a:solidFill>
-                  <a:srgbClr val="FFB300"/>
-                </a:solidFill>
-                <a:latin typeface="JetBrains Mono" pitchFamily="34" charset="0"/>
-                <a:ea typeface="JetBrains Mono" pitchFamily="34" charset="-122"/>
-                <a:cs typeface="JetBrains Mono" pitchFamily="34" charset="-120"/>
-              </a:rPr>
               <a:t>MEDIUM</a:t>
             </a:r>
             <a:endParaRPr lang="en-US" sz="1200" dirty="0"/>
@@ -11141,14 +9993,6 @@
               <a:buNone/>
             </a:pPr>
             <a:r>
-              <a:rPr lang="en-US" altLang="en-US" sz="1600" dirty="0">
-                <a:solidFill>
-                  <a:srgbClr val="FFFFFF"/>
-                </a:solidFill>
-                <a:latin typeface="Inter" pitchFamily="34" charset="0"/>
-                <a:ea typeface="Inter" pitchFamily="34" charset="-122"/>
-                <a:cs typeface="Inter" pitchFamily="34" charset="-120"/>
-              </a:rPr>
               <a:t>Warn and verify independently</a:t>
             </a:r>
             <a:endParaRPr lang="en-US" sz="1600" dirty="0"/>
@@ -11179,6 +10023,10 @@
             <a:prstDash val="solid"/>
           </a:ln>
         </p:spPr>
+        <p:txBody>
+          <a:bodyPr/>
+          <a:p/>
+        </p:txBody>
       </p:sp>
       <p:sp>
         <p:nvSpPr>
@@ -11205,14 +10053,6 @@
               <a:buNone/>
             </a:pPr>
             <a:r>
-              <a:rPr lang="en-US" altLang="en-US" sz="1200" dirty="0">
-                <a:solidFill>
-                  <a:srgbClr val="FFB300"/>
-                </a:solidFill>
-                <a:latin typeface="JetBrains Mono" pitchFamily="34" charset="0"/>
-                <a:ea typeface="JetBrains Mono" pitchFamily="34" charset="-122"/>
-                <a:cs typeface="JetBrains Mono" pitchFamily="34" charset="-120"/>
-              </a:rPr>
               <a:t>HIGH</a:t>
             </a:r>
             <a:endParaRPr lang="en-US" sz="1200" dirty="0"/>
@@ -11244,14 +10084,6 @@
               <a:buNone/>
             </a:pPr>
             <a:r>
-              <a:rPr lang="en-US" altLang="en-US" sz="1600" dirty="0">
-                <a:solidFill>
-                  <a:srgbClr val="FFFFFF"/>
-                </a:solidFill>
-                <a:latin typeface="Inter" pitchFamily="34" charset="0"/>
-                <a:ea typeface="Inter" pitchFamily="34" charset="-122"/>
-                <a:cs typeface="Inter" pitchFamily="34" charset="-120"/>
-              </a:rPr>
               <a:t>Quarantine content and block URL</a:t>
             </a:r>
             <a:endParaRPr lang="en-US" sz="1600" dirty="0"/>
@@ -11282,6 +10114,10 @@
             <a:prstDash val="solid"/>
           </a:ln>
         </p:spPr>
+        <p:txBody>
+          <a:bodyPr/>
+          <a:p/>
+        </p:txBody>
       </p:sp>
       <p:sp>
         <p:nvSpPr>
@@ -11308,14 +10144,6 @@
               <a:buNone/>
             </a:pPr>
             <a:r>
-              <a:rPr lang="en-US" altLang="en-US" sz="1200" dirty="0">
-                <a:solidFill>
-                  <a:srgbClr val="FFB300"/>
-                </a:solidFill>
-                <a:latin typeface="JetBrains Mono" pitchFamily="34" charset="0"/>
-                <a:ea typeface="JetBrains Mono" pitchFamily="34" charset="-122"/>
-                <a:cs typeface="JetBrains Mono" pitchFamily="34" charset="-120"/>
-              </a:rPr>
               <a:t>CRITICAL</a:t>
             </a:r>
             <a:endParaRPr lang="en-US" sz="1200" dirty="0"/>
@@ -11347,14 +10175,6 @@
               <a:buNone/>
             </a:pPr>
             <a:r>
-              <a:rPr lang="en-US" altLang="en-US" sz="1600" dirty="0">
-                <a:solidFill>
-                  <a:srgbClr val="FFFFFF"/>
-                </a:solidFill>
-                <a:latin typeface="Inter" pitchFamily="34" charset="0"/>
-                <a:ea typeface="Inter" pitchFamily="34" charset="-122"/>
-                <a:cs typeface="Inter" pitchFamily="34" charset="-120"/>
-              </a:rPr>
               <a:t>Open incident; analyst approves action</a:t>
             </a:r>
             <a:endParaRPr lang="en-US" sz="1600" dirty="0"/>
@@ -11382,6 +10202,10 @@
             <a:prstDash val="solid"/>
           </a:ln>
         </p:spPr>
+        <p:txBody>
+          <a:bodyPr/>
+          <a:p/>
+        </p:txBody>
       </p:sp>
       <p:sp>
         <p:nvSpPr>
@@ -11408,14 +10232,6 @@
               <a:buNone/>
             </a:pPr>
             <a:r>
-              <a:rPr lang="en-US" altLang="en-US" sz="1200" dirty="0">
-                <a:solidFill>
-                  <a:srgbClr val="8B9BB4"/>
-                </a:solidFill>
-                <a:latin typeface="JetBrains Mono" pitchFamily="34" charset="0"/>
-                <a:ea typeface="JetBrains Mono" pitchFamily="34" charset="-122"/>
-                <a:cs typeface="JetBrains Mono" pitchFamily="34" charset="-120"/>
-              </a:rPr>
               <a:t>Confidence + business impact influence escalation.</a:t>
             </a:r>
             <a:endParaRPr lang="en-US" sz="1200" dirty="0"/>
@@ -11447,14 +10263,6 @@
               <a:buNone/>
             </a:pPr>
             <a:r>
-              <a:rPr lang="en-US" altLang="en-US" sz="1200" dirty="0">
-                <a:solidFill>
-                  <a:srgbClr val="8B9BB4"/>
-                </a:solidFill>
-                <a:latin typeface="JetBrains Mono" pitchFamily="34" charset="0"/>
-                <a:ea typeface="JetBrains Mono" pitchFamily="34" charset="-122"/>
-                <a:cs typeface="JetBrains Mono" pitchFamily="34" charset="-120"/>
-              </a:rPr>
               <a:t>SEC-08 // ALGORITHM</a:t>
             </a:r>
             <a:endParaRPr lang="en-US" sz="1200" dirty="0"/>
@@ -11547,14 +10355,6 @@
               <a:buNone/>
             </a:pPr>
             <a:r>
-              <a:rPr lang="en-US" altLang="en-US" sz="1300" dirty="0">
-                <a:solidFill>
-                  <a:srgbClr val="00E5FF"/>
-                </a:solidFill>
-                <a:latin typeface="JetBrains Mono" pitchFamily="34" charset="0"/>
-                <a:ea typeface="JetBrains Mono" pitchFamily="34" charset="-122"/>
-                <a:cs typeface="JetBrains Mono" pitchFamily="34" charset="-120"/>
-              </a:rPr>
               <a:t>08 // LIVE INCIDENT DEMO</a:t>
             </a:r>
             <a:endParaRPr lang="en-US" sz="1300" dirty="0"/>
@@ -11586,14 +10386,6 @@
               <a:buNone/>
             </a:pPr>
             <a:r>
-              <a:rPr lang="en-US" altLang="en-US" sz="1200" dirty="0">
-                <a:solidFill>
-                  <a:srgbClr val="8B9BB4"/>
-                </a:solidFill>
-                <a:latin typeface="JetBrains Mono" pitchFamily="34" charset="0"/>
-                <a:ea typeface="JetBrains Mono" pitchFamily="34" charset="-122"/>
-                <a:cs typeface="JetBrains Mono" pitchFamily="34" charset="-120"/>
-              </a:rPr>
               <a:t>NEXUS 2026</a:t>
             </a:r>
             <a:endParaRPr lang="en-US" sz="1200" dirty="0"/>
@@ -11625,14 +10417,6 @@
               <a:buNone/>
             </a:pPr>
             <a:r>
-              <a:rPr lang="en-US" altLang="en-US" sz="4300" dirty="0">
-                <a:solidFill>
-                  <a:srgbClr val="FFFFFF"/>
-                </a:solidFill>
-                <a:latin typeface="Space Grotesk" pitchFamily="34" charset="0"/>
-                <a:ea typeface="Space Grotesk" pitchFamily="34" charset="-122"/>
-                <a:cs typeface="Space Grotesk" pitchFamily="34" charset="-120"/>
-              </a:rPr>
               <a:t>A fake CFO request becomes one clear incident</a:t>
             </a:r>
             <a:endParaRPr lang="en-US" sz="4300" dirty="0"/>
@@ -11664,14 +10448,6 @@
               <a:buNone/>
             </a:pPr>
             <a:r>
-              <a:rPr lang="en-US" altLang="en-US" sz="1800" dirty="0">
-                <a:solidFill>
-                  <a:srgbClr val="8B9BB4"/>
-                </a:solidFill>
-                <a:latin typeface="Inter" pitchFamily="34" charset="0"/>
-                <a:ea typeface="Inter" pitchFamily="34" charset="-122"/>
-                <a:cs typeface="Inter" pitchFamily="34" charset="-120"/>
-              </a:rPr>
               <a:t>The cross-modal value appears when each clue points to the same impersonation attempt.</a:t>
             </a:r>
             <a:endParaRPr lang="en-US" sz="1800" dirty="0"/>
@@ -11732,14 +10508,6 @@
               <a:buNone/>
             </a:pPr>
             <a:r>
-              <a:rPr lang="en-US" altLang="en-US" sz="1200" dirty="0">
-                <a:solidFill>
-                  <a:srgbClr val="FF007F"/>
-                </a:solidFill>
-                <a:latin typeface="JetBrains Mono" pitchFamily="34" charset="0"/>
-                <a:ea typeface="JetBrains Mono" pitchFamily="34" charset="-122"/>
-                <a:cs typeface="JetBrains Mono" pitchFamily="34" charset="-120"/>
-              </a:rPr>
               <a:t>01 // ATTACKER SIGNALS</a:t>
             </a:r>
             <a:endParaRPr lang="en-US" sz="1200" dirty="0"/>
@@ -11795,14 +10563,6 @@
               <a:buNone/>
             </a:pPr>
             <a:r>
-              <a:rPr lang="en-US" altLang="en-US" sz="2300" dirty="0">
-                <a:solidFill>
-                  <a:srgbClr val="FFFFFF"/>
-                </a:solidFill>
-                <a:latin typeface="Space Grotesk" pitchFamily="34" charset="0"/>
-                <a:ea typeface="Space Grotesk" pitchFamily="34" charset="-122"/>
-                <a:cs typeface="Space Grotesk" pitchFamily="34" charset="-120"/>
-              </a:rPr>
               <a:t>Urgent CFO request</a:t>
             </a:r>
             <a:endParaRPr lang="en-US" sz="2300" dirty="0"/>
@@ -11837,14 +10597,6 @@
               <a:buNone/>
             </a:pPr>
             <a:r>
-              <a:rPr lang="en-US" altLang="en-US" sz="1700" dirty="0">
-                <a:solidFill>
-                  <a:srgbClr val="8B9BB4"/>
-                </a:solidFill>
-                <a:latin typeface="Inter" pitchFamily="34" charset="0"/>
-                <a:ea typeface="Inter" pitchFamily="34" charset="-122"/>
-                <a:cs typeface="Inter" pitchFamily="34" charset="-120"/>
-              </a:rPr>
               <a:t>CFO-looking email</a:t>
             </a:r>
             <a:endParaRPr lang="en-US" sz="1700" dirty="0"/>
@@ -11857,14 +10609,6 @@
               <a:buNone/>
             </a:pPr>
             <a:r>
-              <a:rPr lang="en-US" altLang="en-US" sz="1700" dirty="0">
-                <a:solidFill>
-                  <a:srgbClr val="8B9BB4"/>
-                </a:solidFill>
-                <a:latin typeface="Inter" pitchFamily="34" charset="0"/>
-                <a:ea typeface="Inter" pitchFamily="34" charset="-122"/>
-                <a:cs typeface="Inter" pitchFamily="34" charset="-120"/>
-              </a:rPr>
               <a:t>Look-alike payment link</a:t>
             </a:r>
             <a:endParaRPr lang="en-US" sz="1700" dirty="0"/>
@@ -11877,14 +10621,6 @@
               <a:buNone/>
             </a:pPr>
             <a:r>
-              <a:rPr lang="en-US" altLang="en-US" sz="1700" dirty="0">
-                <a:solidFill>
-                  <a:srgbClr val="8B9BB4"/>
-                </a:solidFill>
-                <a:latin typeface="Inter" pitchFamily="34" charset="0"/>
-                <a:ea typeface="Inter" pitchFamily="34" charset="-122"/>
-                <a:cs typeface="Inter" pitchFamily="34" charset="-120"/>
-              </a:rPr>
               <a:t>Cloned-sounding voice note</a:t>
             </a:r>
             <a:endParaRPr lang="en-US" sz="1700" dirty="0"/>
@@ -11971,7 +10707,7 @@
               <a:buNone/>
             </a:pPr>
             <a:r>
-              <a:t>02 // AEGISNEXUS CHECKS</a:t>
+              <a:t>02 // AEGISNEXUS CORRELATION CHECKS</a:t>
             </a:r>
             <a:endParaRPr lang="en-US" sz="1200" dirty="0"/>
           </a:p>
@@ -12026,14 +10762,6 @@
               <a:buNone/>
             </a:pPr>
             <a:r>
-              <a:rPr lang="en-US" altLang="en-US" sz="2300" dirty="0">
-                <a:solidFill>
-                  <a:srgbClr val="FFFFFF"/>
-                </a:solidFill>
-                <a:latin typeface="Space Grotesk" pitchFamily="34" charset="0"/>
-                <a:ea typeface="Space Grotesk" pitchFamily="34" charset="-122"/>
-                <a:cs typeface="Space Grotesk" pitchFamily="34" charset="-120"/>
-              </a:rPr>
               <a:t>Identity mismatch</a:t>
             </a:r>
             <a:endParaRPr lang="en-US" sz="2300" dirty="0"/>
@@ -12068,14 +10796,6 @@
               <a:buNone/>
             </a:pPr>
             <a:r>
-              <a:rPr lang="en-US" altLang="en-US" sz="1700" dirty="0">
-                <a:solidFill>
-                  <a:srgbClr val="8B9BB4"/>
-                </a:solidFill>
-                <a:latin typeface="Inter" pitchFamily="34" charset="0"/>
-                <a:ea typeface="Inter" pitchFamily="34" charset="-122"/>
-                <a:cs typeface="Inter" pitchFamily="34" charset="-120"/>
-              </a:rPr>
               <a:t>Unapproved channel</a:t>
             </a:r>
             <a:endParaRPr lang="en-US" sz="1700" dirty="0"/>
@@ -12088,14 +10808,6 @@
               <a:buNone/>
             </a:pPr>
             <a:r>
-              <a:rPr lang="en-US" altLang="en-US" sz="1700" dirty="0">
-                <a:solidFill>
-                  <a:srgbClr val="8B9BB4"/>
-                </a:solidFill>
-                <a:latin typeface="Inter" pitchFamily="34" charset="0"/>
-                <a:ea typeface="Inter" pitchFamily="34" charset="-122"/>
-                <a:cs typeface="Inter" pitchFamily="34" charset="-120"/>
-              </a:rPr>
               <a:t>Unusual payment behavior</a:t>
             </a:r>
             <a:endParaRPr lang="en-US" sz="1700" dirty="0"/>
@@ -12108,14 +10820,6 @@
               <a:buNone/>
             </a:pPr>
             <a:r>
-              <a:rPr lang="en-US" altLang="en-US" sz="1700" dirty="0">
-                <a:solidFill>
-                  <a:srgbClr val="8B9BB4"/>
-                </a:solidFill>
-                <a:latin typeface="Inter" pitchFamily="34" charset="0"/>
-                <a:ea typeface="Inter" pitchFamily="34" charset="-122"/>
-                <a:cs typeface="Inter" pitchFamily="34" charset="-120"/>
-              </a:rPr>
               <a:t>Related graph indicators</a:t>
             </a:r>
             <a:endParaRPr lang="en-US" sz="1700" dirty="0"/>
@@ -12202,14 +10906,6 @@
               <a:buNone/>
             </a:pPr>
             <a:r>
-              <a:rPr lang="en-US" altLang="en-US" sz="1200" dirty="0">
-                <a:solidFill>
-                  <a:srgbClr val="FFB300"/>
-                </a:solidFill>
-                <a:latin typeface="JetBrains Mono" pitchFamily="34" charset="0"/>
-                <a:ea typeface="JetBrains Mono" pitchFamily="34" charset="-122"/>
-                <a:cs typeface="JetBrains Mono" pitchFamily="34" charset="-120"/>
-              </a:rPr>
               <a:t>03 // RISK DECISION</a:t>
             </a:r>
             <a:endParaRPr lang="en-US" sz="1200" dirty="0"/>
@@ -12265,14 +10961,6 @@
               <a:buNone/>
             </a:pPr>
             <a:r>
-              <a:rPr lang="en-US" altLang="en-US" sz="2300" dirty="0">
-                <a:solidFill>
-                  <a:srgbClr val="FFFFFF"/>
-                </a:solidFill>
-                <a:latin typeface="Space Grotesk" pitchFamily="34" charset="0"/>
-                <a:ea typeface="Space Grotesk" pitchFamily="34" charset="-122"/>
-                <a:cs typeface="Space Grotesk" pitchFamily="34" charset="-120"/>
-              </a:rPr>
               <a:t>High-risk incident</a:t>
             </a:r>
             <a:endParaRPr lang="en-US" sz="2300" dirty="0"/>
@@ -12307,14 +10995,6 @@
               <a:buNone/>
             </a:pPr>
             <a:r>
-              <a:rPr lang="en-US" altLang="en-US" sz="1700" dirty="0">
-                <a:solidFill>
-                  <a:srgbClr val="8B9BB4"/>
-                </a:solidFill>
-                <a:latin typeface="Inter" pitchFamily="34" charset="0"/>
-                <a:ea typeface="Inter" pitchFamily="34" charset="-122"/>
-                <a:cs typeface="Inter" pitchFamily="34" charset="-120"/>
-              </a:rPr>
               <a:t>Quarantine message</a:t>
             </a:r>
             <a:endParaRPr lang="en-US" sz="1700" dirty="0"/>
@@ -12327,14 +11007,6 @@
               <a:buNone/>
             </a:pPr>
             <a:r>
-              <a:rPr lang="en-US" altLang="en-US" sz="1700" dirty="0">
-                <a:solidFill>
-                  <a:srgbClr val="8B9BB4"/>
-                </a:solidFill>
-                <a:latin typeface="Inter" pitchFamily="34" charset="0"/>
-                <a:ea typeface="Inter" pitchFamily="34" charset="-122"/>
-                <a:cs typeface="Inter" pitchFamily="34" charset="-120"/>
-              </a:rPr>
               <a:t>Block URL</a:t>
             </a:r>
             <a:endParaRPr lang="en-US" sz="1700" dirty="0"/>
@@ -12347,14 +11019,6 @@
               <a:buNone/>
             </a:pPr>
             <a:r>
-              <a:rPr lang="en-US" altLang="en-US" sz="1700" dirty="0">
-                <a:solidFill>
-                  <a:srgbClr val="8B9BB4"/>
-                </a:solidFill>
-                <a:latin typeface="Inter" pitchFamily="34" charset="0"/>
-                <a:ea typeface="Inter" pitchFamily="34" charset="-122"/>
-                <a:cs typeface="Inter" pitchFamily="34" charset="-120"/>
-              </a:rPr>
               <a:t>Notify analyst for approval</a:t>
             </a:r>
             <a:endParaRPr lang="en-US" sz="1700" dirty="0"/>
@@ -12417,14 +11081,6 @@
               <a:buNone/>
             </a:pPr>
             <a:r>
-              <a:rPr lang="en-US" altLang="en-US" sz="1200" dirty="0">
-                <a:solidFill>
-                  <a:srgbClr val="FFB300"/>
-                </a:solidFill>
-                <a:latin typeface="JetBrains Mono" pitchFamily="34" charset="0"/>
-                <a:ea typeface="JetBrains Mono" pitchFamily="34" charset="-122"/>
-                <a:cs typeface="JetBrains Mono" pitchFamily="34" charset="-120"/>
-              </a:rPr>
               <a:t>EXPECTED DASHBOARD OUTPUT</a:t>
             </a:r>
             <a:endParaRPr lang="en-US" sz="1200" dirty="0"/>
@@ -12518,14 +11174,6 @@
               <a:buNone/>
             </a:pPr>
             <a:r>
-              <a:rPr lang="en-US" altLang="en-US" sz="1200" dirty="0">
-                <a:solidFill>
-                  <a:srgbClr val="8B9BB4"/>
-                </a:solidFill>
-                <a:latin typeface="JetBrains Mono" pitchFamily="34" charset="0"/>
-                <a:ea typeface="JetBrains Mono" pitchFamily="34" charset="-122"/>
-                <a:cs typeface="JetBrains Mono" pitchFamily="34" charset="-120"/>
-              </a:rPr>
               <a:t>SEC-09 // DEMO</a:t>
             </a:r>
             <a:endParaRPr lang="en-US" sz="1200" dirty="0"/>

</xml_diff>

<commit_message>
fix(pptx): preserve original run colors and styling in presentation deck
</commit_message>
<xml_diff>
--- a/docs/NexusHackathon_Presentation.pptx
+++ b/docs/NexusHackathon_Presentation.pptx
@@ -1708,6 +1708,14 @@
               <a:buNone/>
             </a:pPr>
             <a:r>
+              <a:rPr lang="en-US" altLang="en-US" sz="1400" dirty="0">
+                <a:solidFill>
+                  <a:srgbClr val="00E5FF"/>
+                </a:solidFill>
+                <a:latin typeface="JetBrains Mono" pitchFamily="34" charset="0"/>
+                <a:ea typeface="JetBrains Mono" pitchFamily="34" charset="-122"/>
+                <a:cs typeface="JetBrains Mono" pitchFamily="34" charset="-120"/>
+              </a:rPr>
               <a:t>NEXUS 2026 // HACKATHON PRESENTATION</a:t>
             </a:r>
             <a:endParaRPr lang="en-US" sz="1400" dirty="0"/>
@@ -1762,6 +1770,14 @@
               <a:buNone/>
             </a:pPr>
             <a:r>
+              <a:rPr lang="en-US" altLang="en-US" sz="7000" dirty="0">
+                <a:solidFill>
+                  <a:srgbClr val="FFFFFF"/>
+                </a:solidFill>
+                <a:latin typeface="Space Grotesk" pitchFamily="34" charset="0"/>
+                <a:ea typeface="Space Grotesk" pitchFamily="34" charset="-122"/>
+                <a:cs typeface="Space Grotesk" pitchFamily="34" charset="-120"/>
+              </a:rPr>
               <a:t>AegisNexus</a:t>
             </a:r>
             <a:endParaRPr lang="en-US" sz="7000" dirty="0"/>
@@ -1793,6 +1809,14 @@
               <a:buNone/>
             </a:pPr>
             <a:r>
+              <a:rPr lang="en-US" altLang="en-US" sz="3600" dirty="0">
+                <a:solidFill>
+                  <a:srgbClr val="00E5FF"/>
+                </a:solidFill>
+                <a:latin typeface="Space Grotesk" pitchFamily="34" charset="0"/>
+                <a:ea typeface="Space Grotesk" pitchFamily="34" charset="-122"/>
+                <a:cs typeface="Space Grotesk" pitchFamily="34" charset="-120"/>
+              </a:rPr>
               <a:t>Detect the Signal. Defend the Decision.</a:t>
             </a:r>
             <a:endParaRPr lang="en-US" sz="3600" dirty="0"/>
@@ -1853,6 +1877,14 @@
               <a:buNone/>
             </a:pPr>
             <a:r>
+              <a:rPr lang="en-US" altLang="en-US" sz="2300" dirty="0">
+                <a:solidFill>
+                  <a:srgbClr val="FFFFFF"/>
+                </a:solidFill>
+                <a:latin typeface="Inter" pitchFamily="34" charset="0"/>
+                <a:ea typeface="Inter" pitchFamily="34" charset="-122"/>
+                <a:cs typeface="Inter" pitchFamily="34" charset="-120"/>
+              </a:rPr>
               <a:t>AI-Powered Real-Time Deepfake and Phishing Detection &amp; Defense System</a:t>
             </a:r>
             <a:endParaRPr lang="en-US" sz="2300" dirty="0"/>
@@ -1884,6 +1916,14 @@
               <a:buNone/>
             </a:pPr>
             <a:r>
+              <a:rPr lang="en-US" altLang="en-US" sz="1200" dirty="0">
+                <a:solidFill>
+                  <a:srgbClr val="8B9BB4"/>
+                </a:solidFill>
+                <a:latin typeface="JetBrains Mono" pitchFamily="34" charset="0"/>
+                <a:ea typeface="JetBrains Mono" pitchFamily="34" charset="-122"/>
+                <a:cs typeface="JetBrains Mono" pitchFamily="34" charset="-120"/>
+              </a:rPr>
               <a:t>PRESENTED BY</a:t>
             </a:r>
             <a:endParaRPr lang="en-US" sz="1200" dirty="0"/>
@@ -1915,6 +1955,14 @@
               <a:buNone/>
             </a:pPr>
             <a:r>
+              <a:rPr lang="en-US" altLang="en-US" sz="2200" dirty="0">
+                <a:solidFill>
+                  <a:srgbClr val="FFFFFF"/>
+                </a:solidFill>
+                <a:latin typeface="Space Grotesk" pitchFamily="34" charset="0"/>
+                <a:ea typeface="Space Grotesk" pitchFamily="34" charset="-122"/>
+                <a:cs typeface="Space Grotesk" pitchFamily="34" charset="-120"/>
+              </a:rPr>
               <a:t>Mohammad Sahil • Zainab Memon</a:t>
             </a:r>
             <a:endParaRPr lang="en-US" sz="2200" dirty="0"/>
@@ -1946,6 +1994,14 @@
               <a:buNone/>
             </a:pPr>
             <a:r>
+              <a:rPr lang="en-US" altLang="en-US" sz="1800" dirty="0">
+                <a:solidFill>
+                  <a:srgbClr val="00E5FF"/>
+                </a:solidFill>
+                <a:latin typeface="Inter" pitchFamily="34" charset="0"/>
+                <a:ea typeface="Inter" pitchFamily="34" charset="-122"/>
+                <a:cs typeface="Inter" pitchFamily="34" charset="-120"/>
+              </a:rPr>
               <a:t>Tech Creature Solutions</a:t>
             </a:r>
             <a:endParaRPr lang="en-US" sz="1800" dirty="0"/>
@@ -1977,6 +2033,14 @@
               <a:buNone/>
             </a:pPr>
             <a:r>
+              <a:rPr lang="en-US" altLang="en-US" sz="1500" dirty="0">
+                <a:solidFill>
+                  <a:srgbClr val="8B9BB4"/>
+                </a:solidFill>
+                <a:latin typeface="Inter" pitchFamily="34" charset="0"/>
+                <a:ea typeface="Inter" pitchFamily="34" charset="-122"/>
+                <a:cs typeface="Inter" pitchFamily="34" charset="-120"/>
+              </a:rPr>
               <a:t>GLS University • Faculty of Engineering and Technology</a:t>
             </a:r>
             <a:endParaRPr lang="en-US" sz="1500" dirty="0"/>
@@ -2008,7 +2072,15 @@
               <a:buNone/>
             </a:pPr>
             <a:r>
-              <a:t>SYSTEM BRIEF // GLS NEXUS 2026 // SEC-01 • LIVE: aegis-nexus-alpha.vercel.app</a:t>
+              <a:rPr lang="en-US" altLang="en-US" sz="1100" dirty="0">
+                <a:solidFill>
+                  <a:srgbClr val="8B9BB4"/>
+                </a:solidFill>
+                <a:latin typeface="JetBrains Mono" pitchFamily="34" charset="0"/>
+                <a:ea typeface="JetBrains Mono" pitchFamily="34" charset="-122"/>
+                <a:cs typeface="JetBrains Mono" pitchFamily="34" charset="-120"/>
+              </a:rPr>
+              <a:t>SYSTEM BRIEF // NEXUS 2026 // SEC-01</a:t>
             </a:r>
             <a:endParaRPr lang="en-US" sz="1100" dirty="0"/>
           </a:p>
@@ -2100,6 +2172,14 @@
               <a:buNone/>
             </a:pPr>
             <a:r>
+              <a:rPr lang="en-US" altLang="en-US" sz="1300" dirty="0">
+                <a:solidFill>
+                  <a:srgbClr val="00E5FF"/>
+                </a:solidFill>
+                <a:latin typeface="JetBrains Mono" pitchFamily="34" charset="0"/>
+                <a:ea typeface="JetBrains Mono" pitchFamily="34" charset="-122"/>
+                <a:cs typeface="JetBrains Mono" pitchFamily="34" charset="-120"/>
+              </a:rPr>
               <a:t>MANDATORY 06 // ASSUMPTIONS + CHALLENGES + QUERIES</a:t>
             </a:r>
             <a:endParaRPr lang="en-US" sz="1300" dirty="0"/>
@@ -2131,6 +2211,14 @@
               <a:buNone/>
             </a:pPr>
             <a:r>
+              <a:rPr lang="en-US" altLang="en-US" sz="1200" dirty="0">
+                <a:solidFill>
+                  <a:srgbClr val="8B9BB4"/>
+                </a:solidFill>
+                <a:latin typeface="JetBrains Mono" pitchFamily="34" charset="0"/>
+                <a:ea typeface="JetBrains Mono" pitchFamily="34" charset="-122"/>
+                <a:cs typeface="JetBrains Mono" pitchFamily="34" charset="-120"/>
+              </a:rPr>
               <a:t>NEXUS 2026</a:t>
             </a:r>
             <a:endParaRPr lang="en-US" sz="1200" dirty="0"/>
@@ -2162,6 +2250,14 @@
               <a:buNone/>
             </a:pPr>
             <a:r>
+              <a:rPr lang="en-US" altLang="en-US" sz="4300" dirty="0">
+                <a:solidFill>
+                  <a:srgbClr val="FFFFFF"/>
+                </a:solidFill>
+                <a:latin typeface="Space Grotesk" pitchFamily="34" charset="0"/>
+                <a:ea typeface="Space Grotesk" pitchFamily="34" charset="-122"/>
+                <a:cs typeface="Space Grotesk" pitchFamily="34" charset="-120"/>
+              </a:rPr>
               <a:t>Ambitious by design. Responsible by default.</a:t>
             </a:r>
             <a:endParaRPr lang="en-US" sz="4300" dirty="0"/>
@@ -2193,6 +2289,14 @@
               <a:buNone/>
             </a:pPr>
             <a:r>
+              <a:rPr lang="en-US" altLang="en-US" sz="1800" dirty="0">
+                <a:solidFill>
+                  <a:srgbClr val="8B9BB4"/>
+                </a:solidFill>
+                <a:latin typeface="Inter" pitchFamily="34" charset="0"/>
+                <a:ea typeface="Inter" pitchFamily="34" charset="-122"/>
+                <a:cs typeface="Inter" pitchFamily="34" charset="-120"/>
+              </a:rPr>
               <a:t>A credible prototype declares its boundaries, risks, safeguards, and open questions clearly.</a:t>
             </a:r>
             <a:endParaRPr lang="en-US" sz="1800" dirty="0"/>
@@ -2253,6 +2357,14 @@
               <a:buNone/>
             </a:pPr>
             <a:r>
+              <a:rPr lang="en-US" altLang="en-US" sz="1300" dirty="0">
+                <a:solidFill>
+                  <a:srgbClr val="00E5FF"/>
+                </a:solidFill>
+                <a:latin typeface="JetBrains Mono" pitchFamily="34" charset="0"/>
+                <a:ea typeface="JetBrains Mono" pitchFamily="34" charset="-122"/>
+                <a:cs typeface="JetBrains Mono" pitchFamily="34" charset="-120"/>
+              </a:rPr>
               <a:t>PROTOTYPE ASSUMPTIONS</a:t>
             </a:r>
             <a:endParaRPr lang="en-US" sz="1300" dirty="0"/>
@@ -2308,6 +2420,14 @@
               <a:buNone/>
             </a:pPr>
             <a:r>
+              <a:rPr lang="en-US" altLang="en-US" sz="1700" dirty="0">
+                <a:solidFill>
+                  <a:srgbClr val="FFFFFF"/>
+                </a:solidFill>
+                <a:latin typeface="Inter" pitchFamily="34" charset="0"/>
+                <a:ea typeface="Inter" pitchFamily="34" charset="-122"/>
+                <a:cs typeface="Inter" pitchFamily="34" charset="-120"/>
+              </a:rPr>
               <a:t>Simulated or uploaded test events are used instead of live corporate data.</a:t>
             </a:r>
             <a:endParaRPr lang="en-US" sz="1700" dirty="0"/>
@@ -2363,6 +2483,14 @@
               <a:buNone/>
             </a:pPr>
             <a:r>
+              <a:rPr lang="en-US" altLang="en-US" sz="1700" dirty="0">
+                <a:solidFill>
+                  <a:srgbClr val="FFFFFF"/>
+                </a:solidFill>
+                <a:latin typeface="Inter" pitchFamily="34" charset="0"/>
+                <a:ea typeface="Inter" pitchFamily="34" charset="-122"/>
+                <a:cs typeface="Inter" pitchFamily="34" charset="-120"/>
+              </a:rPr>
               <a:t>Pre-trained models and rules are used; no large model is trained from scratch.</a:t>
             </a:r>
             <a:endParaRPr lang="en-US" sz="1700" dirty="0"/>
@@ -2418,6 +2546,14 @@
               <a:buNone/>
             </a:pPr>
             <a:r>
+              <a:rPr lang="en-US" altLang="en-US" sz="1700" dirty="0">
+                <a:solidFill>
+                  <a:srgbClr val="FFFFFF"/>
+                </a:solidFill>
+                <a:latin typeface="Inter" pitchFamily="34" charset="0"/>
+                <a:ea typeface="Inter" pitchFamily="34" charset="-122"/>
+                <a:cs typeface="Inter" pitchFamily="34" charset="-120"/>
+              </a:rPr>
               <a:t>Not every event includes text, audio, video, identity, and network signals.</a:t>
             </a:r>
             <a:endParaRPr lang="en-US" sz="1700" dirty="0"/>
@@ -2478,6 +2614,14 @@
               <a:buNone/>
             </a:pPr>
             <a:r>
+              <a:rPr lang="en-US" altLang="en-US" sz="1300" dirty="0">
+                <a:solidFill>
+                  <a:srgbClr val="FFB300"/>
+                </a:solidFill>
+                <a:latin typeface="JetBrains Mono" pitchFamily="34" charset="0"/>
+                <a:ea typeface="JetBrains Mono" pitchFamily="34" charset="-122"/>
+                <a:cs typeface="JetBrains Mono" pitchFamily="34" charset="-120"/>
+              </a:rPr>
               <a:t>CHALLENGE → MITIGATION</a:t>
             </a:r>
             <a:endParaRPr lang="en-US" sz="1300" dirty="0"/>
@@ -2509,6 +2653,14 @@
               <a:buNone/>
             </a:pPr>
             <a:r>
+              <a:rPr lang="en-US" altLang="en-US" sz="1900" dirty="0">
+                <a:solidFill>
+                  <a:srgbClr val="FFFFFF"/>
+                </a:solidFill>
+                <a:latin typeface="Space Grotesk" pitchFamily="34" charset="0"/>
+                <a:ea typeface="Space Grotesk" pitchFamily="34" charset="-122"/>
+                <a:cs typeface="Space Grotesk" pitchFamily="34" charset="-120"/>
+              </a:rPr>
               <a:t>False alerts</a:t>
             </a:r>
             <a:endParaRPr lang="en-US" sz="1900" dirty="0"/>
@@ -2540,6 +2692,14 @@
               <a:buNone/>
             </a:pPr>
             <a:r>
+              <a:rPr lang="en-US" altLang="en-US" sz="1600" dirty="0">
+                <a:solidFill>
+                  <a:srgbClr val="8B9BB4"/>
+                </a:solidFill>
+                <a:latin typeface="Inter" pitchFamily="34" charset="0"/>
+                <a:ea typeface="Inter" pitchFamily="34" charset="-122"/>
+                <a:cs typeface="Inter" pitchFamily="34" charset="-120"/>
+              </a:rPr>
               <a:t>Risk bands, confidence, evidence, thresholds, analyst review.</a:t>
             </a:r>
             <a:endParaRPr lang="en-US" sz="1600" dirty="0"/>
@@ -2597,6 +2757,14 @@
               <a:buNone/>
             </a:pPr>
             <a:r>
+              <a:rPr lang="en-US" altLang="en-US" sz="1900" dirty="0">
+                <a:solidFill>
+                  <a:srgbClr val="FFFFFF"/>
+                </a:solidFill>
+                <a:latin typeface="Space Grotesk" pitchFamily="34" charset="0"/>
+                <a:ea typeface="Space Grotesk" pitchFamily="34" charset="-122"/>
+                <a:cs typeface="Space Grotesk" pitchFamily="34" charset="-120"/>
+              </a:rPr>
               <a:t>Privacy + biometrics</a:t>
             </a:r>
             <a:endParaRPr lang="en-US" sz="1900" dirty="0"/>
@@ -2628,6 +2796,14 @@
               <a:buNone/>
             </a:pPr>
             <a:r>
+              <a:rPr lang="en-US" altLang="en-US" sz="1600" dirty="0">
+                <a:solidFill>
+                  <a:srgbClr val="8B9BB4"/>
+                </a:solidFill>
+                <a:latin typeface="Inter" pitchFamily="34" charset="0"/>
+                <a:ea typeface="Inter" pitchFamily="34" charset="-122"/>
+                <a:cs typeface="Inter" pitchFamily="34" charset="-120"/>
+              </a:rPr>
               <a:t>Consent-based samples, minimal storage, restricted access.</a:t>
             </a:r>
             <a:endParaRPr lang="en-US" sz="1600" dirty="0"/>
@@ -2685,6 +2861,14 @@
               <a:buNone/>
             </a:pPr>
             <a:r>
+              <a:rPr lang="en-US" altLang="en-US" sz="1900" dirty="0">
+                <a:solidFill>
+                  <a:srgbClr val="FFFFFF"/>
+                </a:solidFill>
+                <a:latin typeface="Space Grotesk" pitchFamily="34" charset="0"/>
+                <a:ea typeface="Space Grotesk" pitchFamily="34" charset="-122"/>
+                <a:cs typeface="Space Grotesk" pitchFamily="34" charset="-120"/>
+              </a:rPr>
               <a:t>Latency + scope</a:t>
             </a:r>
             <a:endParaRPr lang="en-US" sz="1900" dirty="0"/>
@@ -2716,6 +2900,14 @@
               <a:buNone/>
             </a:pPr>
             <a:r>
+              <a:rPr lang="en-US" altLang="en-US" sz="1600" dirty="0">
+                <a:solidFill>
+                  <a:srgbClr val="8B9BB4"/>
+                </a:solidFill>
+                <a:latin typeface="Inter" pitchFamily="34" charset="0"/>
+                <a:ea typeface="Inter" pitchFamily="34" charset="-122"/>
+                <a:cs typeface="Inter" pitchFamily="34" charset="-120"/>
+              </a:rPr>
               <a:t>Lightweight checks first; deeper checks run in parallel; critical actions need analyst approval.</a:t>
             </a:r>
             <a:endParaRPr lang="en-US" sz="1600" dirty="0"/>
@@ -2778,6 +2970,14 @@
               <a:buNone/>
             </a:pPr>
             <a:r>
+              <a:rPr lang="en-US" altLang="en-US" sz="1200" dirty="0">
+                <a:solidFill>
+                  <a:srgbClr val="FFB300"/>
+                </a:solidFill>
+                <a:latin typeface="JetBrains Mono" pitchFamily="34" charset="0"/>
+                <a:ea typeface="JetBrains Mono" pitchFamily="34" charset="-122"/>
+                <a:cs typeface="JetBrains Mono" pitchFamily="34" charset="-120"/>
+              </a:rPr>
               <a:t>OPEN QUERIES</a:t>
             </a:r>
             <a:endParaRPr lang="en-US" sz="1200" dirty="0"/>
@@ -2809,6 +3009,14 @@
               <a:buNone/>
             </a:pPr>
             <a:r>
+              <a:rPr lang="en-US" altLang="en-US" sz="1500" dirty="0">
+                <a:solidFill>
+                  <a:srgbClr val="FFFFFF"/>
+                </a:solidFill>
+                <a:latin typeface="Inter" pitchFamily="34" charset="0"/>
+                <a:ea typeface="Inter" pitchFamily="34" charset="-122"/>
+                <a:cs typeface="Inter" pitchFamily="34" charset="-120"/>
+              </a:rPr>
               <a:t>Are simulated data and pre-trained models acceptable? Which evaluation criterion matters most: accuracy, workflow, UX, or response?</a:t>
             </a:r>
             <a:endParaRPr lang="en-US" sz="1500" dirty="0"/>
@@ -2840,6 +3048,14 @@
               <a:buNone/>
             </a:pPr>
             <a:r>
+              <a:rPr lang="en-US" altLang="en-US" sz="1200" dirty="0">
+                <a:solidFill>
+                  <a:srgbClr val="8B9BB4"/>
+                </a:solidFill>
+                <a:latin typeface="JetBrains Mono" pitchFamily="34" charset="0"/>
+                <a:ea typeface="JetBrains Mono" pitchFamily="34" charset="-122"/>
+                <a:cs typeface="JetBrains Mono" pitchFamily="34" charset="-120"/>
+              </a:rPr>
               <a:t>SEC-10 // SAFETY</a:t>
             </a:r>
             <a:endParaRPr lang="en-US" sz="1200" dirty="0"/>
@@ -2932,6 +3148,14 @@
               <a:buNone/>
             </a:pPr>
             <a:r>
+              <a:rPr lang="en-US" altLang="en-US" sz="1300" dirty="0">
+                <a:solidFill>
+                  <a:srgbClr val="00E5FF"/>
+                </a:solidFill>
+                <a:latin typeface="JetBrains Mono" pitchFamily="34" charset="0"/>
+                <a:ea typeface="JetBrains Mono" pitchFamily="34" charset="-122"/>
+                <a:cs typeface="JetBrains Mono" pitchFamily="34" charset="-120"/>
+              </a:rPr>
               <a:t>10 // EXPECTED OUTCOME</a:t>
             </a:r>
             <a:endParaRPr lang="en-US" sz="1300" dirty="0"/>
@@ -2963,6 +3187,14 @@
               <a:buNone/>
             </a:pPr>
             <a:r>
+              <a:rPr lang="en-US" altLang="en-US" sz="1200" dirty="0">
+                <a:solidFill>
+                  <a:srgbClr val="8B9BB4"/>
+                </a:solidFill>
+                <a:latin typeface="JetBrains Mono" pitchFamily="34" charset="0"/>
+                <a:ea typeface="JetBrains Mono" pitchFamily="34" charset="-122"/>
+                <a:cs typeface="JetBrains Mono" pitchFamily="34" charset="-120"/>
+              </a:rPr>
               <a:t>NEXUS 2026</a:t>
             </a:r>
             <a:endParaRPr lang="en-US" sz="1200" dirty="0"/>
@@ -2994,6 +3226,14 @@
               <a:buNone/>
             </a:pPr>
             <a:r>
+              <a:rPr lang="en-US" altLang="en-US" sz="4400" dirty="0">
+                <a:solidFill>
+                  <a:srgbClr val="FFFFFF"/>
+                </a:solidFill>
+                <a:latin typeface="Space Grotesk" pitchFamily="34" charset="0"/>
+                <a:ea typeface="Space Grotesk" pitchFamily="34" charset="-122"/>
+                <a:cs typeface="Space Grotesk" pitchFamily="34" charset="-120"/>
+              </a:rPr>
               <a:t>The outcome: earlier, clearer, safer decisions</a:t>
             </a:r>
             <a:endParaRPr lang="en-US" sz="4400" dirty="0"/>
@@ -3025,6 +3265,14 @@
               <a:buNone/>
             </a:pPr>
             <a:r>
+              <a:rPr lang="en-US" altLang="en-US" sz="1800" dirty="0">
+                <a:solidFill>
+                  <a:srgbClr val="8B9BB4"/>
+                </a:solidFill>
+                <a:latin typeface="Inter" pitchFamily="34" charset="0"/>
+                <a:ea typeface="Inter" pitchFamily="34" charset="-122"/>
+                <a:cs typeface="Inter" pitchFamily="34" charset="-120"/>
+              </a:rPr>
               <a:t>AegisNexus turns isolated indicators into action-ready intelligence for people and security teams.</a:t>
             </a:r>
             <a:endParaRPr lang="en-US" sz="1800" dirty="0"/>
@@ -3109,7 +3357,15 @@
               <a:buNone/>
             </a:pPr>
             <a:r>
-              <a:t>85% Faster Investigation: Flags multi-channel BEC before wire release.</a:t>
+              <a:rPr lang="en-US" altLang="en-US" sz="2200" dirty="0">
+                <a:solidFill>
+                  <a:srgbClr val="FFFFFF"/>
+                </a:solidFill>
+                <a:latin typeface="Space Grotesk" pitchFamily="34" charset="0"/>
+                <a:ea typeface="Space Grotesk" pitchFamily="34" charset="-122"/>
+                <a:cs typeface="Space Grotesk" pitchFamily="34" charset="-120"/>
+              </a:rPr>
+              <a:t>Earlier detection</a:t>
             </a:r>
             <a:endParaRPr lang="en-US" sz="2200" dirty="0"/>
           </a:p>
@@ -3140,6 +3396,14 @@
               <a:buNone/>
             </a:pPr>
             <a:r>
+              <a:rPr lang="en-US" altLang="en-US" sz="1600" dirty="0">
+                <a:solidFill>
+                  <a:srgbClr val="8B9BB4"/>
+                </a:solidFill>
+                <a:latin typeface="Inter" pitchFamily="34" charset="0"/>
+                <a:ea typeface="Inter" pitchFamily="34" charset="-122"/>
+                <a:cs typeface="Inter" pitchFamily="34" charset="-120"/>
+              </a:rPr>
               <a:t>Flag suspicious activity before a risky action completes.</a:t>
             </a:r>
             <a:endParaRPr lang="en-US" sz="1600" dirty="0"/>
@@ -3224,7 +3488,15 @@
               <a:buNone/>
             </a:pPr>
             <a:r>
-              <a:t>Cross-Modal Confidence: Correlates 5 modalities instead of siloed alerts.</a:t>
+              <a:rPr lang="en-US" altLang="en-US" sz="2200" dirty="0">
+                <a:solidFill>
+                  <a:srgbClr val="FFFFFF"/>
+                </a:solidFill>
+                <a:latin typeface="Space Grotesk" pitchFamily="34" charset="0"/>
+                <a:ea typeface="Space Grotesk" pitchFamily="34" charset="-122"/>
+                <a:cs typeface="Space Grotesk" pitchFamily="34" charset="-120"/>
+              </a:rPr>
+              <a:t>Cross-modal confidence</a:t>
             </a:r>
             <a:endParaRPr lang="en-US" sz="2200" dirty="0"/>
           </a:p>
@@ -3255,6 +3527,14 @@
               <a:buNone/>
             </a:pPr>
             <a:r>
+              <a:rPr lang="en-US" altLang="en-US" sz="1600" dirty="0">
+                <a:solidFill>
+                  <a:srgbClr val="8B9BB4"/>
+                </a:solidFill>
+                <a:latin typeface="Inter" pitchFamily="34" charset="0"/>
+                <a:ea typeface="Inter" pitchFamily="34" charset="-122"/>
+                <a:cs typeface="Inter" pitchFamily="34" charset="-120"/>
+              </a:rPr>
               <a:t>Combine evidence sources instead of trusting one clue.</a:t>
             </a:r>
             <a:endParaRPr lang="en-US" sz="1600" dirty="0"/>
@@ -3339,7 +3619,15 @@
               <a:buNone/>
             </a:pPr>
             <a:r>
-              <a:t>Topological Memory: Maps infrastructure, ASN, and identity anomalies.</a:t>
+              <a:rPr lang="en-US" altLang="en-US" sz="2200" dirty="0">
+                <a:solidFill>
+                  <a:srgbClr val="FFFFFF"/>
+                </a:solidFill>
+                <a:latin typeface="Space Grotesk" pitchFamily="34" charset="0"/>
+                <a:ea typeface="Space Grotesk" pitchFamily="34" charset="-122"/>
+                <a:cs typeface="Space Grotesk" pitchFamily="34" charset="-120"/>
+              </a:rPr>
+              <a:t>Campaign visibility</a:t>
             </a:r>
             <a:endParaRPr lang="en-US" sz="2200" dirty="0"/>
           </a:p>
@@ -3370,6 +3658,14 @@
               <a:buNone/>
             </a:pPr>
             <a:r>
+              <a:rPr lang="en-US" altLang="en-US" sz="1600" dirty="0">
+                <a:solidFill>
+                  <a:srgbClr val="8B9BB4"/>
+                </a:solidFill>
+                <a:latin typeface="Inter" pitchFamily="34" charset="0"/>
+                <a:ea typeface="Inter" pitchFamily="34" charset="-122"/>
+                <a:cs typeface="Inter" pitchFamily="34" charset="-120"/>
+              </a:rPr>
               <a:t>Transform related indicators into one incident view.</a:t>
             </a:r>
             <a:endParaRPr lang="en-US" sz="1600" dirty="0"/>
@@ -3454,7 +3750,15 @@
               <a:buNone/>
             </a:pPr>
             <a:r>
-              <a:t>Explainable Verdict: Transparent 0–100 risk score with zero hallucinations.</a:t>
+              <a:rPr lang="en-US" altLang="en-US" sz="2200" dirty="0">
+                <a:solidFill>
+                  <a:srgbClr val="FFFFFF"/>
+                </a:solidFill>
+                <a:latin typeface="Space Grotesk" pitchFamily="34" charset="0"/>
+                <a:ea typeface="Space Grotesk" pitchFamily="34" charset="-122"/>
+                <a:cs typeface="Space Grotesk" pitchFamily="34" charset="-120"/>
+              </a:rPr>
+              <a:t>Explainable security</a:t>
             </a:r>
             <a:endParaRPr lang="en-US" sz="2200" dirty="0"/>
           </a:p>
@@ -3485,6 +3789,14 @@
               <a:buNone/>
             </a:pPr>
             <a:r>
+              <a:rPr lang="en-US" altLang="en-US" sz="1600" dirty="0">
+                <a:solidFill>
+                  <a:srgbClr val="8B9BB4"/>
+                </a:solidFill>
+                <a:latin typeface="Inter" pitchFamily="34" charset="0"/>
+                <a:ea typeface="Inter" pitchFamily="34" charset="-122"/>
+                <a:cs typeface="Inter" pitchFamily="34" charset="-120"/>
+              </a:rPr>
               <a:t>Show score, evidence, graph, and recommended response.</a:t>
             </a:r>
             <a:endParaRPr lang="en-US" sz="1600" dirty="0"/>
@@ -3569,7 +3881,15 @@
               <a:buNone/>
             </a:pPr>
             <a:r>
-              <a:t>Human-in-the-Loop Gate: Mitigates risk while preserving executive control.</a:t>
+              <a:rPr lang="en-US" altLang="en-US" sz="2200" dirty="0">
+                <a:solidFill>
+                  <a:srgbClr val="FFFFFF"/>
+                </a:solidFill>
+                <a:latin typeface="Space Grotesk" pitchFamily="34" charset="0"/>
+                <a:ea typeface="Space Grotesk" pitchFamily="34" charset="-122"/>
+                <a:cs typeface="Space Grotesk" pitchFamily="34" charset="-120"/>
+              </a:rPr>
+              <a:t>Safer response</a:t>
             </a:r>
             <a:endParaRPr lang="en-US" sz="2200" dirty="0"/>
           </a:p>
@@ -3600,6 +3920,14 @@
               <a:buNone/>
             </a:pPr>
             <a:r>
+              <a:rPr lang="en-US" altLang="en-US" sz="1600" dirty="0">
+                <a:solidFill>
+                  <a:srgbClr val="8B9BB4"/>
+                </a:solidFill>
+                <a:latin typeface="Inter" pitchFamily="34" charset="0"/>
+                <a:ea typeface="Inter" pitchFamily="34" charset="-122"/>
+                <a:cs typeface="Inter" pitchFamily="34" charset="-120"/>
+              </a:rPr>
               <a:t>Contain risk while preserving human control.</a:t>
             </a:r>
             <a:endParaRPr lang="en-US" sz="1600" dirty="0"/>
@@ -3631,6 +3959,14 @@
               <a:buNone/>
             </a:pPr>
             <a:r>
+              <a:rPr lang="en-US" altLang="en-US" sz="1200" dirty="0">
+                <a:solidFill>
+                  <a:srgbClr val="8B9BB4"/>
+                </a:solidFill>
+                <a:latin typeface="JetBrains Mono" pitchFamily="34" charset="0"/>
+                <a:ea typeface="JetBrains Mono" pitchFamily="34" charset="-122"/>
+                <a:cs typeface="JetBrains Mono" pitchFamily="34" charset="-120"/>
+              </a:rPr>
               <a:t>SEC-11 // OUTCOMES</a:t>
             </a:r>
             <a:endParaRPr lang="en-US" sz="1200" dirty="0"/>
@@ -3771,6 +4107,14 @@
               <a:buNone/>
             </a:pPr>
             <a:r>
+              <a:rPr lang="en-US" altLang="en-US" sz="1300" dirty="0">
+                <a:solidFill>
+                  <a:srgbClr val="00E5FF"/>
+                </a:solidFill>
+                <a:latin typeface="JetBrains Mono" pitchFamily="34" charset="0"/>
+                <a:ea typeface="JetBrains Mono" pitchFamily="34" charset="-122"/>
+                <a:cs typeface="JetBrains Mono" pitchFamily="34" charset="-120"/>
+              </a:rPr>
               <a:t>NEXUS 2026 // FINAL PROTOCOL</a:t>
             </a:r>
             <a:endParaRPr lang="en-US" sz="1300" dirty="0"/>
@@ -3802,6 +4146,14 @@
               <a:buNone/>
             </a:pPr>
             <a:r>
+              <a:rPr lang="en-US" altLang="en-US" sz="5200" dirty="0">
+                <a:solidFill>
+                  <a:srgbClr val="FFFFFF"/>
+                </a:solidFill>
+                <a:latin typeface="Space Grotesk" pitchFamily="34" charset="0"/>
+                <a:ea typeface="Space Grotesk" pitchFamily="34" charset="-122"/>
+                <a:cs typeface="Space Grotesk" pitchFamily="34" charset="-120"/>
+              </a:rPr>
               <a:t>Detect the signal. Verify the identity.</a:t>
             </a:r>
             <a:endParaRPr lang="en-US" sz="5200" dirty="0"/>
@@ -3833,6 +4185,14 @@
               <a:buNone/>
             </a:pPr>
             <a:r>
+              <a:rPr lang="en-US" altLang="en-US" sz="5200" dirty="0">
+                <a:solidFill>
+                  <a:srgbClr val="00E5FF"/>
+                </a:solidFill>
+                <a:latin typeface="Space Grotesk" pitchFamily="34" charset="0"/>
+                <a:ea typeface="Space Grotesk" pitchFamily="34" charset="-122"/>
+                <a:cs typeface="Space Grotesk" pitchFamily="34" charset="-120"/>
+              </a:rPr>
               <a:t>Correlate the threat. Make the response safe.</a:t>
             </a:r>
             <a:endParaRPr lang="en-US" sz="5200" dirty="0"/>
@@ -3890,6 +4250,14 @@
               <a:buNone/>
             </a:pPr>
             <a:r>
+              <a:rPr lang="en-US" altLang="en-US" sz="2300" dirty="0">
+                <a:solidFill>
+                  <a:srgbClr val="FFFFFF"/>
+                </a:solidFill>
+                <a:latin typeface="Space Grotesk" pitchFamily="34" charset="0"/>
+                <a:ea typeface="Space Grotesk" pitchFamily="34" charset="-122"/>
+                <a:cs typeface="Space Grotesk" pitchFamily="34" charset="-120"/>
+              </a:rPr>
               <a:t>Tech Creature Solutions</a:t>
             </a:r>
             <a:endParaRPr lang="en-US" sz="2300" dirty="0"/>
@@ -3921,6 +4289,14 @@
               <a:buNone/>
             </a:pPr>
             <a:r>
+              <a:rPr lang="en-US" altLang="en-US" sz="1800" dirty="0">
+                <a:solidFill>
+                  <a:srgbClr val="00E5FF"/>
+                </a:solidFill>
+                <a:latin typeface="Inter" pitchFamily="34" charset="0"/>
+                <a:ea typeface="Inter" pitchFamily="34" charset="-122"/>
+                <a:cs typeface="Inter" pitchFamily="34" charset="-120"/>
+              </a:rPr>
               <a:t>Mohammad Sahil • Zainab Memon</a:t>
             </a:r>
             <a:endParaRPr lang="en-US" sz="1800" dirty="0"/>
@@ -3952,6 +4328,14 @@
               <a:buNone/>
             </a:pPr>
             <a:r>
+              <a:rPr lang="en-US" altLang="en-US" sz="1600" dirty="0">
+                <a:solidFill>
+                  <a:srgbClr val="8B9BB4"/>
+                </a:solidFill>
+                <a:latin typeface="Inter" pitchFamily="34" charset="0"/>
+                <a:ea typeface="Inter" pitchFamily="34" charset="-122"/>
+                <a:cs typeface="Inter" pitchFamily="34" charset="-120"/>
+              </a:rPr>
               <a:t>AegisNexus — AI-Powered Deepfake and Phishing Defense</a:t>
             </a:r>
             <a:endParaRPr lang="en-US" sz="1600" dirty="0"/>
@@ -3983,7 +4367,15 @@
               <a:buNone/>
             </a:pPr>
             <a:r>
-              <a:t>THANK YOU // QUESTIONS &amp; DEMO</a:t>
+              <a:rPr lang="en-US" altLang="en-US" sz="1400" dirty="0">
+                <a:solidFill>
+                  <a:srgbClr val="00E5FF"/>
+                </a:solidFill>
+                <a:latin typeface="JetBrains Mono" pitchFamily="34" charset="0"/>
+                <a:ea typeface="JetBrains Mono" pitchFamily="34" charset="-122"/>
+                <a:cs typeface="JetBrains Mono" pitchFamily="34" charset="-120"/>
+              </a:rPr>
+              <a:t>THANK YOU // QUESTIONS</a:t>
             </a:r>
             <a:endParaRPr lang="en-US" sz="1400" dirty="0"/>
           </a:p>
@@ -4014,7 +4406,15 @@
               <a:buNone/>
             </a:pPr>
             <a:r>
-              <a:t>LIVE POC: aegis-nexus-alpha.vercel.app • GITHUB: sahilshaikh1101/AegisNexus-NexusHackathon</a:t>
+              <a:rPr lang="en-US" altLang="en-US" sz="1100" dirty="0">
+                <a:solidFill>
+                  <a:srgbClr val="8B9BB4"/>
+                </a:solidFill>
+                <a:latin typeface="JetBrains Mono" pitchFamily="34" charset="0"/>
+                <a:ea typeface="JetBrains Mono" pitchFamily="34" charset="-122"/>
+                <a:cs typeface="JetBrains Mono" pitchFamily="34" charset="-120"/>
+              </a:rPr>
+              <a:t>SYSTEM CLOSE // TECH CREATURE SOLUTIONS</a:t>
             </a:r>
             <a:endParaRPr lang="en-US" sz="1100" dirty="0"/>
           </a:p>
@@ -4106,6 +4506,14 @@
               <a:buNone/>
             </a:pPr>
             <a:r>
+              <a:rPr lang="en-US" altLang="en-US" sz="1300" dirty="0">
+                <a:solidFill>
+                  <a:srgbClr val="00E5FF"/>
+                </a:solidFill>
+                <a:latin typeface="JetBrains Mono" pitchFamily="34" charset="0"/>
+                <a:ea typeface="JetBrains Mono" pitchFamily="34" charset="-122"/>
+                <a:cs typeface="JetBrains Mono" pitchFamily="34" charset="-120"/>
+              </a:rPr>
               <a:t>MANDATORY 01 // PROBLEM STATEMENT</a:t>
             </a:r>
             <a:endParaRPr lang="en-US" sz="1300" dirty="0"/>
@@ -4137,6 +4545,14 @@
               <a:buNone/>
             </a:pPr>
             <a:r>
+              <a:rPr lang="en-US" altLang="en-US" sz="1200" dirty="0">
+                <a:solidFill>
+                  <a:srgbClr val="8B9BB4"/>
+                </a:solidFill>
+                <a:latin typeface="JetBrains Mono" pitchFamily="34" charset="0"/>
+                <a:ea typeface="JetBrains Mono" pitchFamily="34" charset="-122"/>
+                <a:cs typeface="JetBrains Mono" pitchFamily="34" charset="-120"/>
+              </a:rPr>
               <a:t>NEXUS 2026</a:t>
             </a:r>
             <a:endParaRPr lang="en-US" sz="1200" dirty="0"/>
@@ -4171,6 +4587,14 @@
               <a:buNone/>
             </a:pPr>
             <a:r>
+              <a:rPr lang="en-US" altLang="en-US" sz="4700" dirty="0">
+                <a:solidFill>
+                  <a:srgbClr val="FFFFFF"/>
+                </a:solidFill>
+                <a:latin typeface="Space Grotesk" pitchFamily="34" charset="0"/>
+                <a:ea typeface="Space Grotesk" pitchFamily="34" charset="-122"/>
+                <a:cs typeface="Space Grotesk" pitchFamily="34" charset="-120"/>
+              </a:rPr>
               <a:t>AI turned one phishing email into a coordinated impersonation attack</a:t>
             </a:r>
             <a:endParaRPr lang="en-US" sz="4700" dirty="0"/>
@@ -4255,6 +4679,14 @@
               <a:buNone/>
             </a:pPr>
             <a:r>
+              <a:rPr lang="en-US" altLang="en-US" sz="2100" dirty="0">
+                <a:solidFill>
+                  <a:srgbClr val="FFFFFF"/>
+                </a:solidFill>
+                <a:latin typeface="Space Grotesk" pitchFamily="34" charset="0"/>
+                <a:ea typeface="Space Grotesk" pitchFamily="34" charset="-122"/>
+                <a:cs typeface="Space Grotesk" pitchFamily="34" charset="-120"/>
+              </a:rPr>
               <a:t>Polished phishing</a:t>
             </a:r>
             <a:endParaRPr lang="en-US" sz="2100" dirty="0"/>
@@ -4286,6 +4718,14 @@
               <a:buNone/>
             </a:pPr>
             <a:r>
+              <a:rPr lang="en-US" altLang="en-US" sz="1600" dirty="0">
+                <a:solidFill>
+                  <a:srgbClr val="8B9BB4"/>
+                </a:solidFill>
+                <a:latin typeface="Inter" pitchFamily="34" charset="0"/>
+                <a:ea typeface="Inter" pitchFamily="34" charset="-122"/>
+                <a:cs typeface="Inter" pitchFamily="34" charset="-120"/>
+              </a:rPr>
               <a:t>Trusted language, urgent payment requests, look-alike links.</a:t>
             </a:r>
             <a:endParaRPr lang="en-US" sz="1600" dirty="0"/>
@@ -4370,6 +4810,14 @@
               <a:buNone/>
             </a:pPr>
             <a:r>
+              <a:rPr lang="en-US" altLang="en-US" sz="2100" dirty="0">
+                <a:solidFill>
+                  <a:srgbClr val="FFFFFF"/>
+                </a:solidFill>
+                <a:latin typeface="Space Grotesk" pitchFamily="34" charset="0"/>
+                <a:ea typeface="Space Grotesk" pitchFamily="34" charset="-122"/>
+                <a:cs typeface="Space Grotesk" pitchFamily="34" charset="-120"/>
+              </a:rPr>
               <a:t>Synthetic presence</a:t>
             </a:r>
             <a:endParaRPr lang="en-US" sz="2100" dirty="0"/>
@@ -4401,6 +4849,14 @@
               <a:buNone/>
             </a:pPr>
             <a:r>
+              <a:rPr lang="en-US" altLang="en-US" sz="1600" dirty="0">
+                <a:solidFill>
+                  <a:srgbClr val="8B9BB4"/>
+                </a:solidFill>
+                <a:latin typeface="Inter" pitchFamily="34" charset="0"/>
+                <a:ea typeface="Inter" pitchFamily="34" charset="-122"/>
+                <a:cs typeface="Inter" pitchFamily="34" charset="-120"/>
+              </a:rPr>
               <a:t>Cloned voice and manipulated video imitate authority.</a:t>
             </a:r>
             <a:endParaRPr lang="en-US" sz="1600" dirty="0"/>
@@ -4485,6 +4941,14 @@
               <a:buNone/>
             </a:pPr>
             <a:r>
+              <a:rPr lang="en-US" altLang="en-US" sz="2100" dirty="0">
+                <a:solidFill>
+                  <a:srgbClr val="FFFFFF"/>
+                </a:solidFill>
+                <a:latin typeface="Space Grotesk" pitchFamily="34" charset="0"/>
+                <a:ea typeface="Space Grotesk" pitchFamily="34" charset="-122"/>
+                <a:cs typeface="Space Grotesk" pitchFamily="34" charset="-120"/>
+              </a:rPr>
               <a:t>Multiple channels</a:t>
             </a:r>
             <a:endParaRPr lang="en-US" sz="2100" dirty="0"/>
@@ -4516,6 +4980,14 @@
               <a:buNone/>
             </a:pPr>
             <a:r>
+              <a:rPr lang="en-US" altLang="en-US" sz="1600" dirty="0">
+                <a:solidFill>
+                  <a:srgbClr val="8B9BB4"/>
+                </a:solidFill>
+                <a:latin typeface="Inter" pitchFamily="34" charset="0"/>
+                <a:ea typeface="Inter" pitchFamily="34" charset="-122"/>
+                <a:cs typeface="Inter" pitchFamily="34" charset="-120"/>
+              </a:rPr>
               <a:t>Email, URL, voice, video, and network activity converge.</a:t>
             </a:r>
             <a:endParaRPr lang="en-US" sz="1600" dirty="0"/>
@@ -4598,7 +5070,15 @@
               <a:buNone/>
             </a:pPr>
             <a:r>
-              <a:t>Sources: FBI IC3 Report ($55.4B BEC Losses) • NSA &amp; CISA Deepfake Guidance</a:t>
+              <a:rPr lang="en-US" altLang="en-US" sz="1100" dirty="0">
+                <a:solidFill>
+                  <a:srgbClr val="8B9BB4"/>
+                </a:solidFill>
+                <a:latin typeface="JetBrains Mono" pitchFamily="34" charset="0"/>
+                <a:ea typeface="JetBrains Mono" pitchFamily="34" charset="-122"/>
+                <a:cs typeface="JetBrains Mono" pitchFamily="34" charset="-120"/>
+              </a:rPr>
+              <a:t>Sources: NSA, FBI &amp; CISA deepfake-threat guidance • FBI business-email-compromise guidance</a:t>
             </a:r>
             <a:endParaRPr lang="en-US" sz="1100" dirty="0"/>
           </a:p>
@@ -4629,6 +5109,14 @@
               <a:buNone/>
             </a:pPr>
             <a:r>
+              <a:rPr lang="en-US" altLang="en-US" sz="1200" dirty="0">
+                <a:solidFill>
+                  <a:srgbClr val="8B9BB4"/>
+                </a:solidFill>
+                <a:latin typeface="JetBrains Mono" pitchFamily="34" charset="0"/>
+                <a:ea typeface="JetBrains Mono" pitchFamily="34" charset="-122"/>
+                <a:cs typeface="JetBrains Mono" pitchFamily="34" charset="-120"/>
+              </a:rPr>
               <a:t>SEC-02 // THREAT</a:t>
             </a:r>
             <a:endParaRPr lang="en-US" sz="1200" dirty="0"/>
@@ -4721,6 +5209,14 @@
               <a:buNone/>
             </a:pPr>
             <a:r>
+              <a:rPr lang="en-US" altLang="en-US" sz="1300" dirty="0">
+                <a:solidFill>
+                  <a:srgbClr val="00E5FF"/>
+                </a:solidFill>
+                <a:latin typeface="JetBrains Mono" pitchFamily="34" charset="0"/>
+                <a:ea typeface="JetBrains Mono" pitchFamily="34" charset="-122"/>
+                <a:cs typeface="JetBrains Mono" pitchFamily="34" charset="-120"/>
+              </a:rPr>
               <a:t>PROBLEM DETAIL // WHY LEGACY CONTROLS MISS CAMPAIGNS</a:t>
             </a:r>
             <a:endParaRPr lang="en-US" sz="1300" dirty="0"/>
@@ -4752,6 +5248,14 @@
               <a:buNone/>
             </a:pPr>
             <a:r>
+              <a:rPr lang="en-US" altLang="en-US" sz="1200" dirty="0">
+                <a:solidFill>
+                  <a:srgbClr val="8B9BB4"/>
+                </a:solidFill>
+                <a:latin typeface="JetBrains Mono" pitchFamily="34" charset="0"/>
+                <a:ea typeface="JetBrains Mono" pitchFamily="34" charset="-122"/>
+                <a:cs typeface="JetBrains Mono" pitchFamily="34" charset="-120"/>
+              </a:rPr>
               <a:t>NEXUS 2026</a:t>
             </a:r>
             <a:endParaRPr lang="en-US" sz="1200" dirty="0"/>
@@ -4783,6 +5287,14 @@
               <a:buNone/>
             </a:pPr>
             <a:r>
+              <a:rPr lang="en-US" altLang="en-US" sz="4500" dirty="0">
+                <a:solidFill>
+                  <a:srgbClr val="FFFFFF"/>
+                </a:solidFill>
+                <a:latin typeface="Space Grotesk" pitchFamily="34" charset="0"/>
+                <a:ea typeface="Space Grotesk" pitchFamily="34" charset="-122"/>
+                <a:cs typeface="Space Grotesk" pitchFamily="34" charset="-120"/>
+              </a:rPr>
               <a:t>Separate alerts hide the full attack story</a:t>
             </a:r>
             <a:endParaRPr lang="en-US" sz="4500" dirty="0"/>
@@ -4814,6 +5326,14 @@
               <a:buNone/>
             </a:pPr>
             <a:r>
+              <a:rPr lang="en-US" altLang="en-US" sz="1800" dirty="0">
+                <a:solidFill>
+                  <a:srgbClr val="8B9BB4"/>
+                </a:solidFill>
+                <a:latin typeface="Inter" pitchFamily="34" charset="0"/>
+                <a:ea typeface="Inter" pitchFamily="34" charset="-122"/>
+                <a:cs typeface="Inter" pitchFamily="34" charset="-120"/>
+              </a:rPr>
               <a:t>Attackers coordinate signals; traditional tools often isolate them. AegisNexus correlates them before a payment or access decision is made.</a:t>
             </a:r>
             <a:endParaRPr lang="en-US" sz="1800" dirty="0"/>
@@ -4845,6 +5365,14 @@
               <a:buNone/>
             </a:pPr>
             <a:r>
+              <a:rPr lang="en-US" altLang="en-US" sz="1300" dirty="0">
+                <a:solidFill>
+                  <a:srgbClr val="FF007F"/>
+                </a:solidFill>
+                <a:latin typeface="JetBrains Mono" pitchFamily="34" charset="0"/>
+                <a:ea typeface="JetBrains Mono" pitchFamily="34" charset="-122"/>
+                <a:cs typeface="JetBrains Mono" pitchFamily="34" charset="-120"/>
+              </a:rPr>
               <a:t>TRADITIONAL VIEW // 4 SEPARATE ALERTS</a:t>
             </a:r>
             <a:endParaRPr lang="en-US" sz="1300" dirty="0"/>
@@ -4876,6 +5404,14 @@
               <a:buNone/>
             </a:pPr>
             <a:r>
+              <a:rPr lang="en-US" altLang="en-US" sz="1300" dirty="0">
+                <a:solidFill>
+                  <a:srgbClr val="00E5FF"/>
+                </a:solidFill>
+                <a:latin typeface="JetBrains Mono" pitchFamily="34" charset="0"/>
+                <a:ea typeface="JetBrains Mono" pitchFamily="34" charset="-122"/>
+                <a:cs typeface="JetBrains Mono" pitchFamily="34" charset="-120"/>
+              </a:rPr>
               <a:t>AEGISNEXUS VIEW // 1 CORRELATED INCIDENT</a:t>
             </a:r>
             <a:endParaRPr lang="en-US" sz="1300" dirty="0"/>
@@ -4960,6 +5496,14 @@
               <a:buNone/>
             </a:pPr>
             <a:r>
+              <a:rPr lang="en-US" altLang="en-US" sz="1700" dirty="0">
+                <a:solidFill>
+                  <a:srgbClr val="FFFFFF"/>
+                </a:solidFill>
+                <a:latin typeface="Inter" pitchFamily="34" charset="0"/>
+                <a:ea typeface="Inter" pitchFamily="34" charset="-122"/>
+                <a:cs typeface="Inter" pitchFamily="34" charset="-120"/>
+              </a:rPr>
               <a:t>Suspicious payment email</a:t>
             </a:r>
             <a:endParaRPr lang="en-US" sz="1700" dirty="0"/>
@@ -5044,6 +5588,14 @@
               <a:buNone/>
             </a:pPr>
             <a:r>
+              <a:rPr lang="en-US" altLang="en-US" sz="1700" dirty="0">
+                <a:solidFill>
+                  <a:srgbClr val="FFFFFF"/>
+                </a:solidFill>
+                <a:latin typeface="Inter" pitchFamily="34" charset="0"/>
+                <a:ea typeface="Inter" pitchFamily="34" charset="-122"/>
+                <a:cs typeface="Inter" pitchFamily="34" charset="-120"/>
+              </a:rPr>
               <a:t>Look-alike payment URL</a:t>
             </a:r>
             <a:endParaRPr lang="en-US" sz="1700" dirty="0"/>
@@ -5128,6 +5680,14 @@
               <a:buNone/>
             </a:pPr>
             <a:r>
+              <a:rPr lang="en-US" altLang="en-US" sz="1700" dirty="0">
+                <a:solidFill>
+                  <a:srgbClr val="FFFFFF"/>
+                </a:solidFill>
+                <a:latin typeface="Inter" pitchFamily="34" charset="0"/>
+                <a:ea typeface="Inter" pitchFamily="34" charset="-122"/>
+                <a:cs typeface="Inter" pitchFamily="34" charset="-120"/>
+              </a:rPr>
               <a:t>Unknown voice note</a:t>
             </a:r>
             <a:endParaRPr lang="en-US" sz="1700" dirty="0"/>
@@ -5212,6 +5772,14 @@
               <a:buNone/>
             </a:pPr>
             <a:r>
+              <a:rPr lang="en-US" altLang="en-US" sz="1700" dirty="0">
+                <a:solidFill>
+                  <a:srgbClr val="FFFFFF"/>
+                </a:solidFill>
+                <a:latin typeface="Inter" pitchFamily="34" charset="0"/>
+                <a:ea typeface="Inter" pitchFamily="34" charset="-122"/>
+                <a:cs typeface="Inter" pitchFamily="34" charset="-120"/>
+              </a:rPr>
               <a:t>Related domain activity</a:t>
             </a:r>
             <a:endParaRPr lang="en-US" sz="1700" dirty="0"/>
@@ -5274,6 +5842,14 @@
               <a:buNone/>
             </a:pPr>
             <a:r>
+              <a:rPr lang="en-US" altLang="en-US" sz="1200" dirty="0">
+                <a:solidFill>
+                  <a:srgbClr val="8B9BB4"/>
+                </a:solidFill>
+                <a:latin typeface="JetBrains Mono" pitchFamily="34" charset="0"/>
+                <a:ea typeface="JetBrains Mono" pitchFamily="34" charset="-122"/>
+                <a:cs typeface="JetBrains Mono" pitchFamily="34" charset="-120"/>
+              </a:rPr>
               <a:t>CORRELATE</a:t>
             </a:r>
             <a:endParaRPr lang="en-US" sz="1200" dirty="0"/>
@@ -5286,6 +5862,14 @@
               <a:buNone/>
             </a:pPr>
             <a:r>
+              <a:rPr lang="en-US" altLang="en-US" sz="1200" dirty="0">
+                <a:solidFill>
+                  <a:srgbClr val="8B9BB4"/>
+                </a:solidFill>
+                <a:latin typeface="JetBrains Mono" pitchFamily="34" charset="0"/>
+                <a:ea typeface="JetBrains Mono" pitchFamily="34" charset="-122"/>
+                <a:cs typeface="JetBrains Mono" pitchFamily="34" charset="-120"/>
+              </a:rPr>
               <a:t>EVIDENCE</a:t>
             </a:r>
             <a:endParaRPr lang="en-US" sz="1200" dirty="0"/>
@@ -5377,6 +5961,14 @@
               <a:buNone/>
             </a:pPr>
             <a:r>
+              <a:rPr lang="en-US" altLang="en-US" sz="1200" dirty="0">
+                <a:solidFill>
+                  <a:srgbClr val="0A0F1A"/>
+                </a:solidFill>
+                <a:latin typeface="JetBrains Mono" pitchFamily="34" charset="0"/>
+                <a:ea typeface="JetBrains Mono" pitchFamily="34" charset="-122"/>
+                <a:cs typeface="JetBrains Mono" pitchFamily="34" charset="-120"/>
+              </a:rPr>
               <a:t>HIGH RISK</a:t>
             </a:r>
             <a:endParaRPr lang="en-US" sz="1200" dirty="0"/>
@@ -5408,6 +6000,14 @@
               <a:buNone/>
             </a:pPr>
             <a:r>
+              <a:rPr lang="en-US" altLang="en-US" sz="2700" dirty="0">
+                <a:solidFill>
+                  <a:srgbClr val="FFFFFF"/>
+                </a:solidFill>
+                <a:latin typeface="Space Grotesk" pitchFamily="34" charset="0"/>
+                <a:ea typeface="Space Grotesk" pitchFamily="34" charset="-122"/>
+                <a:cs typeface="Space Grotesk" pitchFamily="34" charset="-120"/>
+              </a:rPr>
               <a:t>Possible CFO impersonation</a:t>
             </a:r>
             <a:endParaRPr lang="en-US" sz="2700" dirty="0"/>
@@ -5442,6 +6042,14 @@
               <a:buNone/>
             </a:pPr>
             <a:r>
+              <a:rPr lang="en-US" altLang="en-US" sz="1800" dirty="0">
+                <a:solidFill>
+                  <a:srgbClr val="8B9BB4"/>
+                </a:solidFill>
+                <a:latin typeface="Inter" pitchFamily="34" charset="0"/>
+                <a:ea typeface="Inter" pitchFamily="34" charset="-122"/>
+                <a:cs typeface="Inter" pitchFamily="34" charset="-120"/>
+              </a:rPr>
               <a:t>Urgent-payment intent + look-alike domain + unknown voice channel + identity anomaly + linked alert history.</a:t>
             </a:r>
             <a:endParaRPr lang="en-US" sz="1800" dirty="0"/>
@@ -5499,6 +6107,14 @@
               <a:buNone/>
             </a:pPr>
             <a:r>
+              <a:rPr lang="en-US" altLang="en-US" sz="1200" dirty="0">
+                <a:solidFill>
+                  <a:srgbClr val="00E5FF"/>
+                </a:solidFill>
+                <a:latin typeface="JetBrains Mono" pitchFamily="34" charset="0"/>
+                <a:ea typeface="JetBrains Mono" pitchFamily="34" charset="-122"/>
+                <a:cs typeface="JetBrains Mono" pitchFamily="34" charset="-120"/>
+              </a:rPr>
               <a:t>RECOMMENDED ACTION</a:t>
             </a:r>
             <a:endParaRPr lang="en-US" sz="1200" dirty="0"/>
@@ -5530,7 +6146,15 @@
               <a:buNone/>
             </a:pPr>
             <a:r>
-              <a:t>Quarantine · block · notify analyst</a:t>
+              <a:rPr lang="en-US" altLang="en-US" sz="1800" dirty="0">
+                <a:solidFill>
+                  <a:srgbClr val="FFFFFF"/>
+                </a:solidFill>
+                <a:latin typeface="Inter" pitchFamily="34" charset="0"/>
+                <a:ea typeface="Inter" pitchFamily="34" charset="-122"/>
+                <a:cs typeface="Inter" pitchFamily="34" charset="-120"/>
+              </a:rPr>
+              <a:t>Quarantine • block • notify analyst</a:t>
             </a:r>
             <a:endParaRPr lang="en-US" sz="1800" dirty="0"/>
           </a:p>
@@ -5561,6 +6185,14 @@
               <a:buNone/>
             </a:pPr>
             <a:r>
+              <a:rPr lang="en-US" altLang="en-US" sz="1200" dirty="0">
+                <a:solidFill>
+                  <a:srgbClr val="8B9BB4"/>
+                </a:solidFill>
+                <a:latin typeface="JetBrains Mono" pitchFamily="34" charset="0"/>
+                <a:ea typeface="JetBrains Mono" pitchFamily="34" charset="-122"/>
+                <a:cs typeface="JetBrains Mono" pitchFamily="34" charset="-120"/>
+              </a:rPr>
               <a:t>SEC-03 // PROBLEM CONTEXT</a:t>
             </a:r>
             <a:endParaRPr lang="en-US" sz="1200" dirty="0"/>
@@ -5653,6 +6285,14 @@
               <a:buNone/>
             </a:pPr>
             <a:r>
+              <a:rPr lang="en-US" altLang="en-US" sz="1300" dirty="0">
+                <a:solidFill>
+                  <a:srgbClr val="00E5FF"/>
+                </a:solidFill>
+                <a:latin typeface="JetBrains Mono" pitchFamily="34" charset="0"/>
+                <a:ea typeface="JetBrains Mono" pitchFamily="34" charset="-122"/>
+                <a:cs typeface="JetBrains Mono" pitchFamily="34" charset="-120"/>
+              </a:rPr>
               <a:t>MANDATORY 02 // EXPECTED OUTCOME + PROPOSED SOLUTION</a:t>
             </a:r>
             <a:endParaRPr lang="en-US" sz="1300" dirty="0"/>
@@ -5684,6 +6324,14 @@
               <a:buNone/>
             </a:pPr>
             <a:r>
+              <a:rPr lang="en-US" altLang="en-US" sz="1200" dirty="0">
+                <a:solidFill>
+                  <a:srgbClr val="8B9BB4"/>
+                </a:solidFill>
+                <a:latin typeface="JetBrains Mono" pitchFamily="34" charset="0"/>
+                <a:ea typeface="JetBrains Mono" pitchFamily="34" charset="-122"/>
+                <a:cs typeface="JetBrains Mono" pitchFamily="34" charset="-120"/>
+              </a:rPr>
               <a:t>NEXUS 2026</a:t>
             </a:r>
             <a:endParaRPr lang="en-US" sz="1200" dirty="0"/>
@@ -5715,6 +6363,14 @@
               <a:buNone/>
             </a:pPr>
             <a:r>
+              <a:rPr lang="en-US" altLang="en-US" sz="4300" dirty="0">
+                <a:solidFill>
+                  <a:srgbClr val="FFFFFF"/>
+                </a:solidFill>
+                <a:latin typeface="Space Grotesk" pitchFamily="34" charset="0"/>
+                <a:ea typeface="Space Grotesk" pitchFamily="34" charset="-122"/>
+                <a:cs typeface="Space Grotesk" pitchFamily="34" charset="-120"/>
+              </a:rPr>
               <a:t>AegisNexus converts signals into one defensible decision</a:t>
             </a:r>
             <a:endParaRPr lang="en-US" sz="4300" dirty="0"/>
@@ -5746,6 +6402,14 @@
               <a:buNone/>
             </a:pPr>
             <a:r>
+              <a:rPr lang="en-US" altLang="en-US" sz="1800" dirty="0">
+                <a:solidFill>
+                  <a:srgbClr val="8B9BB4"/>
+                </a:solidFill>
+                <a:latin typeface="Inter" pitchFamily="34" charset="0"/>
+                <a:ea typeface="Inter" pitchFamily="34" charset="-122"/>
+                <a:cs typeface="Inter" pitchFamily="34" charset="-120"/>
+              </a:rPr>
               <a:t>Multiple signals. One explainable risk decision. Safe human-controlled response.</a:t>
             </a:r>
             <a:endParaRPr lang="en-US" sz="1800" dirty="0"/>
@@ -5830,6 +6494,14 @@
               <a:buNone/>
             </a:pPr>
             <a:r>
+              <a:rPr lang="en-US" altLang="en-US" sz="2200" dirty="0">
+                <a:solidFill>
+                  <a:srgbClr val="FFFFFF"/>
+                </a:solidFill>
+                <a:latin typeface="Space Grotesk" pitchFamily="34" charset="0"/>
+                <a:ea typeface="Space Grotesk" pitchFamily="34" charset="-122"/>
+                <a:cs typeface="Space Grotesk" pitchFamily="34" charset="-120"/>
+              </a:rPr>
               <a:t>Phishing Intelligence</a:t>
             </a:r>
             <a:endParaRPr lang="en-US" sz="2200" dirty="0"/>
@@ -5861,6 +6533,14 @@
               <a:buNone/>
             </a:pPr>
             <a:r>
+              <a:rPr lang="en-US" altLang="en-US" sz="1600" dirty="0">
+                <a:solidFill>
+                  <a:srgbClr val="8B9BB4"/>
+                </a:solidFill>
+                <a:latin typeface="Inter" pitchFamily="34" charset="0"/>
+                <a:ea typeface="Inter" pitchFamily="34" charset="-122"/>
+                <a:cs typeface="Inter" pitchFamily="34" charset="-120"/>
+              </a:rPr>
               <a:t>Intent, sender, URL, attachment, and urgency checks.</a:t>
             </a:r>
             <a:endParaRPr lang="en-US" sz="1600" dirty="0"/>
@@ -5945,6 +6625,14 @@
               <a:buNone/>
             </a:pPr>
             <a:r>
+              <a:rPr lang="en-US" altLang="en-US" sz="2200" dirty="0">
+                <a:solidFill>
+                  <a:srgbClr val="FFFFFF"/>
+                </a:solidFill>
+                <a:latin typeface="Space Grotesk" pitchFamily="34" charset="0"/>
+                <a:ea typeface="Space Grotesk" pitchFamily="34" charset="-122"/>
+                <a:cs typeface="Space Grotesk" pitchFamily="34" charset="-120"/>
+              </a:rPr>
               <a:t>Deepfake Analysis</a:t>
             </a:r>
             <a:endParaRPr lang="en-US" sz="2200" dirty="0"/>
@@ -5976,6 +6664,14 @@
               <a:buNone/>
             </a:pPr>
             <a:r>
+              <a:rPr lang="en-US" altLang="en-US" sz="1600" dirty="0">
+                <a:solidFill>
+                  <a:srgbClr val="8B9BB4"/>
+                </a:solidFill>
+                <a:latin typeface="Inter" pitchFamily="34" charset="0"/>
+                <a:ea typeface="Inter" pitchFamily="34" charset="-122"/>
+                <a:cs typeface="Inter" pitchFamily="34" charset="-120"/>
+              </a:rPr>
               <a:t>Voice mismatch, replay clues, facial and lip-sync indicators.</a:t>
             </a:r>
             <a:endParaRPr lang="en-US" sz="1600" dirty="0"/>
@@ -6060,6 +6756,14 @@
               <a:buNone/>
             </a:pPr>
             <a:r>
+              <a:rPr lang="en-US" altLang="en-US" sz="2200" dirty="0">
+                <a:solidFill>
+                  <a:srgbClr val="FFFFFF"/>
+                </a:solidFill>
+                <a:latin typeface="Space Grotesk" pitchFamily="34" charset="0"/>
+                <a:ea typeface="Space Grotesk" pitchFamily="34" charset="-122"/>
+                <a:cs typeface="Space Grotesk" pitchFamily="34" charset="-120"/>
+              </a:rPr>
               <a:t>Executive Digital Twin</a:t>
             </a:r>
             <a:endParaRPr lang="en-US" sz="2200" dirty="0"/>
@@ -6091,6 +6795,14 @@
               <a:buNone/>
             </a:pPr>
             <a:r>
+              <a:rPr lang="en-US" altLang="en-US" sz="1600" dirty="0">
+                <a:solidFill>
+                  <a:srgbClr val="8B9BB4"/>
+                </a:solidFill>
+                <a:latin typeface="Inter" pitchFamily="34" charset="0"/>
+                <a:ea typeface="Inter" pitchFamily="34" charset="-122"/>
+                <a:cs typeface="Inter" pitchFamily="34" charset="-120"/>
+              </a:rPr>
               <a:t>Approved channels, behavior, and transaction patterns.</a:t>
             </a:r>
             <a:endParaRPr lang="en-US" sz="1600" dirty="0"/>
@@ -6175,6 +6887,14 @@
               <a:buNone/>
             </a:pPr>
             <a:r>
+              <a:rPr lang="en-US" altLang="en-US" sz="2200" dirty="0">
+                <a:solidFill>
+                  <a:srgbClr val="FFFFFF"/>
+                </a:solidFill>
+                <a:latin typeface="Space Grotesk" pitchFamily="34" charset="0"/>
+                <a:ea typeface="Space Grotesk" pitchFamily="34" charset="-122"/>
+                <a:cs typeface="Space Grotesk" pitchFamily="34" charset="-120"/>
+              </a:rPr>
               <a:t>Threat + Network Context</a:t>
             </a:r>
             <a:endParaRPr lang="en-US" sz="2200" dirty="0"/>
@@ -6206,6 +6926,14 @@
               <a:buNone/>
             </a:pPr>
             <a:r>
+              <a:rPr lang="en-US" altLang="en-US" sz="1600" dirty="0">
+                <a:solidFill>
+                  <a:srgbClr val="8B9BB4"/>
+                </a:solidFill>
+                <a:latin typeface="Inter" pitchFamily="34" charset="0"/>
+                <a:ea typeface="Inter" pitchFamily="34" charset="-122"/>
+                <a:cs typeface="Inter" pitchFamily="34" charset="-120"/>
+              </a:rPr>
               <a:t>Domains, IPs, devices, DNS activity, and policy signals.</a:t>
             </a:r>
             <a:endParaRPr lang="en-US" sz="1600" dirty="0"/>
@@ -6290,6 +7018,14 @@
               <a:buNone/>
             </a:pPr>
             <a:r>
+              <a:rPr lang="en-US" altLang="en-US" sz="2200" dirty="0">
+                <a:solidFill>
+                  <a:srgbClr val="FFFFFF"/>
+                </a:solidFill>
+                <a:latin typeface="Space Grotesk" pitchFamily="34" charset="0"/>
+                <a:ea typeface="Space Grotesk" pitchFamily="34" charset="-122"/>
+                <a:cs typeface="Space Grotesk" pitchFamily="34" charset="-120"/>
+              </a:rPr>
               <a:t>AI Attack Graph</a:t>
             </a:r>
             <a:endParaRPr lang="en-US" sz="2200" dirty="0"/>
@@ -6321,6 +7057,14 @@
               <a:buNone/>
             </a:pPr>
             <a:r>
+              <a:rPr lang="en-US" altLang="en-US" sz="1600" dirty="0">
+                <a:solidFill>
+                  <a:srgbClr val="8B9BB4"/>
+                </a:solidFill>
+                <a:latin typeface="Inter" pitchFamily="34" charset="0"/>
+                <a:ea typeface="Inter" pitchFamily="34" charset="-122"/>
+                <a:cs typeface="Inter" pitchFamily="34" charset="-120"/>
+              </a:rPr>
               <a:t>Links people, URLs, phones, devices, and past alerts.</a:t>
             </a:r>
             <a:endParaRPr lang="en-US" sz="1600" dirty="0"/>
@@ -6405,6 +7149,14 @@
               <a:buNone/>
             </a:pPr>
             <a:r>
+              <a:rPr lang="en-US" altLang="en-US" sz="2200" dirty="0">
+                <a:solidFill>
+                  <a:srgbClr val="FFFFFF"/>
+                </a:solidFill>
+                <a:latin typeface="Space Grotesk" pitchFamily="34" charset="0"/>
+                <a:ea typeface="Space Grotesk" pitchFamily="34" charset="-122"/>
+                <a:cs typeface="Space Grotesk" pitchFamily="34" charset="-120"/>
+              </a:rPr>
               <a:t>Explainable Risk + Response</a:t>
             </a:r>
             <a:endParaRPr lang="en-US" sz="2200" dirty="0"/>
@@ -6436,6 +7188,14 @@
               <a:buNone/>
             </a:pPr>
             <a:r>
+              <a:rPr lang="en-US" altLang="en-US" sz="1600" dirty="0">
+                <a:solidFill>
+                  <a:srgbClr val="8B9BB4"/>
+                </a:solidFill>
+                <a:latin typeface="Inter" pitchFamily="34" charset="0"/>
+                <a:ea typeface="Inter" pitchFamily="34" charset="-122"/>
+                <a:cs typeface="Inter" pitchFamily="34" charset="-120"/>
+              </a:rPr>
               <a:t>Score, evidence, confidence, action, and analyst approval.</a:t>
             </a:r>
             <a:endParaRPr lang="en-US" sz="1600" dirty="0"/>
@@ -6498,6 +7258,14 @@
               <a:buNone/>
             </a:pPr>
             <a:r>
+              <a:rPr lang="en-US" altLang="en-US" sz="1200" dirty="0">
+                <a:solidFill>
+                  <a:srgbClr val="00E5FF"/>
+                </a:solidFill>
+                <a:latin typeface="JetBrains Mono" pitchFamily="34" charset="0"/>
+                <a:ea typeface="JetBrains Mono" pitchFamily="34" charset="-122"/>
+                <a:cs typeface="JetBrains Mono" pitchFamily="34" charset="-120"/>
+              </a:rPr>
               <a:t>EXPECTED OUTPUT</a:t>
             </a:r>
             <a:endParaRPr lang="en-US" sz="1200" dirty="0"/>
@@ -6529,7 +7297,15 @@
               <a:buNone/>
             </a:pPr>
             <a:r>
-              <a:t>Risk score · confidence · evidence · attack graph · recommended response</a:t>
+              <a:rPr lang="en-US" altLang="en-US" sz="1600" dirty="0">
+                <a:solidFill>
+                  <a:srgbClr val="FFFFFF"/>
+                </a:solidFill>
+                <a:latin typeface="Inter" pitchFamily="34" charset="0"/>
+                <a:ea typeface="Inter" pitchFamily="34" charset="-122"/>
+                <a:cs typeface="Inter" pitchFamily="34" charset="-120"/>
+              </a:rPr>
+              <a:t>Risk score • confidence • evidence • attack graph • recommended response</a:t>
             </a:r>
             <a:endParaRPr lang="en-US" sz="1600" dirty="0"/>
           </a:p>
@@ -6560,6 +7336,14 @@
               <a:buNone/>
             </a:pPr>
             <a:r>
+              <a:rPr lang="en-US" altLang="en-US" sz="1200" dirty="0">
+                <a:solidFill>
+                  <a:srgbClr val="8B9BB4"/>
+                </a:solidFill>
+                <a:latin typeface="JetBrains Mono" pitchFamily="34" charset="0"/>
+                <a:ea typeface="JetBrains Mono" pitchFamily="34" charset="-122"/>
+                <a:cs typeface="JetBrains Mono" pitchFamily="34" charset="-120"/>
+              </a:rPr>
               <a:t>SEC-04 // SOLUTION</a:t>
             </a:r>
             <a:endParaRPr lang="en-US" sz="1200" dirty="0"/>
@@ -6652,6 +7436,14 @@
               <a:buNone/>
             </a:pPr>
             <a:r>
+              <a:rPr lang="en-US" altLang="en-US" sz="1300" dirty="0">
+                <a:solidFill>
+                  <a:srgbClr val="00E5FF"/>
+                </a:solidFill>
+                <a:latin typeface="JetBrains Mono" pitchFamily="34" charset="0"/>
+                <a:ea typeface="JetBrains Mono" pitchFamily="34" charset="-122"/>
+                <a:cs typeface="JetBrains Mono" pitchFamily="34" charset="-120"/>
+              </a:rPr>
               <a:t>MANDATORY 03 // WORKFLOW DIAGRAM</a:t>
             </a:r>
             <a:endParaRPr lang="en-US" sz="1300" dirty="0"/>
@@ -6683,6 +7475,14 @@
               <a:buNone/>
             </a:pPr>
             <a:r>
+              <a:rPr lang="en-US" altLang="en-US" sz="1200" dirty="0">
+                <a:solidFill>
+                  <a:srgbClr val="8B9BB4"/>
+                </a:solidFill>
+                <a:latin typeface="JetBrains Mono" pitchFamily="34" charset="0"/>
+                <a:ea typeface="JetBrains Mono" pitchFamily="34" charset="-122"/>
+                <a:cs typeface="JetBrains Mono" pitchFamily="34" charset="-120"/>
+              </a:rPr>
               <a:t>NEXUS 2026</a:t>
             </a:r>
             <a:endParaRPr lang="en-US" sz="1200" dirty="0"/>
@@ -6714,6 +7514,14 @@
               <a:buNone/>
             </a:pPr>
             <a:r>
+              <a:rPr lang="en-US" altLang="en-US" sz="4500" dirty="0">
+                <a:solidFill>
+                  <a:srgbClr val="FFFFFF"/>
+                </a:solidFill>
+                <a:latin typeface="Space Grotesk" pitchFamily="34" charset="0"/>
+                <a:ea typeface="Space Grotesk" pitchFamily="34" charset="-122"/>
+                <a:cs typeface="Space Grotesk" pitchFamily="34" charset="-120"/>
+              </a:rPr>
               <a:t>The real-time defense workflow</a:t>
             </a:r>
             <a:endParaRPr lang="en-US" sz="4500" dirty="0"/>
@@ -6745,6 +7553,14 @@
               <a:buNone/>
             </a:pPr>
             <a:r>
+              <a:rPr lang="en-US" altLang="en-US" sz="1900" dirty="0">
+                <a:solidFill>
+                  <a:srgbClr val="8B9BB4"/>
+                </a:solidFill>
+                <a:latin typeface="Inter" pitchFamily="34" charset="0"/>
+                <a:ea typeface="Inter" pitchFamily="34" charset="-122"/>
+                <a:cs typeface="Inter" pitchFamily="34" charset="-120"/>
+              </a:rPr>
               <a:t>From a suspicious event to an explainable, human-controlled response.</a:t>
             </a:r>
             <a:endParaRPr lang="en-US" sz="1900" dirty="0"/>
@@ -6855,6 +7671,14 @@
               <a:buNone/>
             </a:pPr>
             <a:r>
+              <a:rPr lang="en-US" altLang="en-US" sz="2000" dirty="0">
+                <a:solidFill>
+                  <a:srgbClr val="FFFFFF"/>
+                </a:solidFill>
+                <a:latin typeface="Space Grotesk" pitchFamily="34" charset="0"/>
+                <a:ea typeface="Space Grotesk" pitchFamily="34" charset="-122"/>
+                <a:cs typeface="Space Grotesk" pitchFamily="34" charset="-120"/>
+              </a:rPr>
               <a:t>Multimodal input</a:t>
             </a:r>
             <a:endParaRPr lang="en-US" sz="2000" dirty="0"/>
@@ -6886,7 +7710,15 @@
               <a:buNone/>
             </a:pPr>
             <a:r>
-              <a:t>Email · voice · video · network</a:t>
+              <a:rPr lang="en-US" altLang="en-US" sz="1500" dirty="0">
+                <a:solidFill>
+                  <a:srgbClr val="8B9BB4"/>
+                </a:solidFill>
+                <a:latin typeface="Inter" pitchFamily="34" charset="0"/>
+                <a:ea typeface="Inter" pitchFamily="34" charset="-122"/>
+                <a:cs typeface="Inter" pitchFamily="34" charset="-120"/>
+              </a:rPr>
+              <a:t>Email • voice • video • network</a:t>
             </a:r>
             <a:endParaRPr lang="en-US" sz="1500" dirty="0"/>
           </a:p>
@@ -7022,6 +7854,14 @@
               <a:buNone/>
             </a:pPr>
             <a:r>
+              <a:rPr lang="en-US" altLang="en-US" sz="2000" dirty="0">
+                <a:solidFill>
+                  <a:srgbClr val="FFFFFF"/>
+                </a:solidFill>
+                <a:latin typeface="Space Grotesk" pitchFamily="34" charset="0"/>
+                <a:ea typeface="Space Grotesk" pitchFamily="34" charset="-122"/>
+                <a:cs typeface="Space Grotesk" pitchFamily="34" charset="-120"/>
+              </a:rPr>
               <a:t>Evidence ingest</a:t>
             </a:r>
             <a:endParaRPr lang="en-US" sz="2000" dirty="0"/>
@@ -7053,7 +7893,15 @@
               <a:buNone/>
             </a:pPr>
             <a:r>
-              <a:t>Text · URLs · metadata · media features</a:t>
+              <a:rPr lang="en-US" altLang="en-US" sz="1500" dirty="0">
+                <a:solidFill>
+                  <a:srgbClr val="8B9BB4"/>
+                </a:solidFill>
+                <a:latin typeface="Inter" pitchFamily="34" charset="0"/>
+                <a:ea typeface="Inter" pitchFamily="34" charset="-122"/>
+                <a:cs typeface="Inter" pitchFamily="34" charset="-120"/>
+              </a:rPr>
+              <a:t>Text • URLs • metadata • media features</a:t>
             </a:r>
             <a:endParaRPr lang="en-US" sz="1500" dirty="0"/>
           </a:p>
@@ -7189,6 +8037,14 @@
               <a:buNone/>
             </a:pPr>
             <a:r>
+              <a:rPr lang="en-US" altLang="en-US" sz="2000" dirty="0">
+                <a:solidFill>
+                  <a:srgbClr val="FFFFFF"/>
+                </a:solidFill>
+                <a:latin typeface="Space Grotesk" pitchFamily="34" charset="0"/>
+                <a:ea typeface="Space Grotesk" pitchFamily="34" charset="-122"/>
+                <a:cs typeface="Space Grotesk" pitchFamily="34" charset="-120"/>
+              </a:rPr>
               <a:t>Parallel verification</a:t>
             </a:r>
             <a:endParaRPr lang="en-US" sz="2000" dirty="0"/>
@@ -7220,7 +8076,15 @@
               <a:buNone/>
             </a:pPr>
             <a:r>
-              <a:t>Phishing · deepfake · digital twin · threat checks</a:t>
+              <a:rPr lang="en-US" altLang="en-US" sz="1500" dirty="0">
+                <a:solidFill>
+                  <a:srgbClr val="8B9BB4"/>
+                </a:solidFill>
+                <a:latin typeface="Inter" pitchFamily="34" charset="0"/>
+                <a:ea typeface="Inter" pitchFamily="34" charset="-122"/>
+                <a:cs typeface="Inter" pitchFamily="34" charset="-120"/>
+              </a:rPr>
+              <a:t>Phishing • deepfake • digital twin • threat checks</a:t>
             </a:r>
             <a:endParaRPr lang="en-US" sz="1500" dirty="0"/>
           </a:p>
@@ -7356,6 +8220,14 @@
               <a:buNone/>
             </a:pPr>
             <a:r>
+              <a:rPr lang="en-US" altLang="en-US" sz="2000" dirty="0">
+                <a:solidFill>
+                  <a:srgbClr val="FFFFFF"/>
+                </a:solidFill>
+                <a:latin typeface="Space Grotesk" pitchFamily="34" charset="0"/>
+                <a:ea typeface="Space Grotesk" pitchFamily="34" charset="-122"/>
+                <a:cs typeface="Space Grotesk" pitchFamily="34" charset="-120"/>
+              </a:rPr>
               <a:t>AI Attack Graph</a:t>
             </a:r>
             <a:endParaRPr lang="en-US" sz="2000" dirty="0"/>
@@ -7387,6 +8259,14 @@
               <a:buNone/>
             </a:pPr>
             <a:r>
+              <a:rPr lang="en-US" altLang="en-US" sz="1500" dirty="0">
+                <a:solidFill>
+                  <a:srgbClr val="8B9BB4"/>
+                </a:solidFill>
+                <a:latin typeface="Inter" pitchFamily="34" charset="0"/>
+                <a:ea typeface="Inter" pitchFamily="34" charset="-122"/>
+                <a:cs typeface="Inter" pitchFamily="34" charset="-120"/>
+              </a:rPr>
               <a:t>Connect identities, assets, and prior alerts</a:t>
             </a:r>
             <a:endParaRPr lang="en-US" sz="1500" dirty="0"/>
@@ -7523,6 +8403,14 @@
               <a:buNone/>
             </a:pPr>
             <a:r>
+              <a:rPr lang="en-US" altLang="en-US" sz="2000" dirty="0">
+                <a:solidFill>
+                  <a:srgbClr val="FFFFFF"/>
+                </a:solidFill>
+                <a:latin typeface="Space Grotesk" pitchFamily="34" charset="0"/>
+                <a:ea typeface="Space Grotesk" pitchFamily="34" charset="-122"/>
+                <a:cs typeface="Space Grotesk" pitchFamily="34" charset="-120"/>
+              </a:rPr>
               <a:t>Risk + response</a:t>
             </a:r>
             <a:endParaRPr lang="en-US" sz="2000" dirty="0"/>
@@ -7554,7 +8442,15 @@
               <a:buNone/>
             </a:pPr>
             <a:r>
-              <a:t>Explain score · select safe playbook · approve</a:t>
+              <a:rPr lang="en-US" altLang="en-US" sz="1500" dirty="0">
+                <a:solidFill>
+                  <a:srgbClr val="8B9BB4"/>
+                </a:solidFill>
+                <a:latin typeface="Inter" pitchFamily="34" charset="0"/>
+                <a:ea typeface="Inter" pitchFamily="34" charset="-122"/>
+                <a:cs typeface="Inter" pitchFamily="34" charset="-120"/>
+              </a:rPr>
+              <a:t>Explain score • select safe playbook • approve</a:t>
             </a:r>
             <a:endParaRPr lang="en-US" sz="1500" dirty="0"/>
           </a:p>
@@ -7667,6 +8563,14 @@
               <a:buNone/>
             </a:pPr>
             <a:r>
+              <a:rPr lang="en-US" altLang="en-US" sz="2100" dirty="0">
+                <a:solidFill>
+                  <a:srgbClr val="FFFFFF"/>
+                </a:solidFill>
+                <a:latin typeface="Space Grotesk" pitchFamily="34" charset="0"/>
+                <a:ea typeface="Space Grotesk" pitchFamily="34" charset="-122"/>
+                <a:cs typeface="Space Grotesk" pitchFamily="34" charset="-120"/>
+              </a:rPr>
               <a:t>Security Dashboard + AI Copilot</a:t>
             </a:r>
             <a:endParaRPr lang="en-US" sz="2100" dirty="0"/>
@@ -7698,7 +8602,15 @@
               <a:buNone/>
             </a:pPr>
             <a:r>
-              <a:t>Risk score · evidence · attack graph · reason codes · recommended action</a:t>
+              <a:rPr lang="en-US" altLang="en-US" sz="1600" dirty="0">
+                <a:solidFill>
+                  <a:srgbClr val="8B9BB4"/>
+                </a:solidFill>
+                <a:latin typeface="Inter" pitchFamily="34" charset="0"/>
+                <a:ea typeface="Inter" pitchFamily="34" charset="-122"/>
+                <a:cs typeface="Inter" pitchFamily="34" charset="-120"/>
+              </a:rPr>
+              <a:t>Risk score • evidence • attack graph • reason codes • recommended action</a:t>
             </a:r>
             <a:endParaRPr lang="en-US" sz="1600" dirty="0"/>
           </a:p>
@@ -7729,6 +8641,14 @@
               <a:buNone/>
             </a:pPr>
             <a:r>
+              <a:rPr lang="en-US" altLang="en-US" sz="1200" dirty="0">
+                <a:solidFill>
+                  <a:srgbClr val="8B9BB4"/>
+                </a:solidFill>
+                <a:latin typeface="JetBrains Mono" pitchFamily="34" charset="0"/>
+                <a:ea typeface="JetBrains Mono" pitchFamily="34" charset="-122"/>
+                <a:cs typeface="JetBrains Mono" pitchFamily="34" charset="-120"/>
+              </a:rPr>
               <a:t>SEC-05 // WORKFLOW</a:t>
             </a:r>
             <a:endParaRPr lang="en-US" sz="1200" dirty="0"/>
@@ -7821,6 +8741,14 @@
               <a:buNone/>
             </a:pPr>
             <a:r>
+              <a:rPr lang="en-US" altLang="en-US" sz="1300" dirty="0">
+                <a:solidFill>
+                  <a:srgbClr val="00E5FF"/>
+                </a:solidFill>
+                <a:latin typeface="JetBrains Mono" pitchFamily="34" charset="0"/>
+                <a:ea typeface="JetBrains Mono" pitchFamily="34" charset="-122"/>
+                <a:cs typeface="JetBrains Mono" pitchFamily="34" charset="-120"/>
+              </a:rPr>
               <a:t>05 // CORRELATION LAYER</a:t>
             </a:r>
             <a:endParaRPr lang="en-US" sz="1300" dirty="0"/>
@@ -7852,6 +8780,14 @@
               <a:buNone/>
             </a:pPr>
             <a:r>
+              <a:rPr lang="en-US" altLang="en-US" sz="1200" dirty="0">
+                <a:solidFill>
+                  <a:srgbClr val="8B9BB4"/>
+                </a:solidFill>
+                <a:latin typeface="JetBrains Mono" pitchFamily="34" charset="0"/>
+                <a:ea typeface="JetBrains Mono" pitchFamily="34" charset="-122"/>
+                <a:cs typeface="JetBrains Mono" pitchFamily="34" charset="-120"/>
+              </a:rPr>
               <a:t>NEXUS 2026</a:t>
             </a:r>
             <a:endParaRPr lang="en-US" sz="1200" dirty="0"/>
@@ -7886,6 +8822,14 @@
               <a:buNone/>
             </a:pPr>
             <a:r>
+              <a:rPr lang="en-US" altLang="en-US" sz="4400" dirty="0">
+                <a:solidFill>
+                  <a:srgbClr val="FFFFFF"/>
+                </a:solidFill>
+                <a:latin typeface="Space Grotesk" pitchFamily="34" charset="0"/>
+                <a:ea typeface="Space Grotesk" pitchFamily="34" charset="-122"/>
+                <a:cs typeface="Space Grotesk" pitchFamily="34" charset="-120"/>
+              </a:rPr>
               <a:t>The attack graph is the system’s memory</a:t>
             </a:r>
             <a:endParaRPr lang="en-US" sz="4400" dirty="0"/>
@@ -7920,6 +8864,14 @@
               <a:buNone/>
             </a:pPr>
             <a:r>
+              <a:rPr lang="en-US" altLang="en-US" sz="1900" dirty="0">
+                <a:solidFill>
+                  <a:srgbClr val="8B9BB4"/>
+                </a:solidFill>
+                <a:latin typeface="Inter" pitchFamily="34" charset="0"/>
+                <a:ea typeface="Inter" pitchFamily="34" charset="-122"/>
+                <a:cs typeface="Inter" pitchFamily="34" charset="-120"/>
+              </a:rPr>
               <a:t>One event is uncertain. Connected evidence is actionable.</a:t>
             </a:r>
             <a:endParaRPr lang="en-US" sz="1900" dirty="0"/>
@@ -7975,6 +8927,14 @@
               <a:buNone/>
             </a:pPr>
             <a:r>
+              <a:rPr lang="en-US" altLang="en-US" sz="2100" dirty="0">
+                <a:solidFill>
+                  <a:srgbClr val="FFFFFF"/>
+                </a:solidFill>
+                <a:latin typeface="Space Grotesk" pitchFamily="34" charset="0"/>
+                <a:ea typeface="Space Grotesk" pitchFamily="34" charset="-122"/>
+                <a:cs typeface="Space Grotesk" pitchFamily="34" charset="-120"/>
+              </a:rPr>
               <a:t>Correlation</a:t>
             </a:r>
             <a:endParaRPr lang="en-US" sz="2100" dirty="0"/>
@@ -8006,6 +8966,14 @@
               <a:buNone/>
             </a:pPr>
             <a:r>
+              <a:rPr lang="en-US" altLang="en-US" sz="1600" dirty="0">
+                <a:solidFill>
+                  <a:srgbClr val="8B9BB4"/>
+                </a:solidFill>
+                <a:latin typeface="Inter" pitchFamily="34" charset="0"/>
+                <a:ea typeface="Inter" pitchFamily="34" charset="-122"/>
+                <a:cs typeface="Inter" pitchFamily="34" charset="-120"/>
+              </a:rPr>
               <a:t>Find shared infrastructure, repeated targeting, and campaign overlap.</a:t>
             </a:r>
             <a:endParaRPr lang="en-US" sz="1600" dirty="0"/>
@@ -8061,6 +9029,14 @@
               <a:buNone/>
             </a:pPr>
             <a:r>
+              <a:rPr lang="en-US" altLang="en-US" sz="2100" dirty="0">
+                <a:solidFill>
+                  <a:srgbClr val="FFFFFF"/>
+                </a:solidFill>
+                <a:latin typeface="Space Grotesk" pitchFamily="34" charset="0"/>
+                <a:ea typeface="Space Grotesk" pitchFamily="34" charset="-122"/>
+                <a:cs typeface="Space Grotesk" pitchFamily="34" charset="-120"/>
+              </a:rPr>
               <a:t>Context</a:t>
             </a:r>
             <a:endParaRPr lang="en-US" sz="2100" dirty="0"/>
@@ -8092,6 +9068,14 @@
               <a:buNone/>
             </a:pPr>
             <a:r>
+              <a:rPr lang="en-US" altLang="en-US" sz="1600" dirty="0">
+                <a:solidFill>
+                  <a:srgbClr val="8B9BB4"/>
+                </a:solidFill>
+                <a:latin typeface="Inter" pitchFamily="34" charset="0"/>
+                <a:ea typeface="Inter" pitchFamily="34" charset="-122"/>
+                <a:cs typeface="Inter" pitchFamily="34" charset="-120"/>
+              </a:rPr>
               <a:t>Add identity anomalies and business impact to technical signals.</a:t>
             </a:r>
             <a:endParaRPr lang="en-US" sz="1600" dirty="0"/>
@@ -8147,6 +9131,14 @@
               <a:buNone/>
             </a:pPr>
             <a:r>
+              <a:rPr lang="en-US" altLang="en-US" sz="2100" dirty="0">
+                <a:solidFill>
+                  <a:srgbClr val="FFFFFF"/>
+                </a:solidFill>
+                <a:latin typeface="Space Grotesk" pitchFamily="34" charset="0"/>
+                <a:ea typeface="Space Grotesk" pitchFamily="34" charset="-122"/>
+                <a:cs typeface="Space Grotesk" pitchFamily="34" charset="-120"/>
+              </a:rPr>
               <a:t>Explanation</a:t>
             </a:r>
             <a:endParaRPr lang="en-US" sz="2100" dirty="0"/>
@@ -8178,6 +9170,14 @@
               <a:buNone/>
             </a:pPr>
             <a:r>
+              <a:rPr lang="en-US" altLang="en-US" sz="1600" dirty="0">
+                <a:solidFill>
+                  <a:srgbClr val="8B9BB4"/>
+                </a:solidFill>
+                <a:latin typeface="Inter" pitchFamily="34" charset="0"/>
+                <a:ea typeface="Inter" pitchFamily="34" charset="-122"/>
+                <a:cs typeface="Inter" pitchFamily="34" charset="-120"/>
+              </a:rPr>
               <a:t>Show analysts why the risk score increased and what to do next.</a:t>
             </a:r>
             <a:endParaRPr lang="en-US" sz="1600" dirty="0"/>
@@ -8322,6 +9322,14 @@
               <a:buNone/>
             </a:pPr>
             <a:r>
+              <a:rPr lang="en-US" altLang="en-US" sz="1200" dirty="0">
+                <a:solidFill>
+                  <a:srgbClr val="FFB300"/>
+                </a:solidFill>
+                <a:latin typeface="JetBrains Mono" pitchFamily="34" charset="0"/>
+                <a:ea typeface="JetBrains Mono" pitchFamily="34" charset="-122"/>
+                <a:cs typeface="JetBrains Mono" pitchFamily="34" charset="-120"/>
+              </a:rPr>
               <a:t>CORRELATED INCIDENT</a:t>
             </a:r>
             <a:endParaRPr lang="en-US" sz="1200" dirty="0"/>
@@ -8353,6 +9361,14 @@
               <a:buNone/>
             </a:pPr>
             <a:r>
+              <a:rPr lang="en-US" altLang="en-US" sz="1800" dirty="0">
+                <a:solidFill>
+                  <a:srgbClr val="FFFFFF"/>
+                </a:solidFill>
+                <a:latin typeface="Space Grotesk" pitchFamily="34" charset="0"/>
+                <a:ea typeface="Space Grotesk" pitchFamily="34" charset="-122"/>
+                <a:cs typeface="Space Grotesk" pitchFamily="34" charset="-120"/>
+              </a:rPr>
               <a:t>HIGH-RISK CFO IMPERSONATION</a:t>
             </a:r>
             <a:endParaRPr lang="en-US" sz="1800" dirty="0"/>
@@ -8384,6 +9400,14 @@
               <a:buNone/>
             </a:pPr>
             <a:r>
+              <a:rPr lang="en-US" altLang="en-US" sz="1200" dirty="0">
+                <a:solidFill>
+                  <a:srgbClr val="8B9BB4"/>
+                </a:solidFill>
+                <a:latin typeface="JetBrains Mono" pitchFamily="34" charset="0"/>
+                <a:ea typeface="JetBrains Mono" pitchFamily="34" charset="-122"/>
+                <a:cs typeface="JetBrains Mono" pitchFamily="34" charset="-120"/>
+              </a:rPr>
               <a:t>SEC-06 // ATTACK GRAPH</a:t>
             </a:r>
             <a:endParaRPr lang="en-US" sz="1200" dirty="0"/>
@@ -8476,6 +9500,14 @@
               <a:buNone/>
             </a:pPr>
             <a:r>
+              <a:rPr lang="en-US" altLang="en-US" sz="1300" dirty="0">
+                <a:solidFill>
+                  <a:srgbClr val="00E5FF"/>
+                </a:solidFill>
+                <a:latin typeface="JetBrains Mono" pitchFamily="34" charset="0"/>
+                <a:ea typeface="JetBrains Mono" pitchFamily="34" charset="-122"/>
+                <a:cs typeface="JetBrains Mono" pitchFamily="34" charset="-120"/>
+              </a:rPr>
               <a:t>MANDATORY 04 // TECHNOLOGIES + TOOLS</a:t>
             </a:r>
             <a:endParaRPr lang="en-US" sz="1300" dirty="0"/>
@@ -8507,6 +9539,14 @@
               <a:buNone/>
             </a:pPr>
             <a:r>
+              <a:rPr lang="en-US" altLang="en-US" sz="1200" dirty="0">
+                <a:solidFill>
+                  <a:srgbClr val="8B9BB4"/>
+                </a:solidFill>
+                <a:latin typeface="JetBrains Mono" pitchFamily="34" charset="0"/>
+                <a:ea typeface="JetBrains Mono" pitchFamily="34" charset="-122"/>
+                <a:cs typeface="JetBrains Mono" pitchFamily="34" charset="-120"/>
+              </a:rPr>
               <a:t>NEXUS 2026</a:t>
             </a:r>
             <a:endParaRPr lang="en-US" sz="1200" dirty="0"/>
@@ -8538,6 +9578,14 @@
               <a:buNone/>
             </a:pPr>
             <a:r>
+              <a:rPr lang="en-US" altLang="en-US" sz="4300" dirty="0">
+                <a:solidFill>
+                  <a:srgbClr val="FFFFFF"/>
+                </a:solidFill>
+                <a:latin typeface="Space Grotesk" pitchFamily="34" charset="0"/>
+                <a:ea typeface="Space Grotesk" pitchFamily="34" charset="-122"/>
+                <a:cs typeface="Space Grotesk" pitchFamily="34" charset="-120"/>
+              </a:rPr>
               <a:t>A feasible prototype stack maps directly to the workflow</a:t>
             </a:r>
             <a:endParaRPr lang="en-US" sz="4300" dirty="0"/>
@@ -8569,6 +9617,14 @@
               <a:buNone/>
             </a:pPr>
             <a:r>
+              <a:rPr lang="en-US" altLang="en-US" sz="1800" dirty="0">
+                <a:solidFill>
+                  <a:srgbClr val="8B9BB4"/>
+                </a:solidFill>
+                <a:latin typeface="Inter" pitchFamily="34" charset="0"/>
+                <a:ea typeface="Inter" pitchFamily="34" charset="-122"/>
+                <a:cs typeface="Inter" pitchFamily="34" charset="-120"/>
+              </a:rPr>
               <a:t>Modular by design—each layer can be built, tested, and demonstrated independently.</a:t>
             </a:r>
             <a:endParaRPr lang="en-US" sz="1800" dirty="0"/>
@@ -8653,7 +9709,15 @@
               <a:buNone/>
             </a:pPr>
             <a:r>
-              <a:t>Experience Layer</a:t>
+              <a:rPr lang="en-US" altLang="en-US" sz="1900" dirty="0">
+                <a:solidFill>
+                  <a:srgbClr val="FFFFFF"/>
+                </a:solidFill>
+                <a:latin typeface="Space Grotesk" pitchFamily="34" charset="0"/>
+                <a:ea typeface="Space Grotesk" pitchFamily="34" charset="-122"/>
+                <a:cs typeface="Space Grotesk" pitchFamily="34" charset="-120"/>
+              </a:rPr>
+              <a:t>Experience</a:t>
             </a:r>
             <a:endParaRPr lang="en-US" sz="1900" dirty="0"/>
           </a:p>
@@ -8684,7 +9748,15 @@
               <a:buNone/>
             </a:pPr>
             <a:r>
-              <a:t>React 19 • TypeScript • Vite • Tailwind CSS • Interactive SVG Topology</a:t>
+              <a:rPr lang="en-US" altLang="en-US" sz="1700" dirty="0">
+                <a:solidFill>
+                  <a:srgbClr val="8B9BB4"/>
+                </a:solidFill>
+                <a:latin typeface="Inter" pitchFamily="34" charset="0"/>
+                <a:ea typeface="Inter" pitchFamily="34" charset="-122"/>
+                <a:cs typeface="Inter" pitchFamily="34" charset="-120"/>
+              </a:rPr>
+              <a:t>React • Tailwind CSS • Charts • Cytoscape.js</a:t>
             </a:r>
             <a:endParaRPr lang="en-US" sz="1700" dirty="0"/>
           </a:p>
@@ -8768,7 +9840,15 @@
               <a:buNone/>
             </a:pPr>
             <a:r>
-              <a:t>Gateway &amp; Orchestration</a:t>
+              <a:rPr lang="en-US" altLang="en-US" sz="1900" dirty="0">
+                <a:solidFill>
+                  <a:srgbClr val="FFFFFF"/>
+                </a:solidFill>
+                <a:latin typeface="Space Grotesk" pitchFamily="34" charset="0"/>
+                <a:ea typeface="Space Grotesk" pitchFamily="34" charset="-122"/>
+                <a:cs typeface="Space Grotesk" pitchFamily="34" charset="-120"/>
+              </a:rPr>
+              <a:t>Orchestration</a:t>
             </a:r>
             <a:endParaRPr lang="en-US" sz="1900" dirty="0"/>
           </a:p>
@@ -8799,7 +9879,15 @@
               <a:buNone/>
             </a:pPr>
             <a:r>
-              <a:t>Node.js &amp; Express Gateway • REST APIs • Modular Detectors</a:t>
+              <a:rPr lang="en-US" altLang="en-US" sz="1700" dirty="0">
+                <a:solidFill>
+                  <a:srgbClr val="8B9BB4"/>
+                </a:solidFill>
+                <a:latin typeface="Inter" pitchFamily="34" charset="0"/>
+                <a:ea typeface="Inter" pitchFamily="34" charset="-122"/>
+                <a:cs typeface="Inter" pitchFamily="34" charset="-120"/>
+              </a:rPr>
+              <a:t>Python • FastAPI • API-based modules</a:t>
             </a:r>
             <a:endParaRPr lang="en-US" sz="1700" dirty="0"/>
           </a:p>
@@ -8883,6 +9971,14 @@
               <a:buNone/>
             </a:pPr>
             <a:r>
+              <a:rPr lang="en-US" altLang="en-US" sz="1900" dirty="0">
+                <a:solidFill>
+                  <a:srgbClr val="FFFFFF"/>
+                </a:solidFill>
+                <a:latin typeface="Space Grotesk" pitchFamily="34" charset="0"/>
+                <a:ea typeface="Space Grotesk" pitchFamily="34" charset="-122"/>
+                <a:cs typeface="Space Grotesk" pitchFamily="34" charset="-120"/>
+              </a:rPr>
               <a:t>Intelligence</a:t>
             </a:r>
             <a:endParaRPr lang="en-US" sz="1900" dirty="0"/>
@@ -8914,7 +10010,15 @@
               <a:buNone/>
             </a:pPr>
             <a:r>
-              <a:t>scikit-learn / Transformers · librosa / SpeechBrain · OpenCV / MediaPipe</a:t>
+              <a:rPr lang="en-US" altLang="en-US" sz="1500" dirty="0">
+                <a:solidFill>
+                  <a:srgbClr val="8B9BB4"/>
+                </a:solidFill>
+                <a:latin typeface="Inter" pitchFamily="34" charset="0"/>
+                <a:ea typeface="Inter" pitchFamily="34" charset="-122"/>
+                <a:cs typeface="Inter" pitchFamily="34" charset="-120"/>
+              </a:rPr>
+              <a:t>scikit-learn / Transformers • librosa / SpeechBrain • OpenCV / MediaPipe</a:t>
             </a:r>
             <a:endParaRPr lang="en-US" sz="1500" dirty="0"/>
           </a:p>
@@ -8998,6 +10102,14 @@
               <a:buNone/>
             </a:pPr>
             <a:r>
+              <a:rPr lang="en-US" altLang="en-US" sz="1900" dirty="0">
+                <a:solidFill>
+                  <a:srgbClr val="FFFFFF"/>
+                </a:solidFill>
+                <a:latin typeface="Space Grotesk" pitchFamily="34" charset="0"/>
+                <a:ea typeface="Space Grotesk" pitchFamily="34" charset="-122"/>
+                <a:cs typeface="Space Grotesk" pitchFamily="34" charset="-120"/>
+              </a:rPr>
               <a:t>Correlation</a:t>
             </a:r>
             <a:endParaRPr lang="en-US" sz="1900" dirty="0"/>
@@ -9029,7 +10141,15 @@
               <a:buNone/>
             </a:pPr>
             <a:r>
-              <a:t>NetworkX · threat rules · Digital Twin profiles</a:t>
+              <a:rPr lang="en-US" altLang="en-US" sz="1700" dirty="0">
+                <a:solidFill>
+                  <a:srgbClr val="8B9BB4"/>
+                </a:solidFill>
+                <a:latin typeface="Inter" pitchFamily="34" charset="0"/>
+                <a:ea typeface="Inter" pitchFamily="34" charset="-122"/>
+                <a:cs typeface="Inter" pitchFamily="34" charset="-120"/>
+              </a:rPr>
+              <a:t>NetworkX • threat rules • Digital Twin profiles</a:t>
             </a:r>
             <a:endParaRPr lang="en-US" sz="1700" dirty="0"/>
           </a:p>
@@ -9113,7 +10233,15 @@
               <a:buNone/>
             </a:pPr>
             <a:r>
-              <a:t>Data &amp; Security Framework</a:t>
+              <a:rPr lang="en-US" altLang="en-US" sz="1900" dirty="0">
+                <a:solidFill>
+                  <a:srgbClr val="FFFFFF"/>
+                </a:solidFill>
+                <a:latin typeface="Space Grotesk" pitchFamily="34" charset="0"/>
+                <a:ea typeface="Space Grotesk" pitchFamily="34" charset="-122"/>
+                <a:cs typeface="Space Grotesk" pitchFamily="34" charset="-120"/>
+              </a:rPr>
+              <a:t>Data + deployment</a:t>
             </a:r>
             <a:endParaRPr lang="en-US" sz="1900" dirty="0"/>
           </a:p>
@@ -9144,7 +10272,15 @@
               <a:buNone/>
             </a:pPr>
             <a:r>
-              <a:t>Vercel Cloud CI/CD • Local Encrypted Storage • NIST AI RMF 1.0 • MITRE ATT&amp;CK</a:t>
+              <a:rPr lang="en-US" altLang="en-US" sz="1700" dirty="0">
+                <a:solidFill>
+                  <a:srgbClr val="8B9BB4"/>
+                </a:solidFill>
+                <a:latin typeface="Inter" pitchFamily="34" charset="0"/>
+                <a:ea typeface="Inter" pitchFamily="34" charset="-122"/>
+                <a:cs typeface="Inter" pitchFamily="34" charset="-120"/>
+              </a:rPr>
+              <a:t>SQLite / PostgreSQL • Docker • cloud VM/container</a:t>
             </a:r>
             <a:endParaRPr lang="en-US" sz="1700" dirty="0"/>
           </a:p>
@@ -9204,6 +10340,14 @@
               <a:buNone/>
             </a:pPr>
             <a:r>
+              <a:rPr lang="en-US" altLang="en-US" sz="1300" dirty="0">
+                <a:solidFill>
+                  <a:srgbClr val="FFB300"/>
+                </a:solidFill>
+                <a:latin typeface="JetBrains Mono" pitchFamily="34" charset="0"/>
+                <a:ea typeface="JetBrains Mono" pitchFamily="34" charset="-122"/>
+                <a:cs typeface="JetBrains Mono" pitchFamily="34" charset="-120"/>
+              </a:rPr>
               <a:t>HACKATHON MVP BOUNDARY</a:t>
             </a:r>
             <a:endParaRPr lang="en-US" sz="1300" dirty="0"/>
@@ -9235,6 +10379,14 @@
               <a:buNone/>
             </a:pPr>
             <a:r>
+              <a:rPr lang="en-US" altLang="en-US" sz="2700" dirty="0">
+                <a:solidFill>
+                  <a:srgbClr val="FFFFFF"/>
+                </a:solidFill>
+                <a:latin typeface="Space Grotesk" pitchFamily="34" charset="0"/>
+                <a:ea typeface="Space Grotesk" pitchFamily="34" charset="-122"/>
+                <a:cs typeface="Space Grotesk" pitchFamily="34" charset="-120"/>
+              </a:rPr>
               <a:t>Build the decision engine first</a:t>
             </a:r>
             <a:endParaRPr lang="en-US" sz="2700" dirty="0"/>
@@ -9269,6 +10421,14 @@
               <a:buNone/>
             </a:pPr>
             <a:r>
+              <a:rPr lang="en-US" altLang="en-US" sz="1700" dirty="0">
+                <a:solidFill>
+                  <a:srgbClr val="8B9BB4"/>
+                </a:solidFill>
+                <a:latin typeface="Inter" pitchFamily="34" charset="0"/>
+                <a:ea typeface="Inter" pitchFamily="34" charset="-122"/>
+                <a:cs typeface="Inter" pitchFamily="34" charset="-120"/>
+              </a:rPr>
               <a:t>Prioritize phishing and URL analysis, audio indicators, identity rules, attack graph, explainable risk scoring, dashboard, and response simulation.</a:t>
             </a:r>
             <a:endParaRPr lang="en-US" sz="1700" dirty="0"/>
@@ -9326,6 +10486,14 @@
               <a:buNone/>
             </a:pPr>
             <a:r>
+              <a:rPr lang="en-US" altLang="en-US" sz="1600" dirty="0">
+                <a:solidFill>
+                  <a:srgbClr val="FFFFFF"/>
+                </a:solidFill>
+                <a:latin typeface="Inter" pitchFamily="34" charset="0"/>
+                <a:ea typeface="Inter" pitchFamily="34" charset="-122"/>
+                <a:cs typeface="Inter" pitchFamily="34" charset="-120"/>
+              </a:rPr>
               <a:t>Video analysis remains modular with sample input.</a:t>
             </a:r>
             <a:endParaRPr lang="en-US" sz="1600" dirty="0"/>
@@ -9357,6 +10525,14 @@
               <a:buNone/>
             </a:pPr>
             <a:r>
+              <a:rPr lang="en-US" altLang="en-US" sz="1200" dirty="0">
+                <a:solidFill>
+                  <a:srgbClr val="8B9BB4"/>
+                </a:solidFill>
+                <a:latin typeface="JetBrains Mono" pitchFamily="34" charset="0"/>
+                <a:ea typeface="JetBrains Mono" pitchFamily="34" charset="-122"/>
+                <a:cs typeface="JetBrains Mono" pitchFamily="34" charset="-120"/>
+              </a:rPr>
               <a:t>SEC-07 // STACK</a:t>
             </a:r>
             <a:endParaRPr lang="en-US" sz="1200" dirty="0"/>
@@ -9449,6 +10625,14 @@
               <a:buNone/>
             </a:pPr>
             <a:r>
+              <a:rPr lang="en-US" altLang="en-US" sz="1300" dirty="0">
+                <a:solidFill>
+                  <a:srgbClr val="00E5FF"/>
+                </a:solidFill>
+                <a:latin typeface="JetBrains Mono" pitchFamily="34" charset="0"/>
+                <a:ea typeface="JetBrains Mono" pitchFamily="34" charset="-122"/>
+                <a:cs typeface="JetBrains Mono" pitchFamily="34" charset="-120"/>
+              </a:rPr>
               <a:t>MANDATORY 05 // PSEUDOCODE + ALGORITHM</a:t>
             </a:r>
             <a:endParaRPr lang="en-US" sz="1300" dirty="0"/>
@@ -9480,6 +10664,14 @@
               <a:buNone/>
             </a:pPr>
             <a:r>
+              <a:rPr lang="en-US" altLang="en-US" sz="1200" dirty="0">
+                <a:solidFill>
+                  <a:srgbClr val="8B9BB4"/>
+                </a:solidFill>
+                <a:latin typeface="JetBrains Mono" pitchFamily="34" charset="0"/>
+                <a:ea typeface="JetBrains Mono" pitchFamily="34" charset="-122"/>
+                <a:cs typeface="JetBrains Mono" pitchFamily="34" charset="-120"/>
+              </a:rPr>
               <a:t>NEXUS 2026</a:t>
             </a:r>
             <a:endParaRPr lang="en-US" sz="1200" dirty="0"/>
@@ -9511,6 +10703,14 @@
               <a:buNone/>
             </a:pPr>
             <a:r>
+              <a:rPr lang="en-US" altLang="en-US" sz="4300" dirty="0">
+                <a:solidFill>
+                  <a:srgbClr val="FFFFFF"/>
+                </a:solidFill>
+                <a:latin typeface="Space Grotesk" pitchFamily="34" charset="0"/>
+                <a:ea typeface="Space Grotesk" pitchFamily="34" charset="-122"/>
+                <a:cs typeface="Space Grotesk" pitchFamily="34" charset="-120"/>
+              </a:rPr>
               <a:t>The algorithm fuses evidence before choosing action</a:t>
             </a:r>
             <a:endParaRPr lang="en-US" sz="4300" dirty="0"/>
@@ -9542,6 +10742,14 @@
               <a:buNone/>
             </a:pPr>
             <a:r>
+              <a:rPr lang="en-US" altLang="en-US" sz="1800" dirty="0">
+                <a:solidFill>
+                  <a:srgbClr val="8B9BB4"/>
+                </a:solidFill>
+                <a:latin typeface="Inter" pitchFamily="34" charset="0"/>
+                <a:ea typeface="Inter" pitchFamily="34" charset="-122"/>
+                <a:cs typeface="Inter" pitchFamily="34" charset="-120"/>
+              </a:rPr>
               <a:t>Each available modality contributes evidence; missing modalities are excluded, never guessed.</a:t>
             </a:r>
             <a:endParaRPr lang="en-US" sz="1800" dirty="0"/>
@@ -9602,6 +10810,14 @@
               <a:buNone/>
             </a:pPr>
             <a:r>
+              <a:rPr lang="en-US" altLang="en-US" sz="1200" dirty="0">
+                <a:solidFill>
+                  <a:srgbClr val="00E5FF"/>
+                </a:solidFill>
+                <a:latin typeface="JetBrains Mono" pitchFamily="34" charset="0"/>
+                <a:ea typeface="JetBrains Mono" pitchFamily="34" charset="-122"/>
+                <a:cs typeface="JetBrains Mono" pitchFamily="34" charset="-120"/>
+              </a:rPr>
               <a:t>FUNCTION ANALYZE_SECURITY_EVENT(event)</a:t>
             </a:r>
             <a:endParaRPr lang="en-US" sz="1200" dirty="0"/>
@@ -9636,7 +10852,26 @@
               <a:buNone/>
             </a:pPr>
             <a:r>
-              <a:t>01 features &lt;- extract(text, URL, media, identity, network)</a:t>
+              <a:rPr lang="en-US" altLang="en-US" sz="1500" dirty="0">
+                <a:solidFill>
+                  <a:srgbClr val="8B9BB4"/>
+                </a:solidFill>
+                <a:latin typeface="JetBrains Mono" pitchFamily="34" charset="0"/>
+                <a:ea typeface="JetBrains Mono" pitchFamily="34" charset="-122"/>
+                <a:cs typeface="JetBrains Mono" pitchFamily="34" charset="-120"/>
+              </a:rPr>
+              <a:t>01</a:t>
+            </a:r>
+            <a:r>
+              <a:rPr lang="en-US" altLang="en-US" sz="1500" dirty="0">
+                <a:solidFill>
+                  <a:srgbClr val="FFFFFF"/>
+                </a:solidFill>
+                <a:latin typeface="JetBrains Mono" pitchFamily="34" charset="0"/>
+                <a:ea typeface="JetBrains Mono" pitchFamily="34" charset="-122"/>
+                <a:cs typeface="JetBrains Mono" pitchFamily="34" charset="-120"/>
+              </a:rPr>
+              <a:t>  features ← extract(text, URL, media, identity, network)</a:t>
             </a:r>
             <a:endParaRPr lang="en-US" sz="1500" dirty="0"/>
           </a:p>
@@ -9648,7 +10883,26 @@
               <a:buNone/>
             </a:pPr>
             <a:r>
-              <a:t>02 scores &lt;- detectPhishing + detectAudio + detectVideo</a:t>
+              <a:rPr lang="en-US" altLang="en-US" sz="1500" dirty="0">
+                <a:solidFill>
+                  <a:srgbClr val="8B9BB4"/>
+                </a:solidFill>
+                <a:latin typeface="JetBrains Mono" pitchFamily="34" charset="0"/>
+                <a:ea typeface="JetBrains Mono" pitchFamily="34" charset="-122"/>
+                <a:cs typeface="JetBrains Mono" pitchFamily="34" charset="-120"/>
+              </a:rPr>
+              <a:t>02</a:t>
+            </a:r>
+            <a:r>
+              <a:rPr lang="en-US" altLang="en-US" sz="1500" dirty="0">
+                <a:solidFill>
+                  <a:srgbClr val="FFFFFF"/>
+                </a:solidFill>
+                <a:latin typeface="JetBrains Mono" pitchFamily="34" charset="0"/>
+                <a:ea typeface="JetBrains Mono" pitchFamily="34" charset="-122"/>
+                <a:cs typeface="JetBrains Mono" pitchFamily="34" charset="-120"/>
+              </a:rPr>
+              <a:t>  scores ← detectPhishing + detectAudio + detectVideo</a:t>
             </a:r>
             <a:endParaRPr lang="en-US" sz="1500" dirty="0"/>
           </a:p>
@@ -9660,7 +10914,26 @@
               <a:buNone/>
             </a:pPr>
             <a:r>
-              <a:t>03 scores &lt;- scores + verifyDigitalTwin + checkThreatSignals</a:t>
+              <a:rPr lang="en-US" altLang="en-US" sz="1500" dirty="0">
+                <a:solidFill>
+                  <a:srgbClr val="8B9BB4"/>
+                </a:solidFill>
+                <a:latin typeface="JetBrains Mono" pitchFamily="34" charset="0"/>
+                <a:ea typeface="JetBrains Mono" pitchFamily="34" charset="-122"/>
+                <a:cs typeface="JetBrains Mono" pitchFamily="34" charset="-120"/>
+              </a:rPr>
+              <a:t>03</a:t>
+            </a:r>
+            <a:r>
+              <a:rPr lang="en-US" altLang="en-US" sz="1500" dirty="0">
+                <a:solidFill>
+                  <a:srgbClr val="FFFFFF"/>
+                </a:solidFill>
+                <a:latin typeface="JetBrains Mono" pitchFamily="34" charset="0"/>
+                <a:ea typeface="JetBrains Mono" pitchFamily="34" charset="-122"/>
+                <a:cs typeface="JetBrains Mono" pitchFamily="34" charset="-120"/>
+              </a:rPr>
+              <a:t>  scores ← scores + verifyDigitalTwin + checkThreatSignals</a:t>
             </a:r>
             <a:endParaRPr lang="en-US" sz="1500" dirty="0"/>
           </a:p>
@@ -9672,7 +10945,26 @@
               <a:buNone/>
             </a:pPr>
             <a:r>
-              <a:t>04 graph &lt;- updateAndQueryAttackGraph(features)</a:t>
+              <a:rPr lang="en-US" altLang="en-US" sz="1500" dirty="0">
+                <a:solidFill>
+                  <a:srgbClr val="8B9BB4"/>
+                </a:solidFill>
+                <a:latin typeface="JetBrains Mono" pitchFamily="34" charset="0"/>
+                <a:ea typeface="JetBrains Mono" pitchFamily="34" charset="-122"/>
+                <a:cs typeface="JetBrains Mono" pitchFamily="34" charset="-120"/>
+              </a:rPr>
+              <a:t>04</a:t>
+            </a:r>
+            <a:r>
+              <a:rPr lang="en-US" altLang="en-US" sz="1500" dirty="0">
+                <a:solidFill>
+                  <a:srgbClr val="FFFFFF"/>
+                </a:solidFill>
+                <a:latin typeface="JetBrains Mono" pitchFamily="34" charset="0"/>
+                <a:ea typeface="JetBrains Mono" pitchFamily="34" charset="-122"/>
+                <a:cs typeface="JetBrains Mono" pitchFamily="34" charset="-120"/>
+              </a:rPr>
+              <a:t>  graph ← updateAndQueryAttackGraph(features)</a:t>
             </a:r>
             <a:endParaRPr lang="en-US" sz="1500" dirty="0"/>
           </a:p>
@@ -9684,7 +10976,26 @@
               <a:buNone/>
             </a:pPr>
             <a:r>
-              <a:t>05 risk &lt;- fuse(scores, graph, businessImpact, confidence)</a:t>
+              <a:rPr lang="en-US" altLang="en-US" sz="1500" dirty="0">
+                <a:solidFill>
+                  <a:srgbClr val="8B9BB4"/>
+                </a:solidFill>
+                <a:latin typeface="JetBrains Mono" pitchFamily="34" charset="0"/>
+                <a:ea typeface="JetBrains Mono" pitchFamily="34" charset="-122"/>
+                <a:cs typeface="JetBrains Mono" pitchFamily="34" charset="-120"/>
+              </a:rPr>
+              <a:t>05</a:t>
+            </a:r>
+            <a:r>
+              <a:rPr lang="en-US" altLang="en-US" sz="1500" dirty="0">
+                <a:solidFill>
+                  <a:srgbClr val="FFFFFF"/>
+                </a:solidFill>
+                <a:latin typeface="JetBrains Mono" pitchFamily="34" charset="0"/>
+                <a:ea typeface="JetBrains Mono" pitchFamily="34" charset="-122"/>
+                <a:cs typeface="JetBrains Mono" pitchFamily="34" charset="-120"/>
+              </a:rPr>
+              <a:t>  risk ← fuse(scores, graph, businessImpact, confidence)</a:t>
             </a:r>
             <a:endParaRPr lang="en-US" sz="1500" dirty="0"/>
           </a:p>
@@ -9696,7 +11007,26 @@
               <a:buNone/>
             </a:pPr>
             <a:r>
-              <a:t>06 reasons &lt;- generateExplanation(scores, graph)</a:t>
+              <a:rPr lang="en-US" altLang="en-US" sz="1500" dirty="0">
+                <a:solidFill>
+                  <a:srgbClr val="8B9BB4"/>
+                </a:solidFill>
+                <a:latin typeface="JetBrains Mono" pitchFamily="34" charset="0"/>
+                <a:ea typeface="JetBrains Mono" pitchFamily="34" charset="-122"/>
+                <a:cs typeface="JetBrains Mono" pitchFamily="34" charset="-120"/>
+              </a:rPr>
+              <a:t>06</a:t>
+            </a:r>
+            <a:r>
+              <a:rPr lang="en-US" altLang="en-US" sz="1500" dirty="0">
+                <a:solidFill>
+                  <a:srgbClr val="FFFFFF"/>
+                </a:solidFill>
+                <a:latin typeface="JetBrains Mono" pitchFamily="34" charset="0"/>
+                <a:ea typeface="JetBrains Mono" pitchFamily="34" charset="-122"/>
+                <a:cs typeface="JetBrains Mono" pitchFamily="34" charset="-120"/>
+              </a:rPr>
+              <a:t>  reasons ← generateExplanation(scores, graph)</a:t>
             </a:r>
             <a:endParaRPr lang="en-US" sz="1500" dirty="0"/>
           </a:p>
@@ -9708,7 +11038,26 @@
               <a:buNone/>
             </a:pPr>
             <a:r>
-              <a:t>07 action &lt;- selectSafeResponse(risk)</a:t>
+              <a:rPr lang="en-US" altLang="en-US" sz="1500" dirty="0">
+                <a:solidFill>
+                  <a:srgbClr val="8B9BB4"/>
+                </a:solidFill>
+                <a:latin typeface="JetBrains Mono" pitchFamily="34" charset="0"/>
+                <a:ea typeface="JetBrains Mono" pitchFamily="34" charset="-122"/>
+                <a:cs typeface="JetBrains Mono" pitchFamily="34" charset="-120"/>
+              </a:rPr>
+              <a:t>07</a:t>
+            </a:r>
+            <a:r>
+              <a:rPr lang="en-US" altLang="en-US" sz="1500" dirty="0">
+                <a:solidFill>
+                  <a:srgbClr val="FFFFFF"/>
+                </a:solidFill>
+                <a:latin typeface="JetBrains Mono" pitchFamily="34" charset="0"/>
+                <a:ea typeface="JetBrains Mono" pitchFamily="34" charset="-122"/>
+                <a:cs typeface="JetBrains Mono" pitchFamily="34" charset="-120"/>
+              </a:rPr>
+              <a:t>  action ← selectSafeResponse(risk)</a:t>
             </a:r>
             <a:endParaRPr lang="en-US" sz="1500" dirty="0"/>
           </a:p>
@@ -9720,7 +11069,26 @@
               <a:buNone/>
             </a:pPr>
             <a:r>
-              <a:t>08 return risk, confidence, reasons, graph, action</a:t>
+              <a:rPr lang="en-US" altLang="en-US" sz="1500" dirty="0">
+                <a:solidFill>
+                  <a:srgbClr val="8B9BB4"/>
+                </a:solidFill>
+                <a:latin typeface="JetBrains Mono" pitchFamily="34" charset="0"/>
+                <a:ea typeface="JetBrains Mono" pitchFamily="34" charset="-122"/>
+                <a:cs typeface="JetBrains Mono" pitchFamily="34" charset="-120"/>
+              </a:rPr>
+              <a:t>08</a:t>
+            </a:r>
+            <a:r>
+              <a:rPr lang="en-US" altLang="en-US" sz="1500" dirty="0">
+                <a:solidFill>
+                  <a:srgbClr val="FFFFFF"/>
+                </a:solidFill>
+                <a:latin typeface="JetBrains Mono" pitchFamily="34" charset="0"/>
+                <a:ea typeface="JetBrains Mono" pitchFamily="34" charset="-122"/>
+                <a:cs typeface="JetBrains Mono" pitchFamily="34" charset="-120"/>
+              </a:rPr>
+              <a:t>  return risk, confidence, reasons, graph, action</a:t>
             </a:r>
             <a:endParaRPr lang="en-US" sz="1500" dirty="0"/>
           </a:p>
@@ -9751,6 +11119,14 @@
               <a:buNone/>
             </a:pPr>
             <a:r>
+              <a:rPr lang="en-US" altLang="en-US" sz="1100" dirty="0">
+                <a:solidFill>
+                  <a:srgbClr val="8B9BB4"/>
+                </a:solidFill>
+                <a:latin typeface="JetBrains Mono" pitchFamily="34" charset="0"/>
+                <a:ea typeface="JetBrains Mono" pitchFamily="34" charset="-122"/>
+                <a:cs typeface="JetBrains Mono" pitchFamily="34" charset="-120"/>
+              </a:rPr>
               <a:t>Output is an explainable decision package—not simply “fake” or “genuine”.</a:t>
             </a:r>
             <a:endParaRPr lang="en-US" sz="1100" dirty="0"/>
@@ -9811,6 +11187,14 @@
               <a:buNone/>
             </a:pPr>
             <a:r>
+              <a:rPr lang="en-US" altLang="en-US" sz="2200" dirty="0">
+                <a:solidFill>
+                  <a:srgbClr val="FFFFFF"/>
+                </a:solidFill>
+                <a:latin typeface="Space Grotesk" pitchFamily="34" charset="0"/>
+                <a:ea typeface="Space Grotesk" pitchFamily="34" charset="-122"/>
+                <a:cs typeface="Space Grotesk" pitchFamily="34" charset="-120"/>
+              </a:rPr>
               <a:t>Risk policy → response</a:t>
             </a:r>
             <a:endParaRPr lang="en-US" sz="2200" dirty="0"/>
@@ -9871,6 +11255,14 @@
               <a:buNone/>
             </a:pPr>
             <a:r>
+              <a:rPr lang="en-US" altLang="en-US" sz="1200" dirty="0">
+                <a:solidFill>
+                  <a:srgbClr val="00E5FF"/>
+                </a:solidFill>
+                <a:latin typeface="JetBrains Mono" pitchFamily="34" charset="0"/>
+                <a:ea typeface="JetBrains Mono" pitchFamily="34" charset="-122"/>
+                <a:cs typeface="JetBrains Mono" pitchFamily="34" charset="-120"/>
+              </a:rPr>
               <a:t>LOW</a:t>
             </a:r>
             <a:endParaRPr lang="en-US" sz="1200" dirty="0"/>
@@ -9902,6 +11294,14 @@
               <a:buNone/>
             </a:pPr>
             <a:r>
+              <a:rPr lang="en-US" altLang="en-US" sz="1600" dirty="0">
+                <a:solidFill>
+                  <a:srgbClr val="FFFFFF"/>
+                </a:solidFill>
+                <a:latin typeface="Inter" pitchFamily="34" charset="0"/>
+                <a:ea typeface="Inter" pitchFamily="34" charset="-122"/>
+                <a:cs typeface="Inter" pitchFamily="34" charset="-120"/>
+              </a:rPr>
               <a:t>Allow, monitor, and log</a:t>
             </a:r>
             <a:endParaRPr lang="en-US" sz="1600" dirty="0"/>
@@ -9962,6 +11362,14 @@
               <a:buNone/>
             </a:pPr>
             <a:r>
+              <a:rPr lang="en-US" altLang="en-US" sz="1200" dirty="0">
+                <a:solidFill>
+                  <a:srgbClr val="FFB300"/>
+                </a:solidFill>
+                <a:latin typeface="JetBrains Mono" pitchFamily="34" charset="0"/>
+                <a:ea typeface="JetBrains Mono" pitchFamily="34" charset="-122"/>
+                <a:cs typeface="JetBrains Mono" pitchFamily="34" charset="-120"/>
+              </a:rPr>
               <a:t>MEDIUM</a:t>
             </a:r>
             <a:endParaRPr lang="en-US" sz="1200" dirty="0"/>
@@ -9993,6 +11401,14 @@
               <a:buNone/>
             </a:pPr>
             <a:r>
+              <a:rPr lang="en-US" altLang="en-US" sz="1600" dirty="0">
+                <a:solidFill>
+                  <a:srgbClr val="FFFFFF"/>
+                </a:solidFill>
+                <a:latin typeface="Inter" pitchFamily="34" charset="0"/>
+                <a:ea typeface="Inter" pitchFamily="34" charset="-122"/>
+                <a:cs typeface="Inter" pitchFamily="34" charset="-120"/>
+              </a:rPr>
               <a:t>Warn and verify independently</a:t>
             </a:r>
             <a:endParaRPr lang="en-US" sz="1600" dirty="0"/>
@@ -10053,6 +11469,14 @@
               <a:buNone/>
             </a:pPr>
             <a:r>
+              <a:rPr lang="en-US" altLang="en-US" sz="1200" dirty="0">
+                <a:solidFill>
+                  <a:srgbClr val="FFB300"/>
+                </a:solidFill>
+                <a:latin typeface="JetBrains Mono" pitchFamily="34" charset="0"/>
+                <a:ea typeface="JetBrains Mono" pitchFamily="34" charset="-122"/>
+                <a:cs typeface="JetBrains Mono" pitchFamily="34" charset="-120"/>
+              </a:rPr>
               <a:t>HIGH</a:t>
             </a:r>
             <a:endParaRPr lang="en-US" sz="1200" dirty="0"/>
@@ -10084,6 +11508,14 @@
               <a:buNone/>
             </a:pPr>
             <a:r>
+              <a:rPr lang="en-US" altLang="en-US" sz="1600" dirty="0">
+                <a:solidFill>
+                  <a:srgbClr val="FFFFFF"/>
+                </a:solidFill>
+                <a:latin typeface="Inter" pitchFamily="34" charset="0"/>
+                <a:ea typeface="Inter" pitchFamily="34" charset="-122"/>
+                <a:cs typeface="Inter" pitchFamily="34" charset="-120"/>
+              </a:rPr>
               <a:t>Quarantine content and block URL</a:t>
             </a:r>
             <a:endParaRPr lang="en-US" sz="1600" dirty="0"/>
@@ -10144,6 +11576,14 @@
               <a:buNone/>
             </a:pPr>
             <a:r>
+              <a:rPr lang="en-US" altLang="en-US" sz="1200" dirty="0">
+                <a:solidFill>
+                  <a:srgbClr val="FFB300"/>
+                </a:solidFill>
+                <a:latin typeface="JetBrains Mono" pitchFamily="34" charset="0"/>
+                <a:ea typeface="JetBrains Mono" pitchFamily="34" charset="-122"/>
+                <a:cs typeface="JetBrains Mono" pitchFamily="34" charset="-120"/>
+              </a:rPr>
               <a:t>CRITICAL</a:t>
             </a:r>
             <a:endParaRPr lang="en-US" sz="1200" dirty="0"/>
@@ -10175,6 +11615,14 @@
               <a:buNone/>
             </a:pPr>
             <a:r>
+              <a:rPr lang="en-US" altLang="en-US" sz="1600" dirty="0">
+                <a:solidFill>
+                  <a:srgbClr val="FFFFFF"/>
+                </a:solidFill>
+                <a:latin typeface="Inter" pitchFamily="34" charset="0"/>
+                <a:ea typeface="Inter" pitchFamily="34" charset="-122"/>
+                <a:cs typeface="Inter" pitchFamily="34" charset="-120"/>
+              </a:rPr>
               <a:t>Open incident; analyst approves action</a:t>
             </a:r>
             <a:endParaRPr lang="en-US" sz="1600" dirty="0"/>
@@ -10232,6 +11680,14 @@
               <a:buNone/>
             </a:pPr>
             <a:r>
+              <a:rPr lang="en-US" altLang="en-US" sz="1200" dirty="0">
+                <a:solidFill>
+                  <a:srgbClr val="8B9BB4"/>
+                </a:solidFill>
+                <a:latin typeface="JetBrains Mono" pitchFamily="34" charset="0"/>
+                <a:ea typeface="JetBrains Mono" pitchFamily="34" charset="-122"/>
+                <a:cs typeface="JetBrains Mono" pitchFamily="34" charset="-120"/>
+              </a:rPr>
               <a:t>Confidence + business impact influence escalation.</a:t>
             </a:r>
             <a:endParaRPr lang="en-US" sz="1200" dirty="0"/>
@@ -10263,6 +11719,14 @@
               <a:buNone/>
             </a:pPr>
             <a:r>
+              <a:rPr lang="en-US" altLang="en-US" sz="1200" dirty="0">
+                <a:solidFill>
+                  <a:srgbClr val="8B9BB4"/>
+                </a:solidFill>
+                <a:latin typeface="JetBrains Mono" pitchFamily="34" charset="0"/>
+                <a:ea typeface="JetBrains Mono" pitchFamily="34" charset="-122"/>
+                <a:cs typeface="JetBrains Mono" pitchFamily="34" charset="-120"/>
+              </a:rPr>
               <a:t>SEC-08 // ALGORITHM</a:t>
             </a:r>
             <a:endParaRPr lang="en-US" sz="1200" dirty="0"/>
@@ -10355,6 +11819,14 @@
               <a:buNone/>
             </a:pPr>
             <a:r>
+              <a:rPr lang="en-US" altLang="en-US" sz="1300" dirty="0">
+                <a:solidFill>
+                  <a:srgbClr val="00E5FF"/>
+                </a:solidFill>
+                <a:latin typeface="JetBrains Mono" pitchFamily="34" charset="0"/>
+                <a:ea typeface="JetBrains Mono" pitchFamily="34" charset="-122"/>
+                <a:cs typeface="JetBrains Mono" pitchFamily="34" charset="-120"/>
+              </a:rPr>
               <a:t>08 // LIVE INCIDENT DEMO</a:t>
             </a:r>
             <a:endParaRPr lang="en-US" sz="1300" dirty="0"/>
@@ -10386,6 +11858,14 @@
               <a:buNone/>
             </a:pPr>
             <a:r>
+              <a:rPr lang="en-US" altLang="en-US" sz="1200" dirty="0">
+                <a:solidFill>
+                  <a:srgbClr val="8B9BB4"/>
+                </a:solidFill>
+                <a:latin typeface="JetBrains Mono" pitchFamily="34" charset="0"/>
+                <a:ea typeface="JetBrains Mono" pitchFamily="34" charset="-122"/>
+                <a:cs typeface="JetBrains Mono" pitchFamily="34" charset="-120"/>
+              </a:rPr>
               <a:t>NEXUS 2026</a:t>
             </a:r>
             <a:endParaRPr lang="en-US" sz="1200" dirty="0"/>
@@ -10417,6 +11897,14 @@
               <a:buNone/>
             </a:pPr>
             <a:r>
+              <a:rPr lang="en-US" altLang="en-US" sz="4300" dirty="0">
+                <a:solidFill>
+                  <a:srgbClr val="FFFFFF"/>
+                </a:solidFill>
+                <a:latin typeface="Space Grotesk" pitchFamily="34" charset="0"/>
+                <a:ea typeface="Space Grotesk" pitchFamily="34" charset="-122"/>
+                <a:cs typeface="Space Grotesk" pitchFamily="34" charset="-120"/>
+              </a:rPr>
               <a:t>A fake CFO request becomes one clear incident</a:t>
             </a:r>
             <a:endParaRPr lang="en-US" sz="4300" dirty="0"/>
@@ -10448,6 +11936,14 @@
               <a:buNone/>
             </a:pPr>
             <a:r>
+              <a:rPr lang="en-US" altLang="en-US" sz="1800" dirty="0">
+                <a:solidFill>
+                  <a:srgbClr val="8B9BB4"/>
+                </a:solidFill>
+                <a:latin typeface="Inter" pitchFamily="34" charset="0"/>
+                <a:ea typeface="Inter" pitchFamily="34" charset="-122"/>
+                <a:cs typeface="Inter" pitchFamily="34" charset="-120"/>
+              </a:rPr>
               <a:t>The cross-modal value appears when each clue points to the same impersonation attempt.</a:t>
             </a:r>
             <a:endParaRPr lang="en-US" sz="1800" dirty="0"/>
@@ -10508,6 +12004,14 @@
               <a:buNone/>
             </a:pPr>
             <a:r>
+              <a:rPr lang="en-US" altLang="en-US" sz="1200" dirty="0">
+                <a:solidFill>
+                  <a:srgbClr val="FF007F"/>
+                </a:solidFill>
+                <a:latin typeface="JetBrains Mono" pitchFamily="34" charset="0"/>
+                <a:ea typeface="JetBrains Mono" pitchFamily="34" charset="-122"/>
+                <a:cs typeface="JetBrains Mono" pitchFamily="34" charset="-120"/>
+              </a:rPr>
               <a:t>01 // ATTACKER SIGNALS</a:t>
             </a:r>
             <a:endParaRPr lang="en-US" sz="1200" dirty="0"/>
@@ -10563,6 +12067,14 @@
               <a:buNone/>
             </a:pPr>
             <a:r>
+              <a:rPr lang="en-US" altLang="en-US" sz="2300" dirty="0">
+                <a:solidFill>
+                  <a:srgbClr val="FFFFFF"/>
+                </a:solidFill>
+                <a:latin typeface="Space Grotesk" pitchFamily="34" charset="0"/>
+                <a:ea typeface="Space Grotesk" pitchFamily="34" charset="-122"/>
+                <a:cs typeface="Space Grotesk" pitchFamily="34" charset="-120"/>
+              </a:rPr>
               <a:t>Urgent CFO request</a:t>
             </a:r>
             <a:endParaRPr lang="en-US" sz="2300" dirty="0"/>
@@ -10597,6 +12109,14 @@
               <a:buNone/>
             </a:pPr>
             <a:r>
+              <a:rPr lang="en-US" altLang="en-US" sz="1700" dirty="0">
+                <a:solidFill>
+                  <a:srgbClr val="8B9BB4"/>
+                </a:solidFill>
+                <a:latin typeface="Inter" pitchFamily="34" charset="0"/>
+                <a:ea typeface="Inter" pitchFamily="34" charset="-122"/>
+                <a:cs typeface="Inter" pitchFamily="34" charset="-120"/>
+              </a:rPr>
               <a:t>CFO-looking email</a:t>
             </a:r>
             <a:endParaRPr lang="en-US" sz="1700" dirty="0"/>
@@ -10609,6 +12129,14 @@
               <a:buNone/>
             </a:pPr>
             <a:r>
+              <a:rPr lang="en-US" altLang="en-US" sz="1700" dirty="0">
+                <a:solidFill>
+                  <a:srgbClr val="8B9BB4"/>
+                </a:solidFill>
+                <a:latin typeface="Inter" pitchFamily="34" charset="0"/>
+                <a:ea typeface="Inter" pitchFamily="34" charset="-122"/>
+                <a:cs typeface="Inter" pitchFamily="34" charset="-120"/>
+              </a:rPr>
               <a:t>Look-alike payment link</a:t>
             </a:r>
             <a:endParaRPr lang="en-US" sz="1700" dirty="0"/>
@@ -10621,6 +12149,14 @@
               <a:buNone/>
             </a:pPr>
             <a:r>
+              <a:rPr lang="en-US" altLang="en-US" sz="1700" dirty="0">
+                <a:solidFill>
+                  <a:srgbClr val="8B9BB4"/>
+                </a:solidFill>
+                <a:latin typeface="Inter" pitchFamily="34" charset="0"/>
+                <a:ea typeface="Inter" pitchFamily="34" charset="-122"/>
+                <a:cs typeface="Inter" pitchFamily="34" charset="-120"/>
+              </a:rPr>
               <a:t>Cloned-sounding voice note</a:t>
             </a:r>
             <a:endParaRPr lang="en-US" sz="1700" dirty="0"/>
@@ -10707,7 +12243,15 @@
               <a:buNone/>
             </a:pPr>
             <a:r>
-              <a:t>02 // AEGISNEXUS CORRELATION CHECKS</a:t>
+              <a:rPr lang="en-US" altLang="en-US" sz="1200" dirty="0">
+                <a:solidFill>
+                  <a:srgbClr val="00E5FF"/>
+                </a:solidFill>
+                <a:latin typeface="JetBrains Mono" pitchFamily="34" charset="0"/>
+                <a:ea typeface="JetBrains Mono" pitchFamily="34" charset="-122"/>
+                <a:cs typeface="JetBrains Mono" pitchFamily="34" charset="-120"/>
+              </a:rPr>
+              <a:t>02 // AEGISNEXUS CHECKS</a:t>
             </a:r>
             <a:endParaRPr lang="en-US" sz="1200" dirty="0"/>
           </a:p>
@@ -10762,6 +12306,14 @@
               <a:buNone/>
             </a:pPr>
             <a:r>
+              <a:rPr lang="en-US" altLang="en-US" sz="2300" dirty="0">
+                <a:solidFill>
+                  <a:srgbClr val="FFFFFF"/>
+                </a:solidFill>
+                <a:latin typeface="Space Grotesk" pitchFamily="34" charset="0"/>
+                <a:ea typeface="Space Grotesk" pitchFamily="34" charset="-122"/>
+                <a:cs typeface="Space Grotesk" pitchFamily="34" charset="-120"/>
+              </a:rPr>
               <a:t>Identity mismatch</a:t>
             </a:r>
             <a:endParaRPr lang="en-US" sz="2300" dirty="0"/>
@@ -10796,6 +12348,14 @@
               <a:buNone/>
             </a:pPr>
             <a:r>
+              <a:rPr lang="en-US" altLang="en-US" sz="1700" dirty="0">
+                <a:solidFill>
+                  <a:srgbClr val="8B9BB4"/>
+                </a:solidFill>
+                <a:latin typeface="Inter" pitchFamily="34" charset="0"/>
+                <a:ea typeface="Inter" pitchFamily="34" charset="-122"/>
+                <a:cs typeface="Inter" pitchFamily="34" charset="-120"/>
+              </a:rPr>
               <a:t>Unapproved channel</a:t>
             </a:r>
             <a:endParaRPr lang="en-US" sz="1700" dirty="0"/>
@@ -10808,6 +12368,14 @@
               <a:buNone/>
             </a:pPr>
             <a:r>
+              <a:rPr lang="en-US" altLang="en-US" sz="1700" dirty="0">
+                <a:solidFill>
+                  <a:srgbClr val="8B9BB4"/>
+                </a:solidFill>
+                <a:latin typeface="Inter" pitchFamily="34" charset="0"/>
+                <a:ea typeface="Inter" pitchFamily="34" charset="-122"/>
+                <a:cs typeface="Inter" pitchFamily="34" charset="-120"/>
+              </a:rPr>
               <a:t>Unusual payment behavior</a:t>
             </a:r>
             <a:endParaRPr lang="en-US" sz="1700" dirty="0"/>
@@ -10820,6 +12388,14 @@
               <a:buNone/>
             </a:pPr>
             <a:r>
+              <a:rPr lang="en-US" altLang="en-US" sz="1700" dirty="0">
+                <a:solidFill>
+                  <a:srgbClr val="8B9BB4"/>
+                </a:solidFill>
+                <a:latin typeface="Inter" pitchFamily="34" charset="0"/>
+                <a:ea typeface="Inter" pitchFamily="34" charset="-122"/>
+                <a:cs typeface="Inter" pitchFamily="34" charset="-120"/>
+              </a:rPr>
               <a:t>Related graph indicators</a:t>
             </a:r>
             <a:endParaRPr lang="en-US" sz="1700" dirty="0"/>
@@ -10906,6 +12482,14 @@
               <a:buNone/>
             </a:pPr>
             <a:r>
+              <a:rPr lang="en-US" altLang="en-US" sz="1200" dirty="0">
+                <a:solidFill>
+                  <a:srgbClr val="FFB300"/>
+                </a:solidFill>
+                <a:latin typeface="JetBrains Mono" pitchFamily="34" charset="0"/>
+                <a:ea typeface="JetBrains Mono" pitchFamily="34" charset="-122"/>
+                <a:cs typeface="JetBrains Mono" pitchFamily="34" charset="-120"/>
+              </a:rPr>
               <a:t>03 // RISK DECISION</a:t>
             </a:r>
             <a:endParaRPr lang="en-US" sz="1200" dirty="0"/>
@@ -10961,6 +12545,14 @@
               <a:buNone/>
             </a:pPr>
             <a:r>
+              <a:rPr lang="en-US" altLang="en-US" sz="2300" dirty="0">
+                <a:solidFill>
+                  <a:srgbClr val="FFFFFF"/>
+                </a:solidFill>
+                <a:latin typeface="Space Grotesk" pitchFamily="34" charset="0"/>
+                <a:ea typeface="Space Grotesk" pitchFamily="34" charset="-122"/>
+                <a:cs typeface="Space Grotesk" pitchFamily="34" charset="-120"/>
+              </a:rPr>
               <a:t>High-risk incident</a:t>
             </a:r>
             <a:endParaRPr lang="en-US" sz="2300" dirty="0"/>
@@ -10995,6 +12587,14 @@
               <a:buNone/>
             </a:pPr>
             <a:r>
+              <a:rPr lang="en-US" altLang="en-US" sz="1700" dirty="0">
+                <a:solidFill>
+                  <a:srgbClr val="8B9BB4"/>
+                </a:solidFill>
+                <a:latin typeface="Inter" pitchFamily="34" charset="0"/>
+                <a:ea typeface="Inter" pitchFamily="34" charset="-122"/>
+                <a:cs typeface="Inter" pitchFamily="34" charset="-120"/>
+              </a:rPr>
               <a:t>Quarantine message</a:t>
             </a:r>
             <a:endParaRPr lang="en-US" sz="1700" dirty="0"/>
@@ -11007,6 +12607,14 @@
               <a:buNone/>
             </a:pPr>
             <a:r>
+              <a:rPr lang="en-US" altLang="en-US" sz="1700" dirty="0">
+                <a:solidFill>
+                  <a:srgbClr val="8B9BB4"/>
+                </a:solidFill>
+                <a:latin typeface="Inter" pitchFamily="34" charset="0"/>
+                <a:ea typeface="Inter" pitchFamily="34" charset="-122"/>
+                <a:cs typeface="Inter" pitchFamily="34" charset="-120"/>
+              </a:rPr>
               <a:t>Block URL</a:t>
             </a:r>
             <a:endParaRPr lang="en-US" sz="1700" dirty="0"/>
@@ -11019,6 +12627,14 @@
               <a:buNone/>
             </a:pPr>
             <a:r>
+              <a:rPr lang="en-US" altLang="en-US" sz="1700" dirty="0">
+                <a:solidFill>
+                  <a:srgbClr val="8B9BB4"/>
+                </a:solidFill>
+                <a:latin typeface="Inter" pitchFamily="34" charset="0"/>
+                <a:ea typeface="Inter" pitchFamily="34" charset="-122"/>
+                <a:cs typeface="Inter" pitchFamily="34" charset="-120"/>
+              </a:rPr>
               <a:t>Notify analyst for approval</a:t>
             </a:r>
             <a:endParaRPr lang="en-US" sz="1700" dirty="0"/>
@@ -11081,6 +12697,14 @@
               <a:buNone/>
             </a:pPr>
             <a:r>
+              <a:rPr lang="en-US" altLang="en-US" sz="1200" dirty="0">
+                <a:solidFill>
+                  <a:srgbClr val="FFB300"/>
+                </a:solidFill>
+                <a:latin typeface="JetBrains Mono" pitchFamily="34" charset="0"/>
+                <a:ea typeface="JetBrains Mono" pitchFamily="34" charset="-122"/>
+                <a:cs typeface="JetBrains Mono" pitchFamily="34" charset="-120"/>
+              </a:rPr>
               <a:t>EXPECTED DASHBOARD OUTPUT</a:t>
             </a:r>
             <a:endParaRPr lang="en-US" sz="1200" dirty="0"/>
@@ -11112,7 +12736,15 @@
               <a:buNone/>
             </a:pPr>
             <a:r>
-              <a:t>CRITICAL RISK (95/100) — CFO Impersonation</a:t>
+              <a:rPr lang="en-US" altLang="en-US" sz="2100" dirty="0">
+                <a:solidFill>
+                  <a:srgbClr val="FFFFFF"/>
+                </a:solidFill>
+                <a:latin typeface="Space Grotesk" pitchFamily="34" charset="0"/>
+                <a:ea typeface="Space Grotesk" pitchFamily="34" charset="-122"/>
+                <a:cs typeface="Space Grotesk" pitchFamily="34" charset="-120"/>
+              </a:rPr>
+              <a:t>HIGH RISK — Possible Executive Impersonation</a:t>
             </a:r>
             <a:endParaRPr lang="en-US" sz="2100" dirty="0"/>
           </a:p>
@@ -11143,7 +12775,15 @@
               <a:buNone/>
             </a:pPr>
             <a:r>
-              <a:t>5 Correlated Signals • ,500 Target • 94% Confidence</a:t>
+              <a:rPr lang="en-US" altLang="en-US" sz="1200" dirty="0">
+                <a:solidFill>
+                  <a:srgbClr val="8B9BB4"/>
+                </a:solidFill>
+                <a:latin typeface="JetBrains Mono" pitchFamily="34" charset="0"/>
+                <a:ea typeface="JetBrains Mono" pitchFamily="34" charset="-122"/>
+                <a:cs typeface="JetBrains Mono" pitchFamily="34" charset="-120"/>
+              </a:rPr>
+              <a:t>5 correlated evidence signals</a:t>
             </a:r>
             <a:endParaRPr lang="en-US" sz="1200" dirty="0"/>
           </a:p>
@@ -11174,6 +12814,14 @@
               <a:buNone/>
             </a:pPr>
             <a:r>
+              <a:rPr lang="en-US" altLang="en-US" sz="1200" dirty="0">
+                <a:solidFill>
+                  <a:srgbClr val="8B9BB4"/>
+                </a:solidFill>
+                <a:latin typeface="JetBrains Mono" pitchFamily="34" charset="0"/>
+                <a:ea typeface="JetBrains Mono" pitchFamily="34" charset="-122"/>
+                <a:cs typeface="JetBrains Mono" pitchFamily="34" charset="-120"/>
+              </a:rPr>
               <a:t>SEC-09 // DEMO</a:t>
             </a:r>
             <a:endParaRPr lang="en-US" sz="1200" dirty="0"/>

</xml_diff>